<commit_message>
native_render: replace slide.background with full-screen bg rect
slide.background.fill.solid() doesn't actually paint the slide background in
PowerPoint when the master slide layout already declares a white background—
the master wins and our bg color silently drops. Result: cards (white at 6%
opacity) render on white master bg, white text becomes invisible.

Fix: paint a full-viewport RECTANGLE shape at z-order bottom on every slide,
filled with theme.colors.bg_start. This bypasses master inheritance entirely.

examples/dify-intro/deck.pptx + the AI Coding deck regenerated.

Co-Authored-By: Claude Opus 4.7 (1M context) <noreply@anthropic.com>
</commit_message>
<xml_diff>
--- a/examples/dify-intro/deck.pptx
+++ b/examples/dify-intro/deck.pptx
@@ -3088,14 +3088,6 @@
 <file path=ppt/slides/slide1.xml><?xml version="1.0" encoding="utf-8"?>
 <p:sld xmlns:a="http://schemas.openxmlformats.org/drawingml/2006/main" xmlns:p="http://schemas.openxmlformats.org/presentationml/2006/main" xmlns:r="http://schemas.openxmlformats.org/officeDocument/2006/relationships">
   <p:cSld>
-    <p:bg>
-      <p:bgPr>
-        <a:solidFill>
-          <a:srgbClr val="0A0E27"/>
-        </a:solidFill>
-        <a:effectLst/>
-      </p:bgPr>
-    </p:bg>
     <p:spTree>
       <p:nvGrpSpPr>
         <p:cNvPr id="1" name=""/>
@@ -3105,7 +3097,50 @@
       <p:grpSpPr/>
       <p:sp>
         <p:nvSpPr>
-          <p:cNvPr id="2" name="Rounded Rectangle 1"/>
+          <p:cNvPr id="2" name="Rectangle 1"/>
+          <p:cNvSpPr/>
+          <p:nvPr/>
+        </p:nvSpPr>
+        <p:spPr>
+          <a:xfrm>
+            <a:off x="0" y="0"/>
+            <a:ext cx="12191695" cy="6858000"/>
+          </a:xfrm>
+          <a:prstGeom prst="rect">
+            <a:avLst/>
+          </a:prstGeom>
+          <a:solidFill>
+            <a:srgbClr val="0A0E27"/>
+          </a:solidFill>
+          <a:ln>
+            <a:noFill/>
+          </a:ln>
+        </p:spPr>
+        <p:style>
+          <a:lnRef idx="1">
+            <a:schemeClr val="accent1"/>
+          </a:lnRef>
+          <a:fillRef idx="3">
+            <a:schemeClr val="accent1"/>
+          </a:fillRef>
+          <a:effectRef idx="2">
+            <a:schemeClr val="accent1"/>
+          </a:effectRef>
+          <a:fontRef idx="minor">
+            <a:schemeClr val="lt1"/>
+          </a:fontRef>
+        </p:style>
+        <p:txBody>
+          <a:bodyPr rtlCol="0" anchor="ctr"/>
+          <a:lstStyle/>
+          <a:p>
+            <a:pPr algn="ctr"/>
+          </a:p>
+        </p:txBody>
+      </p:sp>
+      <p:sp>
+        <p:nvSpPr>
+          <p:cNvPr id="3" name="Rounded Rectangle 2"/>
           <p:cNvSpPr/>
           <p:nvPr/>
         </p:nvSpPr>
@@ -3152,7 +3187,7 @@
       </p:sp>
       <p:sp>
         <p:nvSpPr>
-          <p:cNvPr id="3" name="TextBox 2"/>
+          <p:cNvPr id="4" name="TextBox 3"/>
           <p:cNvSpPr txBox="1"/>
           <p:nvPr/>
         </p:nvSpPr>
@@ -3189,7 +3224,7 @@
       </p:sp>
       <p:sp>
         <p:nvSpPr>
-          <p:cNvPr id="4" name="TextBox 3"/>
+          <p:cNvPr id="5" name="TextBox 4"/>
           <p:cNvSpPr txBox="1"/>
           <p:nvPr/>
         </p:nvSpPr>
@@ -3224,7 +3259,7 @@
       </p:sp>
       <p:sp>
         <p:nvSpPr>
-          <p:cNvPr id="5" name="TextBox 4"/>
+          <p:cNvPr id="6" name="TextBox 5"/>
           <p:cNvSpPr txBox="1"/>
           <p:nvPr/>
         </p:nvSpPr>
@@ -3259,7 +3294,7 @@
       </p:sp>
       <p:sp>
         <p:nvSpPr>
-          <p:cNvPr id="6" name="TextBox 5"/>
+          <p:cNvPr id="7" name="TextBox 6"/>
           <p:cNvSpPr txBox="1"/>
           <p:nvPr/>
         </p:nvSpPr>
@@ -3294,7 +3329,7 @@
       </p:sp>
       <p:sp>
         <p:nvSpPr>
-          <p:cNvPr id="7" name="Rounded Rectangle 6"/>
+          <p:cNvPr id="8" name="Rounded Rectangle 7"/>
           <p:cNvSpPr/>
           <p:nvPr/>
         </p:nvSpPr>
@@ -3341,7 +3376,7 @@
       </p:sp>
       <p:sp>
         <p:nvSpPr>
-          <p:cNvPr id="8" name="TextBox 7"/>
+          <p:cNvPr id="9" name="TextBox 8"/>
           <p:cNvSpPr txBox="1"/>
           <p:nvPr/>
         </p:nvSpPr>
@@ -3376,7 +3411,7 @@
       </p:sp>
       <p:sp>
         <p:nvSpPr>
-          <p:cNvPr id="9" name="TextBox 8"/>
+          <p:cNvPr id="10" name="TextBox 9"/>
           <p:cNvSpPr txBox="1"/>
           <p:nvPr/>
         </p:nvSpPr>
@@ -3411,7 +3446,7 @@
       </p:sp>
       <p:sp>
         <p:nvSpPr>
-          <p:cNvPr id="10" name="Rectangle 9"/>
+          <p:cNvPr id="11" name="Rectangle 10"/>
           <p:cNvSpPr/>
           <p:nvPr/>
         </p:nvSpPr>
@@ -3454,7 +3489,7 @@
       </p:sp>
       <p:sp>
         <p:nvSpPr>
-          <p:cNvPr id="11" name="TextBox 10"/>
+          <p:cNvPr id="12" name="TextBox 11"/>
           <p:cNvSpPr txBox="1"/>
           <p:nvPr/>
         </p:nvSpPr>
@@ -3489,7 +3524,7 @@
       </p:sp>
       <p:sp>
         <p:nvSpPr>
-          <p:cNvPr id="12" name="TextBox 11"/>
+          <p:cNvPr id="13" name="TextBox 12"/>
           <p:cNvSpPr txBox="1"/>
           <p:nvPr/>
         </p:nvSpPr>
@@ -3524,7 +3559,7 @@
       </p:sp>
       <p:sp>
         <p:nvSpPr>
-          <p:cNvPr id="13" name="TextBox 12"/>
+          <p:cNvPr id="14" name="TextBox 13"/>
           <p:cNvSpPr txBox="1"/>
           <p:nvPr/>
         </p:nvSpPr>
@@ -3559,7 +3594,7 @@
       </p:sp>
       <p:sp>
         <p:nvSpPr>
-          <p:cNvPr id="14" name="TextBox 13"/>
+          <p:cNvPr id="15" name="TextBox 14"/>
           <p:cNvSpPr txBox="1"/>
           <p:nvPr/>
         </p:nvSpPr>
@@ -3594,7 +3629,7 @@
       </p:sp>
       <p:sp>
         <p:nvSpPr>
-          <p:cNvPr id="15" name="TextBox 14"/>
+          <p:cNvPr id="16" name="TextBox 15"/>
           <p:cNvSpPr txBox="1"/>
           <p:nvPr/>
         </p:nvSpPr>
@@ -3629,7 +3664,7 @@
       </p:sp>
       <p:sp>
         <p:nvSpPr>
-          <p:cNvPr id="16" name="TextBox 15"/>
+          <p:cNvPr id="17" name="TextBox 16"/>
           <p:cNvSpPr txBox="1"/>
           <p:nvPr/>
         </p:nvSpPr>
@@ -3664,7 +3699,7 @@
       </p:sp>
       <p:sp>
         <p:nvSpPr>
-          <p:cNvPr id="17" name="TextBox 16"/>
+          <p:cNvPr id="18" name="TextBox 17"/>
           <p:cNvSpPr txBox="1"/>
           <p:nvPr/>
         </p:nvSpPr>
@@ -3699,7 +3734,7 @@
       </p:sp>
       <p:sp>
         <p:nvSpPr>
-          <p:cNvPr id="18" name="TextBox 17"/>
+          <p:cNvPr id="19" name="TextBox 18"/>
           <p:cNvSpPr txBox="1"/>
           <p:nvPr/>
         </p:nvSpPr>
@@ -3743,14 +3778,6 @@
 <file path=ppt/slides/slide2.xml><?xml version="1.0" encoding="utf-8"?>
 <p:sld xmlns:a="http://schemas.openxmlformats.org/drawingml/2006/main" xmlns:p="http://schemas.openxmlformats.org/presentationml/2006/main" xmlns:r="http://schemas.openxmlformats.org/officeDocument/2006/relationships">
   <p:cSld>
-    <p:bg>
-      <p:bgPr>
-        <a:solidFill>
-          <a:srgbClr val="0A0E27"/>
-        </a:solidFill>
-        <a:effectLst/>
-      </p:bgPr>
-    </p:bg>
     <p:spTree>
       <p:nvGrpSpPr>
         <p:cNvPr id="1" name=""/>
@@ -3760,7 +3787,50 @@
       <p:grpSpPr/>
       <p:sp>
         <p:nvSpPr>
-          <p:cNvPr id="2" name="Rounded Rectangle 1"/>
+          <p:cNvPr id="2" name="Rectangle 1"/>
+          <p:cNvSpPr/>
+          <p:nvPr/>
+        </p:nvSpPr>
+        <p:spPr>
+          <a:xfrm>
+            <a:off x="0" y="0"/>
+            <a:ext cx="12191695" cy="6858000"/>
+          </a:xfrm>
+          <a:prstGeom prst="rect">
+            <a:avLst/>
+          </a:prstGeom>
+          <a:solidFill>
+            <a:srgbClr val="0A0E27"/>
+          </a:solidFill>
+          <a:ln>
+            <a:noFill/>
+          </a:ln>
+        </p:spPr>
+        <p:style>
+          <a:lnRef idx="1">
+            <a:schemeClr val="accent1"/>
+          </a:lnRef>
+          <a:fillRef idx="3">
+            <a:schemeClr val="accent1"/>
+          </a:fillRef>
+          <a:effectRef idx="2">
+            <a:schemeClr val="accent1"/>
+          </a:effectRef>
+          <a:fontRef idx="minor">
+            <a:schemeClr val="lt1"/>
+          </a:fontRef>
+        </p:style>
+        <p:txBody>
+          <a:bodyPr rtlCol="0" anchor="ctr"/>
+          <a:lstStyle/>
+          <a:p>
+            <a:pPr algn="ctr"/>
+          </a:p>
+        </p:txBody>
+      </p:sp>
+      <p:sp>
+        <p:nvSpPr>
+          <p:cNvPr id="3" name="Rounded Rectangle 2"/>
           <p:cNvSpPr/>
           <p:nvPr/>
         </p:nvSpPr>
@@ -3807,7 +3877,7 @@
       </p:sp>
       <p:sp>
         <p:nvSpPr>
-          <p:cNvPr id="3" name="TextBox 2"/>
+          <p:cNvPr id="4" name="TextBox 3"/>
           <p:cNvSpPr txBox="1"/>
           <p:nvPr/>
         </p:nvSpPr>
@@ -3842,7 +3912,7 @@
       </p:sp>
       <p:sp>
         <p:nvSpPr>
-          <p:cNvPr id="4" name="TextBox 3"/>
+          <p:cNvPr id="5" name="TextBox 4"/>
           <p:cNvSpPr txBox="1"/>
           <p:nvPr/>
         </p:nvSpPr>
@@ -3877,7 +3947,7 @@
       </p:sp>
       <p:sp>
         <p:nvSpPr>
-          <p:cNvPr id="5" name="TextBox 4"/>
+          <p:cNvPr id="6" name="TextBox 5"/>
           <p:cNvSpPr txBox="1"/>
           <p:nvPr/>
         </p:nvSpPr>
@@ -3912,7 +3982,7 @@
       </p:sp>
       <p:sp>
         <p:nvSpPr>
-          <p:cNvPr id="6" name="TextBox 5"/>
+          <p:cNvPr id="7" name="TextBox 6"/>
           <p:cNvSpPr txBox="1"/>
           <p:nvPr/>
         </p:nvSpPr>
@@ -3947,7 +4017,7 @@
       </p:sp>
       <p:sp>
         <p:nvSpPr>
-          <p:cNvPr id="7" name="Rectangle 6"/>
+          <p:cNvPr id="8" name="Rectangle 7"/>
           <p:cNvSpPr/>
           <p:nvPr/>
         </p:nvSpPr>
@@ -3990,7 +4060,7 @@
       </p:sp>
       <p:sp>
         <p:nvSpPr>
-          <p:cNvPr id="8" name="TextBox 7"/>
+          <p:cNvPr id="9" name="TextBox 8"/>
           <p:cNvSpPr txBox="1"/>
           <p:nvPr/>
         </p:nvSpPr>
@@ -4025,7 +4095,7 @@
       </p:sp>
       <p:sp>
         <p:nvSpPr>
-          <p:cNvPr id="9" name="Rounded Rectangle 8"/>
+          <p:cNvPr id="10" name="Rounded Rectangle 9"/>
           <p:cNvSpPr/>
           <p:nvPr/>
         </p:nvSpPr>
@@ -4072,7 +4142,7 @@
       </p:sp>
       <p:sp>
         <p:nvSpPr>
-          <p:cNvPr id="10" name="TextBox 9"/>
+          <p:cNvPr id="11" name="TextBox 10"/>
           <p:cNvSpPr txBox="1"/>
           <p:nvPr/>
         </p:nvSpPr>
@@ -4107,7 +4177,7 @@
       </p:sp>
       <p:sp>
         <p:nvSpPr>
-          <p:cNvPr id="11" name="TextBox 10"/>
+          <p:cNvPr id="12" name="TextBox 11"/>
           <p:cNvSpPr txBox="1"/>
           <p:nvPr/>
         </p:nvSpPr>
@@ -4142,7 +4212,7 @@
       </p:sp>
       <p:sp>
         <p:nvSpPr>
-          <p:cNvPr id="12" name="TextBox 11"/>
+          <p:cNvPr id="13" name="TextBox 12"/>
           <p:cNvSpPr txBox="1"/>
           <p:nvPr/>
         </p:nvSpPr>
@@ -4177,7 +4247,7 @@
       </p:sp>
       <p:sp>
         <p:nvSpPr>
-          <p:cNvPr id="13" name="TextBox 12"/>
+          <p:cNvPr id="14" name="TextBox 13"/>
           <p:cNvSpPr txBox="1"/>
           <p:nvPr/>
         </p:nvSpPr>
@@ -4212,7 +4282,7 @@
       </p:sp>
       <p:sp>
         <p:nvSpPr>
-          <p:cNvPr id="14" name="Rectangle 13"/>
+          <p:cNvPr id="15" name="Rectangle 14"/>
           <p:cNvSpPr/>
           <p:nvPr/>
         </p:nvSpPr>
@@ -4255,7 +4325,7 @@
       </p:sp>
       <p:sp>
         <p:nvSpPr>
-          <p:cNvPr id="15" name="TextBox 14"/>
+          <p:cNvPr id="16" name="TextBox 15"/>
           <p:cNvSpPr txBox="1"/>
           <p:nvPr/>
         </p:nvSpPr>
@@ -4290,7 +4360,7 @@
       </p:sp>
       <p:sp>
         <p:nvSpPr>
-          <p:cNvPr id="16" name="TextBox 15"/>
+          <p:cNvPr id="17" name="TextBox 16"/>
           <p:cNvSpPr txBox="1"/>
           <p:nvPr/>
         </p:nvSpPr>
@@ -4325,7 +4395,7 @@
       </p:sp>
       <p:sp>
         <p:nvSpPr>
-          <p:cNvPr id="17" name="TextBox 16"/>
+          <p:cNvPr id="18" name="TextBox 17"/>
           <p:cNvSpPr txBox="1"/>
           <p:nvPr/>
         </p:nvSpPr>
@@ -4369,14 +4439,6 @@
 <file path=ppt/slides/slide3.xml><?xml version="1.0" encoding="utf-8"?>
 <p:sld xmlns:a="http://schemas.openxmlformats.org/drawingml/2006/main" xmlns:p="http://schemas.openxmlformats.org/presentationml/2006/main" xmlns:r="http://schemas.openxmlformats.org/officeDocument/2006/relationships">
   <p:cSld>
-    <p:bg>
-      <p:bgPr>
-        <a:solidFill>
-          <a:srgbClr val="0A0E27"/>
-        </a:solidFill>
-        <a:effectLst/>
-      </p:bgPr>
-    </p:bg>
     <p:spTree>
       <p:nvGrpSpPr>
         <p:cNvPr id="1" name=""/>
@@ -4386,7 +4448,50 @@
       <p:grpSpPr/>
       <p:sp>
         <p:nvSpPr>
-          <p:cNvPr id="2" name="Rounded Rectangle 1"/>
+          <p:cNvPr id="2" name="Rectangle 1"/>
+          <p:cNvSpPr/>
+          <p:nvPr/>
+        </p:nvSpPr>
+        <p:spPr>
+          <a:xfrm>
+            <a:off x="0" y="0"/>
+            <a:ext cx="12191695" cy="6858000"/>
+          </a:xfrm>
+          <a:prstGeom prst="rect">
+            <a:avLst/>
+          </a:prstGeom>
+          <a:solidFill>
+            <a:srgbClr val="0A0E27"/>
+          </a:solidFill>
+          <a:ln>
+            <a:noFill/>
+          </a:ln>
+        </p:spPr>
+        <p:style>
+          <a:lnRef idx="1">
+            <a:schemeClr val="accent1"/>
+          </a:lnRef>
+          <a:fillRef idx="3">
+            <a:schemeClr val="accent1"/>
+          </a:fillRef>
+          <a:effectRef idx="2">
+            <a:schemeClr val="accent1"/>
+          </a:effectRef>
+          <a:fontRef idx="minor">
+            <a:schemeClr val="lt1"/>
+          </a:fontRef>
+        </p:style>
+        <p:txBody>
+          <a:bodyPr rtlCol="0" anchor="ctr"/>
+          <a:lstStyle/>
+          <a:p>
+            <a:pPr algn="ctr"/>
+          </a:p>
+        </p:txBody>
+      </p:sp>
+      <p:sp>
+        <p:nvSpPr>
+          <p:cNvPr id="3" name="Rounded Rectangle 2"/>
           <p:cNvSpPr/>
           <p:nvPr/>
         </p:nvSpPr>
@@ -4433,7 +4538,7 @@
       </p:sp>
       <p:sp>
         <p:nvSpPr>
-          <p:cNvPr id="3" name="TextBox 2"/>
+          <p:cNvPr id="4" name="TextBox 3"/>
           <p:cNvSpPr txBox="1"/>
           <p:nvPr/>
         </p:nvSpPr>
@@ -4468,7 +4573,7 @@
       </p:sp>
       <p:sp>
         <p:nvSpPr>
-          <p:cNvPr id="4" name="TextBox 3"/>
+          <p:cNvPr id="5" name="TextBox 4"/>
           <p:cNvSpPr txBox="1"/>
           <p:nvPr/>
         </p:nvSpPr>
@@ -4503,7 +4608,7 @@
       </p:sp>
       <p:sp>
         <p:nvSpPr>
-          <p:cNvPr id="5" name="TextBox 4"/>
+          <p:cNvPr id="6" name="TextBox 5"/>
           <p:cNvSpPr txBox="1"/>
           <p:nvPr/>
         </p:nvSpPr>
@@ -4558,7 +4663,7 @@
       </p:sp>
       <p:sp>
         <p:nvSpPr>
-          <p:cNvPr id="6" name="Rounded Rectangle 5"/>
+          <p:cNvPr id="7" name="Rounded Rectangle 6"/>
           <p:cNvSpPr/>
           <p:nvPr/>
         </p:nvSpPr>
@@ -4605,7 +4710,7 @@
       </p:sp>
       <p:sp>
         <p:nvSpPr>
-          <p:cNvPr id="7" name="TextBox 6"/>
+          <p:cNvPr id="8" name="TextBox 7"/>
           <p:cNvSpPr txBox="1"/>
           <p:nvPr/>
         </p:nvSpPr>
@@ -4640,7 +4745,7 @@
       </p:sp>
       <p:sp>
         <p:nvSpPr>
-          <p:cNvPr id="8" name="Rounded Rectangle 7"/>
+          <p:cNvPr id="9" name="Rounded Rectangle 8"/>
           <p:cNvSpPr/>
           <p:nvPr/>
         </p:nvSpPr>
@@ -4685,7 +4790,7 @@
       </p:sp>
       <p:sp>
         <p:nvSpPr>
-          <p:cNvPr id="9" name="TextBox 8"/>
+          <p:cNvPr id="10" name="TextBox 9"/>
           <p:cNvSpPr txBox="1"/>
           <p:nvPr/>
         </p:nvSpPr>
@@ -4720,7 +4825,7 @@
       </p:sp>
       <p:sp>
         <p:nvSpPr>
-          <p:cNvPr id="10" name="TextBox 9"/>
+          <p:cNvPr id="11" name="TextBox 10"/>
           <p:cNvSpPr txBox="1"/>
           <p:nvPr/>
         </p:nvSpPr>
@@ -4755,7 +4860,7 @@
       </p:sp>
       <p:sp>
         <p:nvSpPr>
-          <p:cNvPr id="11" name="TextBox 10"/>
+          <p:cNvPr id="12" name="TextBox 11"/>
           <p:cNvSpPr txBox="1"/>
           <p:nvPr/>
         </p:nvSpPr>
@@ -4790,7 +4895,7 @@
       </p:sp>
       <p:sp>
         <p:nvSpPr>
-          <p:cNvPr id="12" name="Rounded Rectangle 11"/>
+          <p:cNvPr id="13" name="Rounded Rectangle 12"/>
           <p:cNvSpPr/>
           <p:nvPr/>
         </p:nvSpPr>
@@ -4835,7 +4940,7 @@
       </p:sp>
       <p:sp>
         <p:nvSpPr>
-          <p:cNvPr id="13" name="TextBox 12"/>
+          <p:cNvPr id="14" name="TextBox 13"/>
           <p:cNvSpPr txBox="1"/>
           <p:nvPr/>
         </p:nvSpPr>
@@ -4870,7 +4975,7 @@
       </p:sp>
       <p:sp>
         <p:nvSpPr>
-          <p:cNvPr id="14" name="TextBox 13"/>
+          <p:cNvPr id="15" name="TextBox 14"/>
           <p:cNvSpPr txBox="1"/>
           <p:nvPr/>
         </p:nvSpPr>
@@ -4905,7 +5010,7 @@
       </p:sp>
       <p:sp>
         <p:nvSpPr>
-          <p:cNvPr id="15" name="TextBox 14"/>
+          <p:cNvPr id="16" name="TextBox 15"/>
           <p:cNvSpPr txBox="1"/>
           <p:nvPr/>
         </p:nvSpPr>
@@ -4940,7 +5045,7 @@
       </p:sp>
       <p:sp>
         <p:nvSpPr>
-          <p:cNvPr id="16" name="Rounded Rectangle 15"/>
+          <p:cNvPr id="17" name="Rounded Rectangle 16"/>
           <p:cNvSpPr/>
           <p:nvPr/>
         </p:nvSpPr>
@@ -4985,7 +5090,7 @@
       </p:sp>
       <p:sp>
         <p:nvSpPr>
-          <p:cNvPr id="17" name="TextBox 16"/>
+          <p:cNvPr id="18" name="TextBox 17"/>
           <p:cNvSpPr txBox="1"/>
           <p:nvPr/>
         </p:nvSpPr>
@@ -5020,7 +5125,7 @@
       </p:sp>
       <p:sp>
         <p:nvSpPr>
-          <p:cNvPr id="18" name="TextBox 17"/>
+          <p:cNvPr id="19" name="TextBox 18"/>
           <p:cNvSpPr txBox="1"/>
           <p:nvPr/>
         </p:nvSpPr>
@@ -5055,7 +5160,7 @@
       </p:sp>
       <p:sp>
         <p:nvSpPr>
-          <p:cNvPr id="19" name="TextBox 18"/>
+          <p:cNvPr id="20" name="TextBox 19"/>
           <p:cNvSpPr txBox="1"/>
           <p:nvPr/>
         </p:nvSpPr>
@@ -5090,7 +5195,7 @@
       </p:sp>
       <p:sp>
         <p:nvSpPr>
-          <p:cNvPr id="20" name="Rounded Rectangle 19"/>
+          <p:cNvPr id="21" name="Rounded Rectangle 20"/>
           <p:cNvSpPr/>
           <p:nvPr/>
         </p:nvSpPr>
@@ -5135,7 +5240,7 @@
       </p:sp>
       <p:sp>
         <p:nvSpPr>
-          <p:cNvPr id="21" name="TextBox 20"/>
+          <p:cNvPr id="22" name="TextBox 21"/>
           <p:cNvSpPr txBox="1"/>
           <p:nvPr/>
         </p:nvSpPr>
@@ -5170,7 +5275,7 @@
       </p:sp>
       <p:sp>
         <p:nvSpPr>
-          <p:cNvPr id="22" name="TextBox 21"/>
+          <p:cNvPr id="23" name="TextBox 22"/>
           <p:cNvSpPr txBox="1"/>
           <p:nvPr/>
         </p:nvSpPr>
@@ -5205,7 +5310,7 @@
       </p:sp>
       <p:sp>
         <p:nvSpPr>
-          <p:cNvPr id="23" name="TextBox 22"/>
+          <p:cNvPr id="24" name="TextBox 23"/>
           <p:cNvSpPr txBox="1"/>
           <p:nvPr/>
         </p:nvSpPr>
@@ -5240,7 +5345,7 @@
       </p:sp>
       <p:sp>
         <p:nvSpPr>
-          <p:cNvPr id="24" name="TextBox 23"/>
+          <p:cNvPr id="25" name="TextBox 24"/>
           <p:cNvSpPr txBox="1"/>
           <p:nvPr/>
         </p:nvSpPr>
@@ -5275,7 +5380,7 @@
       </p:sp>
       <p:sp>
         <p:nvSpPr>
-          <p:cNvPr id="25" name="TextBox 24"/>
+          <p:cNvPr id="26" name="TextBox 25"/>
           <p:cNvSpPr txBox="1"/>
           <p:nvPr/>
         </p:nvSpPr>
@@ -5319,14 +5424,6 @@
 <file path=ppt/slides/slide4.xml><?xml version="1.0" encoding="utf-8"?>
 <p:sld xmlns:a="http://schemas.openxmlformats.org/drawingml/2006/main" xmlns:p="http://schemas.openxmlformats.org/presentationml/2006/main" xmlns:r="http://schemas.openxmlformats.org/officeDocument/2006/relationships">
   <p:cSld>
-    <p:bg>
-      <p:bgPr>
-        <a:solidFill>
-          <a:srgbClr val="0A0E27"/>
-        </a:solidFill>
-        <a:effectLst/>
-      </p:bgPr>
-    </p:bg>
     <p:spTree>
       <p:nvGrpSpPr>
         <p:cNvPr id="1" name=""/>
@@ -5336,7 +5433,50 @@
       <p:grpSpPr/>
       <p:sp>
         <p:nvSpPr>
-          <p:cNvPr id="2" name="Rounded Rectangle 1"/>
+          <p:cNvPr id="2" name="Rectangle 1"/>
+          <p:cNvSpPr/>
+          <p:nvPr/>
+        </p:nvSpPr>
+        <p:spPr>
+          <a:xfrm>
+            <a:off x="0" y="0"/>
+            <a:ext cx="12191695" cy="6858000"/>
+          </a:xfrm>
+          <a:prstGeom prst="rect">
+            <a:avLst/>
+          </a:prstGeom>
+          <a:solidFill>
+            <a:srgbClr val="0A0E27"/>
+          </a:solidFill>
+          <a:ln>
+            <a:noFill/>
+          </a:ln>
+        </p:spPr>
+        <p:style>
+          <a:lnRef idx="1">
+            <a:schemeClr val="accent1"/>
+          </a:lnRef>
+          <a:fillRef idx="3">
+            <a:schemeClr val="accent1"/>
+          </a:fillRef>
+          <a:effectRef idx="2">
+            <a:schemeClr val="accent1"/>
+          </a:effectRef>
+          <a:fontRef idx="minor">
+            <a:schemeClr val="lt1"/>
+          </a:fontRef>
+        </p:style>
+        <p:txBody>
+          <a:bodyPr rtlCol="0" anchor="ctr"/>
+          <a:lstStyle/>
+          <a:p>
+            <a:pPr algn="ctr"/>
+          </a:p>
+        </p:txBody>
+      </p:sp>
+      <p:sp>
+        <p:nvSpPr>
+          <p:cNvPr id="3" name="Rounded Rectangle 2"/>
           <p:cNvSpPr/>
           <p:nvPr/>
         </p:nvSpPr>
@@ -5383,7 +5523,7 @@
       </p:sp>
       <p:sp>
         <p:nvSpPr>
-          <p:cNvPr id="3" name="TextBox 2"/>
+          <p:cNvPr id="4" name="TextBox 3"/>
           <p:cNvSpPr txBox="1"/>
           <p:nvPr/>
         </p:nvSpPr>
@@ -5418,7 +5558,7 @@
       </p:sp>
       <p:sp>
         <p:nvSpPr>
-          <p:cNvPr id="4" name="TextBox 3"/>
+          <p:cNvPr id="5" name="TextBox 4"/>
           <p:cNvSpPr txBox="1"/>
           <p:nvPr/>
         </p:nvSpPr>
@@ -5453,7 +5593,7 @@
       </p:sp>
       <p:sp>
         <p:nvSpPr>
-          <p:cNvPr id="5" name="TextBox 4"/>
+          <p:cNvPr id="6" name="TextBox 5"/>
           <p:cNvSpPr txBox="1"/>
           <p:nvPr/>
         </p:nvSpPr>
@@ -5488,7 +5628,7 @@
       </p:sp>
       <p:sp>
         <p:nvSpPr>
-          <p:cNvPr id="6" name="Rectangle 5"/>
+          <p:cNvPr id="7" name="Rectangle 6"/>
           <p:cNvSpPr/>
           <p:nvPr/>
         </p:nvSpPr>
@@ -5531,7 +5671,7 @@
       </p:sp>
       <p:sp>
         <p:nvSpPr>
-          <p:cNvPr id="7" name="TextBox 6"/>
+          <p:cNvPr id="8" name="TextBox 7"/>
           <p:cNvSpPr txBox="1"/>
           <p:nvPr/>
         </p:nvSpPr>
@@ -5566,7 +5706,7 @@
       </p:sp>
       <p:sp>
         <p:nvSpPr>
-          <p:cNvPr id="8" name="Rounded Rectangle 7"/>
+          <p:cNvPr id="9" name="Rounded Rectangle 8"/>
           <p:cNvSpPr/>
           <p:nvPr/>
         </p:nvSpPr>
@@ -5613,7 +5753,7 @@
       </p:sp>
       <p:sp>
         <p:nvSpPr>
-          <p:cNvPr id="9" name="TextBox 8"/>
+          <p:cNvPr id="10" name="TextBox 9"/>
           <p:cNvSpPr txBox="1"/>
           <p:nvPr/>
         </p:nvSpPr>
@@ -5648,7 +5788,7 @@
       </p:sp>
       <p:sp>
         <p:nvSpPr>
-          <p:cNvPr id="10" name="TextBox 9"/>
+          <p:cNvPr id="11" name="TextBox 10"/>
           <p:cNvSpPr txBox="1"/>
           <p:nvPr/>
         </p:nvSpPr>
@@ -5683,7 +5823,7 @@
       </p:sp>
       <p:sp>
         <p:nvSpPr>
-          <p:cNvPr id="11" name="TextBox 10"/>
+          <p:cNvPr id="12" name="TextBox 11"/>
           <p:cNvSpPr txBox="1"/>
           <p:nvPr/>
         </p:nvSpPr>
@@ -5718,7 +5858,7 @@
       </p:sp>
       <p:sp>
         <p:nvSpPr>
-          <p:cNvPr id="12" name="Rectangle 11"/>
+          <p:cNvPr id="13" name="Rectangle 12"/>
           <p:cNvSpPr/>
           <p:nvPr/>
         </p:nvSpPr>
@@ -5761,7 +5901,7 @@
       </p:sp>
       <p:sp>
         <p:nvSpPr>
-          <p:cNvPr id="13" name="TextBox 12"/>
+          <p:cNvPr id="14" name="TextBox 13"/>
           <p:cNvSpPr txBox="1"/>
           <p:nvPr/>
         </p:nvSpPr>
@@ -5796,7 +5936,7 @@
       </p:sp>
       <p:sp>
         <p:nvSpPr>
-          <p:cNvPr id="14" name="Rounded Rectangle 13"/>
+          <p:cNvPr id="15" name="Rounded Rectangle 14"/>
           <p:cNvSpPr/>
           <p:nvPr/>
         </p:nvSpPr>
@@ -5843,7 +5983,7 @@
       </p:sp>
       <p:sp>
         <p:nvSpPr>
-          <p:cNvPr id="15" name="TextBox 14"/>
+          <p:cNvPr id="16" name="TextBox 15"/>
           <p:cNvSpPr txBox="1"/>
           <p:nvPr/>
         </p:nvSpPr>
@@ -5878,7 +6018,7 @@
       </p:sp>
       <p:sp>
         <p:nvSpPr>
-          <p:cNvPr id="16" name="TextBox 15"/>
+          <p:cNvPr id="17" name="TextBox 16"/>
           <p:cNvSpPr txBox="1"/>
           <p:nvPr/>
         </p:nvSpPr>
@@ -5913,7 +6053,7 @@
       </p:sp>
       <p:sp>
         <p:nvSpPr>
-          <p:cNvPr id="17" name="TextBox 16"/>
+          <p:cNvPr id="18" name="TextBox 17"/>
           <p:cNvSpPr txBox="1"/>
           <p:nvPr/>
         </p:nvSpPr>
@@ -5948,7 +6088,7 @@
       </p:sp>
       <p:sp>
         <p:nvSpPr>
-          <p:cNvPr id="18" name="Rectangle 17"/>
+          <p:cNvPr id="19" name="Rectangle 18"/>
           <p:cNvSpPr/>
           <p:nvPr/>
         </p:nvSpPr>
@@ -5991,7 +6131,7 @@
       </p:sp>
       <p:sp>
         <p:nvSpPr>
-          <p:cNvPr id="19" name="TextBox 18"/>
+          <p:cNvPr id="20" name="TextBox 19"/>
           <p:cNvSpPr txBox="1"/>
           <p:nvPr/>
         </p:nvSpPr>
@@ -6026,7 +6166,7 @@
       </p:sp>
       <p:sp>
         <p:nvSpPr>
-          <p:cNvPr id="20" name="TextBox 19"/>
+          <p:cNvPr id="21" name="TextBox 20"/>
           <p:cNvSpPr txBox="1"/>
           <p:nvPr/>
         </p:nvSpPr>
@@ -6061,7 +6201,7 @@
       </p:sp>
       <p:sp>
         <p:nvSpPr>
-          <p:cNvPr id="21" name="TextBox 20"/>
+          <p:cNvPr id="22" name="TextBox 21"/>
           <p:cNvSpPr txBox="1"/>
           <p:nvPr/>
         </p:nvSpPr>
@@ -6105,14 +6245,6 @@
 <file path=ppt/slides/slide5.xml><?xml version="1.0" encoding="utf-8"?>
 <p:sld xmlns:a="http://schemas.openxmlformats.org/drawingml/2006/main" xmlns:p="http://schemas.openxmlformats.org/presentationml/2006/main" xmlns:r="http://schemas.openxmlformats.org/officeDocument/2006/relationships">
   <p:cSld>
-    <p:bg>
-      <p:bgPr>
-        <a:solidFill>
-          <a:srgbClr val="0A0E27"/>
-        </a:solidFill>
-        <a:effectLst/>
-      </p:bgPr>
-    </p:bg>
     <p:spTree>
       <p:nvGrpSpPr>
         <p:cNvPr id="1" name=""/>
@@ -6122,7 +6254,50 @@
       <p:grpSpPr/>
       <p:sp>
         <p:nvSpPr>
-          <p:cNvPr id="2" name="Rounded Rectangle 1"/>
+          <p:cNvPr id="2" name="Rectangle 1"/>
+          <p:cNvSpPr/>
+          <p:nvPr/>
+        </p:nvSpPr>
+        <p:spPr>
+          <a:xfrm>
+            <a:off x="0" y="0"/>
+            <a:ext cx="12191695" cy="6858000"/>
+          </a:xfrm>
+          <a:prstGeom prst="rect">
+            <a:avLst/>
+          </a:prstGeom>
+          <a:solidFill>
+            <a:srgbClr val="0A0E27"/>
+          </a:solidFill>
+          <a:ln>
+            <a:noFill/>
+          </a:ln>
+        </p:spPr>
+        <p:style>
+          <a:lnRef idx="1">
+            <a:schemeClr val="accent1"/>
+          </a:lnRef>
+          <a:fillRef idx="3">
+            <a:schemeClr val="accent1"/>
+          </a:fillRef>
+          <a:effectRef idx="2">
+            <a:schemeClr val="accent1"/>
+          </a:effectRef>
+          <a:fontRef idx="minor">
+            <a:schemeClr val="lt1"/>
+          </a:fontRef>
+        </p:style>
+        <p:txBody>
+          <a:bodyPr rtlCol="0" anchor="ctr"/>
+          <a:lstStyle/>
+          <a:p>
+            <a:pPr algn="ctr"/>
+          </a:p>
+        </p:txBody>
+      </p:sp>
+      <p:sp>
+        <p:nvSpPr>
+          <p:cNvPr id="3" name="Rounded Rectangle 2"/>
           <p:cNvSpPr/>
           <p:nvPr/>
         </p:nvSpPr>
@@ -6169,7 +6344,7 @@
       </p:sp>
       <p:sp>
         <p:nvSpPr>
-          <p:cNvPr id="3" name="Rounded Rectangle 2"/>
+          <p:cNvPr id="4" name="Rounded Rectangle 3"/>
           <p:cNvSpPr/>
           <p:nvPr/>
         </p:nvSpPr>
@@ -6214,7 +6389,7 @@
       </p:sp>
       <p:sp>
         <p:nvSpPr>
-          <p:cNvPr id="4" name="TextBox 3"/>
+          <p:cNvPr id="5" name="TextBox 4"/>
           <p:cNvSpPr txBox="1"/>
           <p:nvPr/>
         </p:nvSpPr>
@@ -6249,7 +6424,7 @@
       </p:sp>
       <p:sp>
         <p:nvSpPr>
-          <p:cNvPr id="5" name="Rectangle 4"/>
+          <p:cNvPr id="6" name="Rectangle 5"/>
           <p:cNvSpPr/>
           <p:nvPr/>
         </p:nvSpPr>
@@ -6292,7 +6467,7 @@
       </p:sp>
       <p:sp>
         <p:nvSpPr>
-          <p:cNvPr id="6" name="TextBox 5"/>
+          <p:cNvPr id="7" name="TextBox 6"/>
           <p:cNvSpPr txBox="1"/>
           <p:nvPr/>
         </p:nvSpPr>
@@ -6327,7 +6502,7 @@
       </p:sp>
       <p:sp>
         <p:nvSpPr>
-          <p:cNvPr id="7" name="TextBox 6"/>
+          <p:cNvPr id="8" name="TextBox 7"/>
           <p:cNvSpPr txBox="1"/>
           <p:nvPr/>
         </p:nvSpPr>
@@ -6362,7 +6537,7 @@
       </p:sp>
       <p:sp>
         <p:nvSpPr>
-          <p:cNvPr id="8" name="Rounded Rectangle 7"/>
+          <p:cNvPr id="9" name="Rounded Rectangle 8"/>
           <p:cNvSpPr/>
           <p:nvPr/>
         </p:nvSpPr>
@@ -6409,7 +6584,7 @@
       </p:sp>
       <p:sp>
         <p:nvSpPr>
-          <p:cNvPr id="9" name="TextBox 8"/>
+          <p:cNvPr id="10" name="TextBox 9"/>
           <p:cNvSpPr txBox="1"/>
           <p:nvPr/>
         </p:nvSpPr>
@@ -6444,7 +6619,7 @@
       </p:sp>
       <p:sp>
         <p:nvSpPr>
-          <p:cNvPr id="10" name="TextBox 9"/>
+          <p:cNvPr id="11" name="TextBox 10"/>
           <p:cNvSpPr txBox="1"/>
           <p:nvPr/>
         </p:nvSpPr>
@@ -6479,7 +6654,7 @@
       </p:sp>
       <p:sp>
         <p:nvSpPr>
-          <p:cNvPr id="11" name="TextBox 10"/>
+          <p:cNvPr id="12" name="TextBox 11"/>
           <p:cNvSpPr txBox="1"/>
           <p:nvPr/>
         </p:nvSpPr>
@@ -6514,7 +6689,7 @@
       </p:sp>
       <p:sp>
         <p:nvSpPr>
-          <p:cNvPr id="12" name="Rectangle 11"/>
+          <p:cNvPr id="13" name="Rectangle 12"/>
           <p:cNvSpPr/>
           <p:nvPr/>
         </p:nvSpPr>
@@ -6557,7 +6732,7 @@
       </p:sp>
       <p:sp>
         <p:nvSpPr>
-          <p:cNvPr id="13" name="Rounded Rectangle 12"/>
+          <p:cNvPr id="14" name="Rounded Rectangle 13"/>
           <p:cNvSpPr/>
           <p:nvPr/>
         </p:nvSpPr>
@@ -6604,7 +6779,7 @@
       </p:sp>
       <p:sp>
         <p:nvSpPr>
-          <p:cNvPr id="14" name="TextBox 13"/>
+          <p:cNvPr id="15" name="TextBox 14"/>
           <p:cNvSpPr txBox="1"/>
           <p:nvPr/>
         </p:nvSpPr>
@@ -6639,7 +6814,7 @@
       </p:sp>
       <p:sp>
         <p:nvSpPr>
-          <p:cNvPr id="15" name="TextBox 14"/>
+          <p:cNvPr id="16" name="TextBox 15"/>
           <p:cNvSpPr txBox="1"/>
           <p:nvPr/>
         </p:nvSpPr>
@@ -6674,7 +6849,7 @@
       </p:sp>
       <p:sp>
         <p:nvSpPr>
-          <p:cNvPr id="16" name="TextBox 15"/>
+          <p:cNvPr id="17" name="TextBox 16"/>
           <p:cNvSpPr txBox="1"/>
           <p:nvPr/>
         </p:nvSpPr>
@@ -6709,7 +6884,7 @@
       </p:sp>
       <p:sp>
         <p:nvSpPr>
-          <p:cNvPr id="17" name="Rectangle 16"/>
+          <p:cNvPr id="18" name="Rectangle 17"/>
           <p:cNvSpPr/>
           <p:nvPr/>
         </p:nvSpPr>
@@ -6752,7 +6927,7 @@
       </p:sp>
       <p:sp>
         <p:nvSpPr>
-          <p:cNvPr id="18" name="Rounded Rectangle 17"/>
+          <p:cNvPr id="19" name="Rounded Rectangle 18"/>
           <p:cNvSpPr/>
           <p:nvPr/>
         </p:nvSpPr>
@@ -6799,7 +6974,7 @@
       </p:sp>
       <p:sp>
         <p:nvSpPr>
-          <p:cNvPr id="19" name="TextBox 18"/>
+          <p:cNvPr id="20" name="TextBox 19"/>
           <p:cNvSpPr txBox="1"/>
           <p:nvPr/>
         </p:nvSpPr>
@@ -6834,7 +7009,7 @@
       </p:sp>
       <p:sp>
         <p:nvSpPr>
-          <p:cNvPr id="20" name="TextBox 19"/>
+          <p:cNvPr id="21" name="TextBox 20"/>
           <p:cNvSpPr txBox="1"/>
           <p:nvPr/>
         </p:nvSpPr>
@@ -6869,7 +7044,7 @@
       </p:sp>
       <p:sp>
         <p:nvSpPr>
-          <p:cNvPr id="21" name="Rectangle 20"/>
+          <p:cNvPr id="22" name="Rectangle 21"/>
           <p:cNvSpPr/>
           <p:nvPr/>
         </p:nvSpPr>
@@ -6912,7 +7087,7 @@
       </p:sp>
       <p:sp>
         <p:nvSpPr>
-          <p:cNvPr id="22" name="TextBox 21"/>
+          <p:cNvPr id="23" name="TextBox 22"/>
           <p:cNvSpPr txBox="1"/>
           <p:nvPr/>
         </p:nvSpPr>
@@ -6947,7 +7122,7 @@
       </p:sp>
       <p:sp>
         <p:nvSpPr>
-          <p:cNvPr id="23" name="Rounded Rectangle 22"/>
+          <p:cNvPr id="24" name="Rounded Rectangle 23"/>
           <p:cNvSpPr/>
           <p:nvPr/>
         </p:nvSpPr>
@@ -6994,7 +7169,7 @@
       </p:sp>
       <p:sp>
         <p:nvSpPr>
-          <p:cNvPr id="24" name="TextBox 23"/>
+          <p:cNvPr id="25" name="TextBox 24"/>
           <p:cNvSpPr txBox="1"/>
           <p:nvPr/>
         </p:nvSpPr>
@@ -7029,7 +7204,7 @@
       </p:sp>
       <p:sp>
         <p:nvSpPr>
-          <p:cNvPr id="25" name="TextBox 24"/>
+          <p:cNvPr id="26" name="TextBox 25"/>
           <p:cNvSpPr txBox="1"/>
           <p:nvPr/>
         </p:nvSpPr>
@@ -7064,7 +7239,7 @@
       </p:sp>
       <p:sp>
         <p:nvSpPr>
-          <p:cNvPr id="26" name="TextBox 25"/>
+          <p:cNvPr id="27" name="TextBox 26"/>
           <p:cNvSpPr txBox="1"/>
           <p:nvPr/>
         </p:nvSpPr>
@@ -7099,7 +7274,7 @@
       </p:sp>
       <p:sp>
         <p:nvSpPr>
-          <p:cNvPr id="27" name="Rectangle 26"/>
+          <p:cNvPr id="28" name="Rectangle 27"/>
           <p:cNvSpPr/>
           <p:nvPr/>
         </p:nvSpPr>
@@ -7142,7 +7317,7 @@
       </p:sp>
       <p:sp>
         <p:nvSpPr>
-          <p:cNvPr id="28" name="TextBox 27"/>
+          <p:cNvPr id="29" name="TextBox 28"/>
           <p:cNvSpPr txBox="1"/>
           <p:nvPr/>
         </p:nvSpPr>
@@ -7177,7 +7352,7 @@
       </p:sp>
       <p:sp>
         <p:nvSpPr>
-          <p:cNvPr id="29" name="TextBox 28"/>
+          <p:cNvPr id="30" name="TextBox 29"/>
           <p:cNvSpPr txBox="1"/>
           <p:nvPr/>
         </p:nvSpPr>
@@ -7221,14 +7396,6 @@
 <file path=ppt/slides/slide6.xml><?xml version="1.0" encoding="utf-8"?>
 <p:sld xmlns:a="http://schemas.openxmlformats.org/drawingml/2006/main" xmlns:p="http://schemas.openxmlformats.org/presentationml/2006/main" xmlns:r="http://schemas.openxmlformats.org/officeDocument/2006/relationships">
   <p:cSld>
-    <p:bg>
-      <p:bgPr>
-        <a:solidFill>
-          <a:srgbClr val="0A0E27"/>
-        </a:solidFill>
-        <a:effectLst/>
-      </p:bgPr>
-    </p:bg>
     <p:spTree>
       <p:nvGrpSpPr>
         <p:cNvPr id="1" name=""/>
@@ -7238,7 +7405,50 @@
       <p:grpSpPr/>
       <p:sp>
         <p:nvSpPr>
-          <p:cNvPr id="2" name="Rounded Rectangle 1"/>
+          <p:cNvPr id="2" name="Rectangle 1"/>
+          <p:cNvSpPr/>
+          <p:nvPr/>
+        </p:nvSpPr>
+        <p:spPr>
+          <a:xfrm>
+            <a:off x="0" y="0"/>
+            <a:ext cx="12191695" cy="6858000"/>
+          </a:xfrm>
+          <a:prstGeom prst="rect">
+            <a:avLst/>
+          </a:prstGeom>
+          <a:solidFill>
+            <a:srgbClr val="0A0E27"/>
+          </a:solidFill>
+          <a:ln>
+            <a:noFill/>
+          </a:ln>
+        </p:spPr>
+        <p:style>
+          <a:lnRef idx="1">
+            <a:schemeClr val="accent1"/>
+          </a:lnRef>
+          <a:fillRef idx="3">
+            <a:schemeClr val="accent1"/>
+          </a:fillRef>
+          <a:effectRef idx="2">
+            <a:schemeClr val="accent1"/>
+          </a:effectRef>
+          <a:fontRef idx="minor">
+            <a:schemeClr val="lt1"/>
+          </a:fontRef>
+        </p:style>
+        <p:txBody>
+          <a:bodyPr rtlCol="0" anchor="ctr"/>
+          <a:lstStyle/>
+          <a:p>
+            <a:pPr algn="ctr"/>
+          </a:p>
+        </p:txBody>
+      </p:sp>
+      <p:sp>
+        <p:nvSpPr>
+          <p:cNvPr id="3" name="Rounded Rectangle 2"/>
           <p:cNvSpPr/>
           <p:nvPr/>
         </p:nvSpPr>
@@ -7285,7 +7495,7 @@
       </p:sp>
       <p:sp>
         <p:nvSpPr>
-          <p:cNvPr id="3" name="TextBox 2"/>
+          <p:cNvPr id="4" name="TextBox 3"/>
           <p:cNvSpPr txBox="1"/>
           <p:nvPr/>
         </p:nvSpPr>
@@ -7320,7 +7530,7 @@
       </p:sp>
       <p:sp>
         <p:nvSpPr>
-          <p:cNvPr id="4" name="TextBox 3"/>
+          <p:cNvPr id="5" name="TextBox 4"/>
           <p:cNvSpPr txBox="1"/>
           <p:nvPr/>
         </p:nvSpPr>
@@ -7355,7 +7565,7 @@
       </p:sp>
       <p:sp>
         <p:nvSpPr>
-          <p:cNvPr id="5" name="TextBox 4"/>
+          <p:cNvPr id="6" name="TextBox 5"/>
           <p:cNvSpPr txBox="1"/>
           <p:nvPr/>
         </p:nvSpPr>
@@ -7390,7 +7600,7 @@
       </p:sp>
       <p:sp>
         <p:nvSpPr>
-          <p:cNvPr id="6" name="Rounded Rectangle 5"/>
+          <p:cNvPr id="7" name="Rounded Rectangle 6"/>
           <p:cNvSpPr/>
           <p:nvPr/>
         </p:nvSpPr>
@@ -7437,7 +7647,7 @@
       </p:sp>
       <p:sp>
         <p:nvSpPr>
-          <p:cNvPr id="7" name="TextBox 6"/>
+          <p:cNvPr id="8" name="TextBox 7"/>
           <p:cNvSpPr txBox="1"/>
           <p:nvPr/>
         </p:nvSpPr>
@@ -7472,7 +7682,7 @@
       </p:sp>
       <p:sp>
         <p:nvSpPr>
-          <p:cNvPr id="8" name="Rectangle 7"/>
+          <p:cNvPr id="9" name="Rectangle 8"/>
           <p:cNvSpPr/>
           <p:nvPr/>
         </p:nvSpPr>
@@ -7515,7 +7725,7 @@
       </p:sp>
       <p:sp>
         <p:nvSpPr>
-          <p:cNvPr id="9" name="Rounded Rectangle 8"/>
+          <p:cNvPr id="10" name="Rounded Rectangle 9"/>
           <p:cNvSpPr/>
           <p:nvPr/>
         </p:nvSpPr>
@@ -7560,7 +7770,7 @@
       </p:sp>
       <p:sp>
         <p:nvSpPr>
-          <p:cNvPr id="10" name="TextBox 9"/>
+          <p:cNvPr id="11" name="TextBox 10"/>
           <p:cNvSpPr txBox="1"/>
           <p:nvPr/>
         </p:nvSpPr>
@@ -7595,7 +7805,7 @@
       </p:sp>
       <p:sp>
         <p:nvSpPr>
-          <p:cNvPr id="11" name="TextBox 10"/>
+          <p:cNvPr id="12" name="TextBox 11"/>
           <p:cNvSpPr txBox="1"/>
           <p:nvPr/>
         </p:nvSpPr>
@@ -7630,7 +7840,7 @@
       </p:sp>
       <p:sp>
         <p:nvSpPr>
-          <p:cNvPr id="12" name="Rounded Rectangle 11"/>
+          <p:cNvPr id="13" name="Rounded Rectangle 12"/>
           <p:cNvSpPr/>
           <p:nvPr/>
         </p:nvSpPr>
@@ -7675,7 +7885,7 @@
       </p:sp>
       <p:sp>
         <p:nvSpPr>
-          <p:cNvPr id="13" name="TextBox 12"/>
+          <p:cNvPr id="14" name="TextBox 13"/>
           <p:cNvSpPr txBox="1"/>
           <p:nvPr/>
         </p:nvSpPr>
@@ -7710,7 +7920,7 @@
       </p:sp>
       <p:sp>
         <p:nvSpPr>
-          <p:cNvPr id="14" name="TextBox 13"/>
+          <p:cNvPr id="15" name="TextBox 14"/>
           <p:cNvSpPr txBox="1"/>
           <p:nvPr/>
         </p:nvSpPr>
@@ -7745,7 +7955,7 @@
       </p:sp>
       <p:sp>
         <p:nvSpPr>
-          <p:cNvPr id="15" name="Rounded Rectangle 14"/>
+          <p:cNvPr id="16" name="Rounded Rectangle 15"/>
           <p:cNvSpPr/>
           <p:nvPr/>
         </p:nvSpPr>
@@ -7790,7 +8000,7 @@
       </p:sp>
       <p:sp>
         <p:nvSpPr>
-          <p:cNvPr id="16" name="TextBox 15"/>
+          <p:cNvPr id="17" name="TextBox 16"/>
           <p:cNvSpPr txBox="1"/>
           <p:nvPr/>
         </p:nvSpPr>
@@ -7825,7 +8035,7 @@
       </p:sp>
       <p:sp>
         <p:nvSpPr>
-          <p:cNvPr id="17" name="TextBox 16"/>
+          <p:cNvPr id="18" name="TextBox 17"/>
           <p:cNvSpPr txBox="1"/>
           <p:nvPr/>
         </p:nvSpPr>
@@ -7860,7 +8070,7 @@
       </p:sp>
       <p:sp>
         <p:nvSpPr>
-          <p:cNvPr id="18" name="Rounded Rectangle 17"/>
+          <p:cNvPr id="19" name="Rounded Rectangle 18"/>
           <p:cNvSpPr/>
           <p:nvPr/>
         </p:nvSpPr>
@@ -7907,7 +8117,7 @@
       </p:sp>
       <p:sp>
         <p:nvSpPr>
-          <p:cNvPr id="19" name="TextBox 18"/>
+          <p:cNvPr id="20" name="TextBox 19"/>
           <p:cNvSpPr txBox="1"/>
           <p:nvPr/>
         </p:nvSpPr>
@@ -7942,7 +8152,7 @@
       </p:sp>
       <p:sp>
         <p:nvSpPr>
-          <p:cNvPr id="20" name="Rectangle 19"/>
+          <p:cNvPr id="21" name="Rectangle 20"/>
           <p:cNvSpPr/>
           <p:nvPr/>
         </p:nvSpPr>
@@ -7985,7 +8195,7 @@
       </p:sp>
       <p:sp>
         <p:nvSpPr>
-          <p:cNvPr id="21" name="Rounded Rectangle 20"/>
+          <p:cNvPr id="22" name="Rounded Rectangle 21"/>
           <p:cNvSpPr/>
           <p:nvPr/>
         </p:nvSpPr>
@@ -8030,7 +8240,7 @@
       </p:sp>
       <p:sp>
         <p:nvSpPr>
-          <p:cNvPr id="22" name="TextBox 21"/>
+          <p:cNvPr id="23" name="TextBox 22"/>
           <p:cNvSpPr txBox="1"/>
           <p:nvPr/>
         </p:nvSpPr>
@@ -8065,7 +8275,7 @@
       </p:sp>
       <p:sp>
         <p:nvSpPr>
-          <p:cNvPr id="23" name="TextBox 22"/>
+          <p:cNvPr id="24" name="TextBox 23"/>
           <p:cNvSpPr txBox="1"/>
           <p:nvPr/>
         </p:nvSpPr>
@@ -8100,7 +8310,7 @@
       </p:sp>
       <p:sp>
         <p:nvSpPr>
-          <p:cNvPr id="24" name="Rounded Rectangle 23"/>
+          <p:cNvPr id="25" name="Rounded Rectangle 24"/>
           <p:cNvSpPr/>
           <p:nvPr/>
         </p:nvSpPr>
@@ -8145,7 +8355,7 @@
       </p:sp>
       <p:sp>
         <p:nvSpPr>
-          <p:cNvPr id="25" name="TextBox 24"/>
+          <p:cNvPr id="26" name="TextBox 25"/>
           <p:cNvSpPr txBox="1"/>
           <p:nvPr/>
         </p:nvSpPr>
@@ -8180,7 +8390,7 @@
       </p:sp>
       <p:sp>
         <p:nvSpPr>
-          <p:cNvPr id="26" name="TextBox 25"/>
+          <p:cNvPr id="27" name="TextBox 26"/>
           <p:cNvSpPr txBox="1"/>
           <p:nvPr/>
         </p:nvSpPr>
@@ -8215,7 +8425,7 @@
       </p:sp>
       <p:sp>
         <p:nvSpPr>
-          <p:cNvPr id="27" name="Rounded Rectangle 26"/>
+          <p:cNvPr id="28" name="Rounded Rectangle 27"/>
           <p:cNvSpPr/>
           <p:nvPr/>
         </p:nvSpPr>
@@ -8260,7 +8470,7 @@
       </p:sp>
       <p:sp>
         <p:nvSpPr>
-          <p:cNvPr id="28" name="TextBox 27"/>
+          <p:cNvPr id="29" name="TextBox 28"/>
           <p:cNvSpPr txBox="1"/>
           <p:nvPr/>
         </p:nvSpPr>
@@ -8295,7 +8505,7 @@
       </p:sp>
       <p:sp>
         <p:nvSpPr>
-          <p:cNvPr id="29" name="TextBox 28"/>
+          <p:cNvPr id="30" name="TextBox 29"/>
           <p:cNvSpPr txBox="1"/>
           <p:nvPr/>
         </p:nvSpPr>
@@ -8330,7 +8540,7 @@
       </p:sp>
       <p:sp>
         <p:nvSpPr>
-          <p:cNvPr id="30" name="Rounded Rectangle 29"/>
+          <p:cNvPr id="31" name="Rounded Rectangle 30"/>
           <p:cNvSpPr/>
           <p:nvPr/>
         </p:nvSpPr>
@@ -8377,7 +8587,7 @@
       </p:sp>
       <p:sp>
         <p:nvSpPr>
-          <p:cNvPr id="31" name="TextBox 30"/>
+          <p:cNvPr id="32" name="TextBox 31"/>
           <p:cNvSpPr txBox="1"/>
           <p:nvPr/>
         </p:nvSpPr>
@@ -8412,7 +8622,7 @@
       </p:sp>
       <p:sp>
         <p:nvSpPr>
-          <p:cNvPr id="32" name="Rectangle 31"/>
+          <p:cNvPr id="33" name="Rectangle 32"/>
           <p:cNvSpPr/>
           <p:nvPr/>
         </p:nvSpPr>
@@ -8455,7 +8665,7 @@
       </p:sp>
       <p:sp>
         <p:nvSpPr>
-          <p:cNvPr id="33" name="Rounded Rectangle 32"/>
+          <p:cNvPr id="34" name="Rounded Rectangle 33"/>
           <p:cNvSpPr/>
           <p:nvPr/>
         </p:nvSpPr>
@@ -8500,7 +8710,7 @@
       </p:sp>
       <p:sp>
         <p:nvSpPr>
-          <p:cNvPr id="34" name="TextBox 33"/>
+          <p:cNvPr id="35" name="TextBox 34"/>
           <p:cNvSpPr txBox="1"/>
           <p:nvPr/>
         </p:nvSpPr>
@@ -8535,7 +8745,7 @@
       </p:sp>
       <p:sp>
         <p:nvSpPr>
-          <p:cNvPr id="35" name="TextBox 34"/>
+          <p:cNvPr id="36" name="TextBox 35"/>
           <p:cNvSpPr txBox="1"/>
           <p:nvPr/>
         </p:nvSpPr>
@@ -8570,7 +8780,7 @@
       </p:sp>
       <p:sp>
         <p:nvSpPr>
-          <p:cNvPr id="36" name="Rounded Rectangle 35"/>
+          <p:cNvPr id="37" name="Rounded Rectangle 36"/>
           <p:cNvSpPr/>
           <p:nvPr/>
         </p:nvSpPr>
@@ -8615,7 +8825,7 @@
       </p:sp>
       <p:sp>
         <p:nvSpPr>
-          <p:cNvPr id="37" name="TextBox 36"/>
+          <p:cNvPr id="38" name="TextBox 37"/>
           <p:cNvSpPr txBox="1"/>
           <p:nvPr/>
         </p:nvSpPr>
@@ -8650,7 +8860,7 @@
       </p:sp>
       <p:sp>
         <p:nvSpPr>
-          <p:cNvPr id="38" name="TextBox 37"/>
+          <p:cNvPr id="39" name="TextBox 38"/>
           <p:cNvSpPr txBox="1"/>
           <p:nvPr/>
         </p:nvSpPr>
@@ -8685,7 +8895,7 @@
       </p:sp>
       <p:sp>
         <p:nvSpPr>
-          <p:cNvPr id="39" name="Rounded Rectangle 38"/>
+          <p:cNvPr id="40" name="Rounded Rectangle 39"/>
           <p:cNvSpPr/>
           <p:nvPr/>
         </p:nvSpPr>
@@ -8730,7 +8940,7 @@
       </p:sp>
       <p:sp>
         <p:nvSpPr>
-          <p:cNvPr id="40" name="TextBox 39"/>
+          <p:cNvPr id="41" name="TextBox 40"/>
           <p:cNvSpPr txBox="1"/>
           <p:nvPr/>
         </p:nvSpPr>
@@ -8765,7 +8975,7 @@
       </p:sp>
       <p:sp>
         <p:nvSpPr>
-          <p:cNvPr id="41" name="TextBox 40"/>
+          <p:cNvPr id="42" name="TextBox 41"/>
           <p:cNvSpPr txBox="1"/>
           <p:nvPr/>
         </p:nvSpPr>
@@ -8800,7 +9010,7 @@
       </p:sp>
       <p:sp>
         <p:nvSpPr>
-          <p:cNvPr id="42" name="TextBox 41"/>
+          <p:cNvPr id="43" name="TextBox 42"/>
           <p:cNvSpPr txBox="1"/>
           <p:nvPr/>
         </p:nvSpPr>
@@ -8835,7 +9045,7 @@
       </p:sp>
       <p:sp>
         <p:nvSpPr>
-          <p:cNvPr id="43" name="TextBox 42"/>
+          <p:cNvPr id="44" name="TextBox 43"/>
           <p:cNvSpPr txBox="1"/>
           <p:nvPr/>
         </p:nvSpPr>
@@ -8879,14 +9089,6 @@
 <file path=ppt/slides/slide7.xml><?xml version="1.0" encoding="utf-8"?>
 <p:sld xmlns:a="http://schemas.openxmlformats.org/drawingml/2006/main" xmlns:p="http://schemas.openxmlformats.org/presentationml/2006/main" xmlns:r="http://schemas.openxmlformats.org/officeDocument/2006/relationships">
   <p:cSld>
-    <p:bg>
-      <p:bgPr>
-        <a:solidFill>
-          <a:srgbClr val="0A0E27"/>
-        </a:solidFill>
-        <a:effectLst/>
-      </p:bgPr>
-    </p:bg>
     <p:spTree>
       <p:nvGrpSpPr>
         <p:cNvPr id="1" name=""/>
@@ -8896,7 +9098,50 @@
       <p:grpSpPr/>
       <p:sp>
         <p:nvSpPr>
-          <p:cNvPr id="2" name="Rounded Rectangle 1"/>
+          <p:cNvPr id="2" name="Rectangle 1"/>
+          <p:cNvSpPr/>
+          <p:nvPr/>
+        </p:nvSpPr>
+        <p:spPr>
+          <a:xfrm>
+            <a:off x="0" y="0"/>
+            <a:ext cx="12191695" cy="6858000"/>
+          </a:xfrm>
+          <a:prstGeom prst="rect">
+            <a:avLst/>
+          </a:prstGeom>
+          <a:solidFill>
+            <a:srgbClr val="0A0E27"/>
+          </a:solidFill>
+          <a:ln>
+            <a:noFill/>
+          </a:ln>
+        </p:spPr>
+        <p:style>
+          <a:lnRef idx="1">
+            <a:schemeClr val="accent1"/>
+          </a:lnRef>
+          <a:fillRef idx="3">
+            <a:schemeClr val="accent1"/>
+          </a:fillRef>
+          <a:effectRef idx="2">
+            <a:schemeClr val="accent1"/>
+          </a:effectRef>
+          <a:fontRef idx="minor">
+            <a:schemeClr val="lt1"/>
+          </a:fontRef>
+        </p:style>
+        <p:txBody>
+          <a:bodyPr rtlCol="0" anchor="ctr"/>
+          <a:lstStyle/>
+          <a:p>
+            <a:pPr algn="ctr"/>
+          </a:p>
+        </p:txBody>
+      </p:sp>
+      <p:sp>
+        <p:nvSpPr>
+          <p:cNvPr id="3" name="Rounded Rectangle 2"/>
           <p:cNvSpPr/>
           <p:nvPr/>
         </p:nvSpPr>
@@ -8943,7 +9188,7 @@
       </p:sp>
       <p:sp>
         <p:nvSpPr>
-          <p:cNvPr id="3" name="TextBox 2"/>
+          <p:cNvPr id="4" name="TextBox 3"/>
           <p:cNvSpPr txBox="1"/>
           <p:nvPr/>
         </p:nvSpPr>
@@ -8978,7 +9223,7 @@
       </p:sp>
       <p:sp>
         <p:nvSpPr>
-          <p:cNvPr id="4" name="TextBox 3"/>
+          <p:cNvPr id="5" name="TextBox 4"/>
           <p:cNvSpPr txBox="1"/>
           <p:nvPr/>
         </p:nvSpPr>
@@ -9013,7 +9258,7 @@
       </p:sp>
       <p:sp>
         <p:nvSpPr>
-          <p:cNvPr id="5" name="Rounded Rectangle 4"/>
+          <p:cNvPr id="6" name="Rounded Rectangle 5"/>
           <p:cNvSpPr/>
           <p:nvPr/>
         </p:nvSpPr>
@@ -9058,7 +9303,7 @@
       </p:sp>
       <p:sp>
         <p:nvSpPr>
-          <p:cNvPr id="6" name="Rounded Rectangle 5"/>
+          <p:cNvPr id="7" name="Rounded Rectangle 6"/>
           <p:cNvSpPr/>
           <p:nvPr/>
         </p:nvSpPr>
@@ -9103,7 +9348,7 @@
       </p:sp>
       <p:sp>
         <p:nvSpPr>
-          <p:cNvPr id="7" name="TextBox 6"/>
+          <p:cNvPr id="8" name="TextBox 7"/>
           <p:cNvSpPr txBox="1"/>
           <p:nvPr/>
         </p:nvSpPr>
@@ -9138,7 +9383,7 @@
       </p:sp>
       <p:sp>
         <p:nvSpPr>
-          <p:cNvPr id="8" name="TextBox 7"/>
+          <p:cNvPr id="9" name="TextBox 8"/>
           <p:cNvSpPr txBox="1"/>
           <p:nvPr/>
         </p:nvSpPr>
@@ -9173,7 +9418,7 @@
       </p:sp>
       <p:sp>
         <p:nvSpPr>
-          <p:cNvPr id="9" name="Rounded Rectangle 8"/>
+          <p:cNvPr id="10" name="Rounded Rectangle 9"/>
           <p:cNvSpPr/>
           <p:nvPr/>
         </p:nvSpPr>
@@ -9218,7 +9463,7 @@
       </p:sp>
       <p:sp>
         <p:nvSpPr>
-          <p:cNvPr id="10" name="Rounded Rectangle 9"/>
+          <p:cNvPr id="11" name="Rounded Rectangle 10"/>
           <p:cNvSpPr/>
           <p:nvPr/>
         </p:nvSpPr>
@@ -9263,7 +9508,7 @@
       </p:sp>
       <p:sp>
         <p:nvSpPr>
-          <p:cNvPr id="11" name="TextBox 10"/>
+          <p:cNvPr id="12" name="TextBox 11"/>
           <p:cNvSpPr txBox="1"/>
           <p:nvPr/>
         </p:nvSpPr>
@@ -9298,7 +9543,7 @@
       </p:sp>
       <p:sp>
         <p:nvSpPr>
-          <p:cNvPr id="12" name="TextBox 11"/>
+          <p:cNvPr id="13" name="TextBox 12"/>
           <p:cNvSpPr txBox="1"/>
           <p:nvPr/>
         </p:nvSpPr>
@@ -9333,7 +9578,7 @@
       </p:sp>
       <p:sp>
         <p:nvSpPr>
-          <p:cNvPr id="13" name="Rounded Rectangle 12"/>
+          <p:cNvPr id="14" name="Rounded Rectangle 13"/>
           <p:cNvSpPr/>
           <p:nvPr/>
         </p:nvSpPr>
@@ -9378,7 +9623,7 @@
       </p:sp>
       <p:sp>
         <p:nvSpPr>
-          <p:cNvPr id="14" name="Rounded Rectangle 13"/>
+          <p:cNvPr id="15" name="Rounded Rectangle 14"/>
           <p:cNvSpPr/>
           <p:nvPr/>
         </p:nvSpPr>
@@ -9423,7 +9668,7 @@
       </p:sp>
       <p:sp>
         <p:nvSpPr>
-          <p:cNvPr id="15" name="TextBox 14"/>
+          <p:cNvPr id="16" name="TextBox 15"/>
           <p:cNvSpPr txBox="1"/>
           <p:nvPr/>
         </p:nvSpPr>
@@ -9458,7 +9703,7 @@
       </p:sp>
       <p:sp>
         <p:nvSpPr>
-          <p:cNvPr id="16" name="Rounded Rectangle 15"/>
+          <p:cNvPr id="17" name="Rounded Rectangle 16"/>
           <p:cNvSpPr/>
           <p:nvPr/>
         </p:nvSpPr>
@@ -9505,7 +9750,7 @@
       </p:sp>
       <p:sp>
         <p:nvSpPr>
-          <p:cNvPr id="17" name="TextBox 16"/>
+          <p:cNvPr id="18" name="TextBox 17"/>
           <p:cNvSpPr txBox="1"/>
           <p:nvPr/>
         </p:nvSpPr>
@@ -9540,7 +9785,7 @@
       </p:sp>
       <p:sp>
         <p:nvSpPr>
-          <p:cNvPr id="18" name="TextBox 17"/>
+          <p:cNvPr id="19" name="TextBox 18"/>
           <p:cNvSpPr txBox="1"/>
           <p:nvPr/>
         </p:nvSpPr>
@@ -9575,7 +9820,7 @@
       </p:sp>
       <p:sp>
         <p:nvSpPr>
-          <p:cNvPr id="19" name="TextBox 18"/>
+          <p:cNvPr id="20" name="TextBox 19"/>
           <p:cNvSpPr txBox="1"/>
           <p:nvPr/>
         </p:nvSpPr>
@@ -9610,7 +9855,7 @@
       </p:sp>
       <p:sp>
         <p:nvSpPr>
-          <p:cNvPr id="20" name="TextBox 19"/>
+          <p:cNvPr id="21" name="TextBox 20"/>
           <p:cNvSpPr txBox="1"/>
           <p:nvPr/>
         </p:nvSpPr>
@@ -9645,7 +9890,7 @@
       </p:sp>
       <p:sp>
         <p:nvSpPr>
-          <p:cNvPr id="21" name="TextBox 20"/>
+          <p:cNvPr id="22" name="TextBox 21"/>
           <p:cNvSpPr txBox="1"/>
           <p:nvPr/>
         </p:nvSpPr>
@@ -9680,7 +9925,7 @@
       </p:sp>
       <p:sp>
         <p:nvSpPr>
-          <p:cNvPr id="22" name="TextBox 21"/>
+          <p:cNvPr id="23" name="TextBox 22"/>
           <p:cNvSpPr txBox="1"/>
           <p:nvPr/>
         </p:nvSpPr>
@@ -9715,7 +9960,7 @@
       </p:sp>
       <p:sp>
         <p:nvSpPr>
-          <p:cNvPr id="23" name="TextBox 22"/>
+          <p:cNvPr id="24" name="TextBox 23"/>
           <p:cNvSpPr txBox="1"/>
           <p:nvPr/>
         </p:nvSpPr>
@@ -9750,7 +9995,7 @@
       </p:sp>
       <p:sp>
         <p:nvSpPr>
-          <p:cNvPr id="24" name="TextBox 23"/>
+          <p:cNvPr id="25" name="TextBox 24"/>
           <p:cNvSpPr txBox="1"/>
           <p:nvPr/>
         </p:nvSpPr>
@@ -9785,7 +10030,7 @@
       </p:sp>
       <p:sp>
         <p:nvSpPr>
-          <p:cNvPr id="25" name="Rounded Rectangle 24"/>
+          <p:cNvPr id="26" name="Rounded Rectangle 25"/>
           <p:cNvSpPr/>
           <p:nvPr/>
         </p:nvSpPr>
@@ -9830,7 +10075,7 @@
       </p:sp>
       <p:sp>
         <p:nvSpPr>
-          <p:cNvPr id="26" name="Rounded Rectangle 25"/>
+          <p:cNvPr id="27" name="Rounded Rectangle 26"/>
           <p:cNvSpPr/>
           <p:nvPr/>
         </p:nvSpPr>
@@ -9875,7 +10120,7 @@
       </p:sp>
       <p:sp>
         <p:nvSpPr>
-          <p:cNvPr id="27" name="TextBox 26"/>
+          <p:cNvPr id="28" name="TextBox 27"/>
           <p:cNvSpPr txBox="1"/>
           <p:nvPr/>
         </p:nvSpPr>
@@ -9910,7 +10155,7 @@
       </p:sp>
       <p:sp>
         <p:nvSpPr>
-          <p:cNvPr id="28" name="Rounded Rectangle 27"/>
+          <p:cNvPr id="29" name="Rounded Rectangle 28"/>
           <p:cNvSpPr/>
           <p:nvPr/>
         </p:nvSpPr>
@@ -9957,7 +10202,7 @@
       </p:sp>
       <p:sp>
         <p:nvSpPr>
-          <p:cNvPr id="29" name="TextBox 28"/>
+          <p:cNvPr id="30" name="TextBox 29"/>
           <p:cNvSpPr txBox="1"/>
           <p:nvPr/>
         </p:nvSpPr>
@@ -9992,7 +10237,7 @@
       </p:sp>
       <p:pic>
         <p:nvPicPr>
-          <p:cNvPr id="30" name="Picture 29" descr="b0f2e749292c.png"/>
+          <p:cNvPr id="31" name="Picture 30" descr="b0f2e749292c.png"/>
           <p:cNvPicPr>
             <a:picLocks noChangeAspect="1"/>
           </p:cNvPicPr>
@@ -10016,7 +10261,7 @@
       </p:pic>
       <p:sp>
         <p:nvSpPr>
-          <p:cNvPr id="31" name="Rounded Rectangle 30"/>
+          <p:cNvPr id="32" name="Rounded Rectangle 31"/>
           <p:cNvSpPr/>
           <p:nvPr/>
         </p:nvSpPr>
@@ -10063,7 +10308,7 @@
       </p:sp>
       <p:sp>
         <p:nvSpPr>
-          <p:cNvPr id="32" name="TextBox 31"/>
+          <p:cNvPr id="33" name="TextBox 32"/>
           <p:cNvSpPr txBox="1"/>
           <p:nvPr/>
         </p:nvSpPr>
@@ -10098,7 +10343,7 @@
       </p:sp>
       <p:sp>
         <p:nvSpPr>
-          <p:cNvPr id="33" name="TextBox 32"/>
+          <p:cNvPr id="34" name="TextBox 33"/>
           <p:cNvSpPr txBox="1"/>
           <p:nvPr/>
         </p:nvSpPr>
@@ -10153,7 +10398,7 @@
       </p:sp>
       <p:sp>
         <p:nvSpPr>
-          <p:cNvPr id="34" name="TextBox 33"/>
+          <p:cNvPr id="35" name="TextBox 34"/>
           <p:cNvSpPr txBox="1"/>
           <p:nvPr/>
         </p:nvSpPr>
@@ -10188,7 +10433,7 @@
       </p:sp>
       <p:sp>
         <p:nvSpPr>
-          <p:cNvPr id="35" name="TextBox 34"/>
+          <p:cNvPr id="36" name="TextBox 35"/>
           <p:cNvSpPr txBox="1"/>
           <p:nvPr/>
         </p:nvSpPr>
@@ -10232,14 +10477,6 @@
 <file path=ppt/slides/slide8.xml><?xml version="1.0" encoding="utf-8"?>
 <p:sld xmlns:a="http://schemas.openxmlformats.org/drawingml/2006/main" xmlns:p="http://schemas.openxmlformats.org/presentationml/2006/main" xmlns:r="http://schemas.openxmlformats.org/officeDocument/2006/relationships">
   <p:cSld>
-    <p:bg>
-      <p:bgPr>
-        <a:solidFill>
-          <a:srgbClr val="0A0E27"/>
-        </a:solidFill>
-        <a:effectLst/>
-      </p:bgPr>
-    </p:bg>
     <p:spTree>
       <p:nvGrpSpPr>
         <p:cNvPr id="1" name=""/>
@@ -10249,7 +10486,50 @@
       <p:grpSpPr/>
       <p:sp>
         <p:nvSpPr>
-          <p:cNvPr id="2" name="Rounded Rectangle 1"/>
+          <p:cNvPr id="2" name="Rectangle 1"/>
+          <p:cNvSpPr/>
+          <p:nvPr/>
+        </p:nvSpPr>
+        <p:spPr>
+          <a:xfrm>
+            <a:off x="0" y="0"/>
+            <a:ext cx="12191695" cy="6858000"/>
+          </a:xfrm>
+          <a:prstGeom prst="rect">
+            <a:avLst/>
+          </a:prstGeom>
+          <a:solidFill>
+            <a:srgbClr val="0A0E27"/>
+          </a:solidFill>
+          <a:ln>
+            <a:noFill/>
+          </a:ln>
+        </p:spPr>
+        <p:style>
+          <a:lnRef idx="1">
+            <a:schemeClr val="accent1"/>
+          </a:lnRef>
+          <a:fillRef idx="3">
+            <a:schemeClr val="accent1"/>
+          </a:fillRef>
+          <a:effectRef idx="2">
+            <a:schemeClr val="accent1"/>
+          </a:effectRef>
+          <a:fontRef idx="minor">
+            <a:schemeClr val="lt1"/>
+          </a:fontRef>
+        </p:style>
+        <p:txBody>
+          <a:bodyPr rtlCol="0" anchor="ctr"/>
+          <a:lstStyle/>
+          <a:p>
+            <a:pPr algn="ctr"/>
+          </a:p>
+        </p:txBody>
+      </p:sp>
+      <p:sp>
+        <p:nvSpPr>
+          <p:cNvPr id="3" name="Rounded Rectangle 2"/>
           <p:cNvSpPr/>
           <p:nvPr/>
         </p:nvSpPr>
@@ -10296,7 +10576,7 @@
       </p:sp>
       <p:sp>
         <p:nvSpPr>
-          <p:cNvPr id="3" name="TextBox 2"/>
+          <p:cNvPr id="4" name="TextBox 3"/>
           <p:cNvSpPr txBox="1"/>
           <p:nvPr/>
         </p:nvSpPr>
@@ -10331,7 +10611,7 @@
       </p:sp>
       <p:sp>
         <p:nvSpPr>
-          <p:cNvPr id="4" name="TextBox 3"/>
+          <p:cNvPr id="5" name="TextBox 4"/>
           <p:cNvSpPr txBox="1"/>
           <p:nvPr/>
         </p:nvSpPr>
@@ -10366,7 +10646,7 @@
       </p:sp>
       <p:sp>
         <p:nvSpPr>
-          <p:cNvPr id="5" name="TextBox 4"/>
+          <p:cNvPr id="6" name="TextBox 5"/>
           <p:cNvSpPr txBox="1"/>
           <p:nvPr/>
         </p:nvSpPr>
@@ -10401,7 +10681,7 @@
       </p:sp>
       <p:sp>
         <p:nvSpPr>
-          <p:cNvPr id="6" name="Rectangle 5"/>
+          <p:cNvPr id="7" name="Rectangle 6"/>
           <p:cNvSpPr/>
           <p:nvPr/>
         </p:nvSpPr>
@@ -10444,7 +10724,7 @@
       </p:sp>
       <p:sp>
         <p:nvSpPr>
-          <p:cNvPr id="7" name="TextBox 6"/>
+          <p:cNvPr id="8" name="TextBox 7"/>
           <p:cNvSpPr txBox="1"/>
           <p:nvPr/>
         </p:nvSpPr>
@@ -10479,7 +10759,7 @@
       </p:sp>
       <p:sp>
         <p:nvSpPr>
-          <p:cNvPr id="8" name="TextBox 7"/>
+          <p:cNvPr id="9" name="TextBox 8"/>
           <p:cNvSpPr txBox="1"/>
           <p:nvPr/>
         </p:nvSpPr>
@@ -10514,7 +10794,7 @@
       </p:sp>
       <p:sp>
         <p:nvSpPr>
-          <p:cNvPr id="9" name="TextBox 8"/>
+          <p:cNvPr id="10" name="TextBox 9"/>
           <p:cNvSpPr txBox="1"/>
           <p:nvPr/>
         </p:nvSpPr>

</xml_diff>

<commit_message>
fix: bento-paper 暖陶土渐变 + badge 间距 + 默认主题 (#14)
* fix: bento-paper 暖陶土渐变 + badge 间距修复 + 默认主题切换

Color palette:
- accent gradient: 棕绿 #8B5E3C→#4a7c6b → 暖陶土 #B8654A→#D4956B
- accent_success: 冷绿 #5C7A5E → 暖橄榄 #7A8B5E（与陶土色调协调）
- accent_warning: 冷橙 #c47d00 → 暖琥珀 #D4952A

Badge spacing (native + SVG):
- ASCII 字宽估算: 7→8px, padding: 18→24px
- 字号: 11→12px, letter-spacing: 50→100 (native) / 0.5→1 (SVG)
- 胶囊高度: 22→24px

Default theme: bento-tech → bento-paper

Co-Authored-By: Claude Opus 4.7 <noreply@anthropic.com>

* fix: match native badge height(24px) and gap(10px) to SVG

---------

Co-authored-by: Claude Opus 4.7 <noreply@anthropic.com>
</commit_message>
<xml_diff>
--- a/examples/dify-intro/deck.pptx
+++ b/examples/dify-intro/deck.pptx
@@ -3340,7 +3340,7 @@
         <p:spPr>
           <a:xfrm>
             <a:off x="914377" y="2686050"/>
-            <a:ext cx="1238219" cy="209550"/>
+            <a:ext cx="1447763" cy="209550"/>
           </a:xfrm>
           <a:prstGeom prst="roundRect">
             <a:avLst>
@@ -3391,7 +3391,7 @@
         <p:spPr>
           <a:xfrm>
             <a:off x="914377" y="2714625"/>
-            <a:ext cx="1238219" cy="171450"/>
+            <a:ext cx="1447763" cy="171450"/>
           </a:xfrm>
           <a:prstGeom prst="rect">
             <a:avLst/>
@@ -3406,7 +3406,7 @@
           <a:p>
             <a:pPr algn="ctr"/>
             <a:r>
-              <a:rPr sz="825" b="1" i="0" spc="50">
+              <a:rPr sz="900" b="1" i="0" spc="100">
                 <a:solidFill>
                   <a:srgbClr val="FFFFFF"/>
                 </a:solidFill>
@@ -5601,7 +5601,7 @@
           <a:noFill/>
         </p:spPr>
         <p:txBody>
-          <a:bodyPr wrap="none" lIns="0" rIns="0" tIns="0" bIns="0">
+          <a:bodyPr wrap="square" lIns="0" rIns="0" tIns="0" bIns="0">
             <a:spAutoFit/>
           </a:bodyPr>
           <a:lstStyle/>
@@ -5835,7 +5835,7 @@
           <a:noFill/>
         </p:spPr>
         <p:txBody>
-          <a:bodyPr wrap="none" lIns="0" rIns="0" tIns="0" bIns="0">
+          <a:bodyPr wrap="square" lIns="0" rIns="0" tIns="0" bIns="0">
             <a:spAutoFit/>
           </a:bodyPr>
           <a:lstStyle/>
@@ -6069,7 +6069,7 @@
           <a:noFill/>
         </p:spPr>
         <p:txBody>
-          <a:bodyPr wrap="none" lIns="0" rIns="0" tIns="0" bIns="0">
+          <a:bodyPr wrap="square" lIns="0" rIns="0" tIns="0" bIns="0">
             <a:spAutoFit/>
           </a:bodyPr>
           <a:lstStyle/>
@@ -6678,7 +6678,7 @@
           <a:noFill/>
         </p:spPr>
         <p:txBody>
-          <a:bodyPr wrap="none" lIns="0" rIns="0" tIns="0" bIns="0">
+          <a:bodyPr wrap="square" lIns="0" rIns="0" tIns="0" bIns="0">
             <a:spAutoFit/>
           </a:bodyPr>
           <a:lstStyle/>
@@ -6877,7 +6877,7 @@
           <a:noFill/>
         </p:spPr>
         <p:txBody>
-          <a:bodyPr wrap="none" lIns="0" rIns="0" tIns="0" bIns="0">
+          <a:bodyPr wrap="square" lIns="0" rIns="0" tIns="0" bIns="0">
             <a:spAutoFit/>
           </a:bodyPr>
           <a:lstStyle/>
@@ -7076,7 +7076,7 @@
           <a:noFill/>
         </p:spPr>
         <p:txBody>
-          <a:bodyPr wrap="none" lIns="0" rIns="0" tIns="0" bIns="0">
+          <a:bodyPr wrap="square" lIns="0" rIns="0" tIns="0" bIns="0">
             <a:spAutoFit/>
           </a:bodyPr>
           <a:lstStyle/>
@@ -7275,7 +7275,7 @@
           <a:noFill/>
         </p:spPr>
         <p:txBody>
-          <a:bodyPr wrap="none" lIns="0" rIns="0" tIns="0" bIns="0">
+          <a:bodyPr wrap="square" lIns="0" rIns="0" tIns="0" bIns="0">
             <a:spAutoFit/>
           </a:bodyPr>
           <a:lstStyle/>
@@ -10327,33 +10327,95 @@
           </a:p>
         </p:txBody>
       </p:sp>
-      <p:pic>
-        <p:nvPicPr>
-          <p:cNvPr id="31" name="Picture 30" descr="b0f2e749292c.png"/>
-          <p:cNvPicPr>
-            <a:picLocks noChangeAspect="1"/>
-          </p:cNvPicPr>
-          <p:nvPr/>
-        </p:nvPicPr>
-        <p:blipFill>
-          <a:blip r:embed="rId2"/>
-          <a:stretch>
-            <a:fillRect/>
-          </a:stretch>
-        </p:blipFill>
+      <p:sp>
+        <p:nvSpPr>
+          <p:cNvPr id="31" name="Rounded Rectangle 30"/>
+          <p:cNvSpPr/>
+          <p:nvPr/>
+        </p:nvSpPr>
         <p:spPr>
           <a:xfrm>
             <a:off x="914377" y="4114800"/>
             <a:ext cx="2781230" cy="1466850"/>
           </a:xfrm>
-          <a:prstGeom prst="rect">
-            <a:avLst/>
-          </a:prstGeom>
-        </p:spPr>
-      </p:pic>
-      <p:sp>
-        <p:nvSpPr>
-          <p:cNvPr id="32" name="Rounded Rectangle 31"/>
+          <a:prstGeom prst="roundRect">
+            <a:avLst>
+              <a:gd name="adj" fmla="val 5000"/>
+            </a:avLst>
+          </a:prstGeom>
+          <a:solidFill>
+            <a:srgbClr val="7C5CFF">
+              <a:alpha val="10000"/>
+            </a:srgbClr>
+          </a:solidFill>
+          <a:ln w="12700">
+            <a:solidFill>
+              <a:srgbClr val="7C5CFF">
+                <a:alpha val="40000"/>
+              </a:srgbClr>
+            </a:solidFill>
+          </a:ln>
+        </p:spPr>
+        <p:style>
+          <a:lnRef idx="1">
+            <a:schemeClr val="accent1"/>
+          </a:lnRef>
+          <a:fillRef idx="3">
+            <a:schemeClr val="accent1"/>
+          </a:fillRef>
+          <a:effectRef idx="2">
+            <a:schemeClr val="accent1"/>
+          </a:effectRef>
+          <a:fontRef idx="minor">
+            <a:schemeClr val="lt1"/>
+          </a:fontRef>
+        </p:style>
+        <p:txBody>
+          <a:bodyPr rtlCol="0" anchor="ctr"/>
+          <a:lstStyle/>
+          <a:p>
+            <a:pPr algn="ctr"/>
+          </a:p>
+        </p:txBody>
+      </p:sp>
+      <p:sp>
+        <p:nvSpPr>
+          <p:cNvPr id="32" name="TextBox 31"/>
+          <p:cNvSpPr txBox="1"/>
+          <p:nvPr/>
+        </p:nvSpPr>
+        <p:spPr>
+          <a:xfrm>
+            <a:off x="914377" y="4733925"/>
+            <a:ext cx="2781230" cy="228600"/>
+          </a:xfrm>
+          <a:prstGeom prst="rect">
+            <a:avLst/>
+          </a:prstGeom>
+          <a:noFill/>
+        </p:spPr>
+        <p:txBody>
+          <a:bodyPr wrap="square" lIns="0" rIns="0" tIns="0" bIns="0">
+            <a:spAutoFit/>
+          </a:bodyPr>
+          <a:lstStyle/>
+          <a:p>
+            <a:pPr algn="ctr"/>
+            <a:r>
+              <a:rPr sz="1050" b="0" i="0">
+                <a:solidFill>
+                  <a:srgbClr val="BCC4D8"/>
+                </a:solidFill>
+                <a:latin typeface="PingFang SC"/>
+              </a:rPr>
+              <a:t>Workflow 编排画布概念图</a:t>
+            </a:r>
+          </a:p>
+        </p:txBody>
+      </p:sp>
+      <p:sp>
+        <p:nvSpPr>
+          <p:cNvPr id="33" name="Rounded Rectangle 32"/>
           <p:cNvSpPr/>
           <p:nvPr/>
         </p:nvSpPr>
@@ -10404,7 +10466,7 @@
       </p:sp>
       <p:sp>
         <p:nvSpPr>
-          <p:cNvPr id="33" name="TextBox 32"/>
+          <p:cNvPr id="34" name="TextBox 33"/>
           <p:cNvSpPr txBox="1"/>
           <p:nvPr/>
         </p:nvSpPr>
@@ -10439,7 +10501,7 @@
       </p:sp>
       <p:sp>
         <p:nvSpPr>
-          <p:cNvPr id="34" name="TextBox 33"/>
+          <p:cNvPr id="35" name="TextBox 34"/>
           <p:cNvSpPr txBox="1"/>
           <p:nvPr/>
         </p:nvSpPr>
@@ -10494,7 +10556,7 @@
       </p:sp>
       <p:sp>
         <p:nvSpPr>
-          <p:cNvPr id="35" name="TextBox 34"/>
+          <p:cNvPr id="36" name="TextBox 35"/>
           <p:cNvSpPr txBox="1"/>
           <p:nvPr/>
         </p:nvSpPr>
@@ -10529,7 +10591,7 @@
       </p:sp>
       <p:sp>
         <p:nvSpPr>
-          <p:cNvPr id="36" name="TextBox 35"/>
+          <p:cNvPr id="37" name="TextBox 36"/>
           <p:cNvSpPr txBox="1"/>
           <p:nvPr/>
         </p:nvSpPr>

</xml_diff>

<commit_message>
fix: native PPTX renderer 渐变背景 — bg_start→bg_end 线性渐变
Native renderer 之前只填充纯色 bg_start，与 SVG/HTML 预览的渐变
背景视觉效果差距明显。现通过 lxml 直接写 OOXML <a:gradFill> 实现
对角线渐变背景，与 SVG 输出视觉一致。

Co-Authored-By: Claude Opus 4.7 <noreply@anthropic.com>
</commit_message>
<xml_diff>
--- a/examples/dify-intro/deck.pptx
+++ b/examples/dify-intro/deck.pptx
@@ -3109,12 +3109,20 @@
           <a:prstGeom prst="rect">
             <a:avLst/>
           </a:prstGeom>
-          <a:solidFill>
-            <a:srgbClr val="0A0E27"/>
-          </a:solidFill>
           <a:ln>
             <a:noFill/>
           </a:ln>
+          <a:gradFill>
+            <a:gsLst>
+              <a:gs pos="0">
+                <a:srgbClr val="0a0e27"/>
+              </a:gs>
+              <a:gs pos="100000">
+                <a:srgbClr val="1a1f3a"/>
+              </a:gs>
+            </a:gsLst>
+            <a:lin ang="5400000" scaled="1"/>
+          </a:gradFill>
         </p:spPr>
         <p:style>
           <a:lnRef idx="1">
@@ -3340,7 +3348,7 @@
         <p:spPr>
           <a:xfrm>
             <a:off x="914377" y="2686050"/>
-            <a:ext cx="1447763" cy="209550"/>
+            <a:ext cx="1447763" cy="228600"/>
           </a:xfrm>
           <a:prstGeom prst="roundRect">
             <a:avLst>
@@ -3807,12 +3815,20 @@
           <a:prstGeom prst="rect">
             <a:avLst/>
           </a:prstGeom>
-          <a:solidFill>
-            <a:srgbClr val="0A0E27"/>
-          </a:solidFill>
           <a:ln>
             <a:noFill/>
           </a:ln>
+          <a:gradFill>
+            <a:gsLst>
+              <a:gs pos="0">
+                <a:srgbClr val="0a0e27"/>
+              </a:gs>
+              <a:gs pos="100000">
+                <a:srgbClr val="1a1f3a"/>
+              </a:gs>
+            </a:gsLst>
+            <a:lin ang="5400000" scaled="1"/>
+          </a:gradFill>
         </p:spPr>
         <p:style>
           <a:lnRef idx="1">
@@ -4476,12 +4492,20 @@
           <a:prstGeom prst="rect">
             <a:avLst/>
           </a:prstGeom>
-          <a:solidFill>
-            <a:srgbClr val="0A0E27"/>
-          </a:solidFill>
           <a:ln>
             <a:noFill/>
           </a:ln>
+          <a:gradFill>
+            <a:gsLst>
+              <a:gs pos="0">
+                <a:srgbClr val="0a0e27"/>
+              </a:gs>
+              <a:gs pos="100000">
+                <a:srgbClr val="1a1f3a"/>
+              </a:gs>
+            </a:gsLst>
+            <a:lin ang="5400000" scaled="1"/>
+          </a:gradFill>
         </p:spPr>
         <p:style>
           <a:lnRef idx="1">
@@ -5469,12 +5493,20 @@
           <a:prstGeom prst="rect">
             <a:avLst/>
           </a:prstGeom>
-          <a:solidFill>
-            <a:srgbClr val="0A0E27"/>
-          </a:solidFill>
           <a:ln>
             <a:noFill/>
           </a:ln>
+          <a:gradFill>
+            <a:gsLst>
+              <a:gs pos="0">
+                <a:srgbClr val="0a0e27"/>
+              </a:gs>
+              <a:gs pos="100000">
+                <a:srgbClr val="1a1f3a"/>
+              </a:gs>
+            </a:gsLst>
+            <a:lin ang="5400000" scaled="1"/>
+          </a:gradFill>
         </p:spPr>
         <p:style>
           <a:lnRef idx="1">
@@ -6302,12 +6334,20 @@
           <a:prstGeom prst="rect">
             <a:avLst/>
           </a:prstGeom>
-          <a:solidFill>
-            <a:srgbClr val="0A0E27"/>
-          </a:solidFill>
           <a:ln>
             <a:noFill/>
           </a:ln>
+          <a:gradFill>
+            <a:gsLst>
+              <a:gs pos="0">
+                <a:srgbClr val="0a0e27"/>
+              </a:gs>
+              <a:gs pos="100000">
+                <a:srgbClr val="1a1f3a"/>
+              </a:gs>
+            </a:gsLst>
+            <a:lin ang="5400000" scaled="1"/>
+          </a:gradFill>
         </p:spPr>
         <p:style>
           <a:lnRef idx="1">
@@ -7473,12 +7513,20 @@
           <a:prstGeom prst="rect">
             <a:avLst/>
           </a:prstGeom>
-          <a:solidFill>
-            <a:srgbClr val="0A0E27"/>
-          </a:solidFill>
           <a:ln>
             <a:noFill/>
           </a:ln>
+          <a:gradFill>
+            <a:gsLst>
+              <a:gs pos="0">
+                <a:srgbClr val="0a0e27"/>
+              </a:gs>
+              <a:gs pos="100000">
+                <a:srgbClr val="1a1f3a"/>
+              </a:gs>
+            </a:gsLst>
+            <a:lin ang="5400000" scaled="1"/>
+          </a:gradFill>
         </p:spPr>
         <p:style>
           <a:lnRef idx="1">
@@ -9182,12 +9230,20 @@
           <a:prstGeom prst="rect">
             <a:avLst/>
           </a:prstGeom>
-          <a:solidFill>
-            <a:srgbClr val="0A0E27"/>
-          </a:solidFill>
           <a:ln>
             <a:noFill/>
           </a:ln>
+          <a:gradFill>
+            <a:gsLst>
+              <a:gs pos="0">
+                <a:srgbClr val="0a0e27"/>
+              </a:gs>
+              <a:gs pos="100000">
+                <a:srgbClr val="1a1f3a"/>
+              </a:gs>
+            </a:gsLst>
+            <a:lin ang="5400000" scaled="1"/>
+          </a:gradFill>
         </p:spPr>
         <p:style>
           <a:lnRef idx="1">
@@ -10656,12 +10712,20 @@
           <a:prstGeom prst="rect">
             <a:avLst/>
           </a:prstGeom>
-          <a:solidFill>
-            <a:srgbClr val="0A0E27"/>
-          </a:solidFill>
           <a:ln>
             <a:noFill/>
           </a:ln>
+          <a:gradFill>
+            <a:gsLst>
+              <a:gs pos="0">
+                <a:srgbClr val="0a0e27"/>
+              </a:gs>
+              <a:gs pos="100000">
+                <a:srgbClr val="1a1f3a"/>
+              </a:gs>
+            </a:gsLst>
+            <a:lin ang="5400000" scaled="1"/>
+          </a:gradFill>
         </p:spPr>
         <p:style>
           <a:lnRef idx="1">

</xml_diff>

<commit_message>
fix: stat 单位换行 + quote 字体 + card-stack 间距 + 硬编码字体消除
- stat 窄卡: 单位换行时不增加 y 偏移，紧贴 value 下方左对齐
- card-quote: 横幅和大卡模式都使用 theme.fonts.display (serif)
- card-stack: 窄卡 (H<240) sec_gap/sec_label_gap 16→20
- 消除硬编码: font_name→theme.fonts.sans/mono/display (3处)
- render.py docstring: bento-tech→bento-paper

Co-Authored-By: Claude Opus 4.7 <noreply@anthropic.com>
</commit_message>
<xml_diff>
--- a/examples/dify-intro/deck.pptx
+++ b/examples/dify-intro/deck.pptx
@@ -3222,7 +3222,7 @@
             <a:pPr algn="r"/>
             <a:r>
               <a:rPr sz="11925" b="1" i="0" spc="600">
-                <a:latin typeface="PingFang SC"/>
+                <a:latin typeface="'Noto Sans SC', 'PingFang SC', 'Microsoft YaHei', sans-serif"/>
                 <a:solidFill>
                   <a:srgbClr val="B8654A">
                     <a:alpha val="6999"/>
@@ -3262,7 +3262,7 @@
                 <a:solidFill>
                   <a:srgbClr val="D4956B"/>
                 </a:solidFill>
-                <a:latin typeface="PingFang SC"/>
+                <a:latin typeface="'Noto Sans SC', 'PingFang SC', 'Microsoft YaHei', sans-serif"/>
               </a:rPr>
               <a:t>PRODUCT INTRO · 2026 Q2</a:t>
             </a:r>
@@ -3297,7 +3297,7 @@
                 <a:solidFill>
                   <a:srgbClr val="1A1815"/>
                 </a:solidFill>
-                <a:latin typeface="PingFang SC"/>
+                <a:latin typeface="'Noto Sans SC', 'PingFang SC', 'Microsoft YaHei', sans-serif"/>
               </a:rPr>
               <a:t>Dify 企业介绍</a:t>
             </a:r>
@@ -3332,7 +3332,7 @@
                 <a:solidFill>
                   <a:srgbClr val="1A1815"/>
                 </a:solidFill>
-                <a:latin typeface="PingFang SC"/>
+                <a:latin typeface="'Noto Sans SC', 'PingFang SC', 'Microsoft YaHei', sans-serif"/>
               </a:rPr>
               <a:t>下一代 AI 应用开发平台</a:t>
             </a:r>
@@ -3418,7 +3418,7 @@
                 <a:solidFill>
                   <a:srgbClr val="FFFFFF"/>
                 </a:solidFill>
-                <a:latin typeface="PingFang SC"/>
+                <a:latin typeface="'Noto Sans SC', 'PingFang SC', 'Microsoft YaHei', sans-serif"/>
               </a:rPr>
               <a:t>PRODUCTION-READY</a:t>
             </a:r>
@@ -3453,7 +3453,7 @@
                 <a:solidFill>
                   <a:srgbClr val="5C5548"/>
                 </a:solidFill>
-                <a:latin typeface="PingFang SC"/>
+                <a:latin typeface="'Noto Sans SC', 'PingFang SC', 'Microsoft YaHei', sans-serif"/>
               </a:rPr>
               <a:t>把生成式 AI 的不确定，变成产品落地的确定</a:t>
             </a:r>
@@ -3531,7 +3531,7 @@
                 <a:solidFill>
                   <a:srgbClr val="9C9588"/>
                 </a:solidFill>
-                <a:latin typeface="PingFang SC"/>
+                <a:latin typeface="'Noto Sans SC', 'PingFang SC', 'Microsoft YaHei', sans-serif"/>
               </a:rPr>
               <a:t>PRESENTED BY</a:t>
             </a:r>
@@ -3566,7 +3566,7 @@
                 <a:solidFill>
                   <a:srgbClr val="1A1815"/>
                 </a:solidFill>
-                <a:latin typeface="PingFang SC"/>
+                <a:latin typeface="'Noto Sans SC', 'PingFang SC', 'Microsoft YaHei', sans-serif"/>
               </a:rPr>
               <a:t>Dify Team</a:t>
             </a:r>
@@ -3601,7 +3601,7 @@
                 <a:solidFill>
                   <a:srgbClr val="9C9588"/>
                 </a:solidFill>
-                <a:latin typeface="PingFang SC"/>
+                <a:latin typeface="'Noto Sans SC', 'PingFang SC', 'Microsoft YaHei', sans-serif"/>
               </a:rPr>
               <a:t>DATE</a:t>
             </a:r>
@@ -3636,7 +3636,7 @@
                 <a:solidFill>
                   <a:srgbClr val="1A1815"/>
                 </a:solidFill>
-                <a:latin typeface="PingFang SC"/>
+                <a:latin typeface="'Noto Sans SC', 'PingFang SC', 'Microsoft YaHei', sans-serif"/>
               </a:rPr>
               <a:t>2026 Q2</a:t>
             </a:r>
@@ -3671,7 +3671,7 @@
                 <a:solidFill>
                   <a:srgbClr val="9C9588"/>
                 </a:solidFill>
-                <a:latin typeface="PingFang SC"/>
+                <a:latin typeface="'Noto Sans SC', 'PingFang SC', 'Microsoft YaHei', sans-serif"/>
               </a:rPr>
               <a:t>AUDIENCE</a:t>
             </a:r>
@@ -3706,7 +3706,7 @@
                 <a:solidFill>
                   <a:srgbClr val="1A1815"/>
                 </a:solidFill>
-                <a:latin typeface="PingFang SC"/>
+                <a:latin typeface="'Noto Sans SC', 'PingFang SC', 'Microsoft YaHei', sans-serif"/>
               </a:rPr>
               <a:t>企业客户 / 投资人</a:t>
             </a:r>
@@ -3741,7 +3741,7 @@
                 <a:solidFill>
                   <a:srgbClr val="9C9588"/>
                 </a:solidFill>
-                <a:latin typeface="PingFang SC"/>
+                <a:latin typeface="'Noto Sans SC', 'PingFang SC', 'Microsoft YaHei', sans-serif"/>
               </a:rPr>
               <a:t>Dify 企业介绍</a:t>
             </a:r>
@@ -3776,7 +3776,7 @@
                 <a:solidFill>
                   <a:srgbClr val="9C9588"/>
                 </a:solidFill>
-                <a:latin typeface="SF Mono"/>
+                <a:latin typeface="'IBM Plex Mono', 'SF Mono', 'JetBrains Mono', Menlo, monospace"/>
               </a:rPr>
               <a:t>01 / 08</a:t>
             </a:r>
@@ -3931,7 +3931,7 @@
                 <a:solidFill>
                   <a:srgbClr val="D4956B"/>
                 </a:solidFill>
-                <a:latin typeface="PingFang SC"/>
+                <a:latin typeface="'Noto Sans SC', 'PingFang SC', 'Microsoft YaHei', sans-serif"/>
               </a:rPr>
               <a:t>全球开发者</a:t>
             </a:r>
@@ -3966,7 +3966,7 @@
                 <a:solidFill>
                   <a:srgbClr val="1A1815"/>
                 </a:solidFill>
-                <a:latin typeface="PingFang SC"/>
+                <a:latin typeface="'Noto Sans SC', 'PingFang SC', 'Microsoft YaHei', sans-serif"/>
               </a:rPr>
               <a:t>180</a:t>
             </a:r>
@@ -4001,7 +4001,7 @@
                 <a:solidFill>
                   <a:srgbClr val="5C5548"/>
                 </a:solidFill>
-                <a:latin typeface="PingFang SC"/>
+                <a:latin typeface="'Noto Sans SC', 'PingFang SC', 'Microsoft YaHei', sans-serif"/>
               </a:rPr>
               <a:t>万+</a:t>
             </a:r>
@@ -4036,7 +4036,7 @@
                 <a:solidFill>
                   <a:srgbClr val="7A8B5E"/>
                 </a:solidFill>
-                <a:latin typeface="PingFang SC"/>
+                <a:latin typeface="'Noto Sans SC', 'PingFang SC', 'Microsoft YaHei', sans-serif"/>
               </a:rPr>
               <a:t>↑ 180% YoY</a:t>
             </a:r>
@@ -4114,7 +4114,7 @@
                 <a:solidFill>
                   <a:srgbClr val="5C5548"/>
                 </a:solidFill>
-                <a:latin typeface="PingFang SC"/>
+                <a:latin typeface="'Noto Sans SC', 'PingFang SC', 'Microsoft YaHei', sans-serif"/>
               </a:rPr>
               <a:t>覆盖 130+ 个国家与地区</a:t>
             </a:r>
@@ -4200,7 +4200,7 @@
                 <a:solidFill>
                   <a:srgbClr val="D4956B"/>
                 </a:solidFill>
-                <a:latin typeface="PingFang SC"/>
+                <a:latin typeface="'Noto Sans SC', 'PingFang SC', 'Microsoft YaHei', sans-serif"/>
               </a:rPr>
               <a:t>企业客户</a:t>
             </a:r>
@@ -4235,7 +4235,7 @@
                 <a:solidFill>
                   <a:srgbClr val="1A1815"/>
                 </a:solidFill>
-                <a:latin typeface="PingFang SC"/>
+                <a:latin typeface="'Noto Sans SC', 'PingFang SC', 'Microsoft YaHei', sans-serif"/>
               </a:rPr>
               <a:t>12000</a:t>
             </a:r>
@@ -4270,7 +4270,7 @@
                 <a:solidFill>
                   <a:srgbClr val="5C5548"/>
                 </a:solidFill>
-                <a:latin typeface="PingFang SC"/>
+                <a:latin typeface="'Noto Sans SC', 'PingFang SC', 'Microsoft YaHei', sans-serif"/>
               </a:rPr>
               <a:t>+</a:t>
             </a:r>
@@ -4305,7 +4305,7 @@
                 <a:solidFill>
                   <a:srgbClr val="7A8B5E"/>
                 </a:solidFill>
-                <a:latin typeface="PingFang SC"/>
+                <a:latin typeface="'Noto Sans SC', 'PingFang SC', 'Microsoft YaHei', sans-serif"/>
               </a:rPr>
               <a:t>↑ Fortune 500 中的 23 家</a:t>
             </a:r>
@@ -4383,7 +4383,7 @@
                 <a:solidFill>
                   <a:srgbClr val="5C5548"/>
                 </a:solidFill>
-                <a:latin typeface="PingFang SC"/>
+                <a:latin typeface="'Noto Sans SC', 'PingFang SC', 'Microsoft YaHei', sans-serif"/>
               </a:rPr>
               <a:t>金融、零售、教育、政务皆有落地</a:t>
             </a:r>
@@ -4418,7 +4418,7 @@
                 <a:solidFill>
                   <a:srgbClr val="9C9588"/>
                 </a:solidFill>
-                <a:latin typeface="PingFang SC"/>
+                <a:latin typeface="'Noto Sans SC', 'PingFang SC', 'Microsoft YaHei', sans-serif"/>
               </a:rPr>
               <a:t>Dify 企业介绍</a:t>
             </a:r>
@@ -4453,7 +4453,7 @@
                 <a:solidFill>
                   <a:srgbClr val="9C9588"/>
                 </a:solidFill>
-                <a:latin typeface="SF Mono"/>
+                <a:latin typeface="'IBM Plex Mono', 'SF Mono', 'JetBrains Mono', Menlo, monospace"/>
               </a:rPr>
               <a:t>02 / 08</a:t>
             </a:r>
@@ -4608,7 +4608,7 @@
                 <a:solidFill>
                   <a:srgbClr val="D4956B"/>
                 </a:solidFill>
-                <a:latin typeface="PingFang SC"/>
+                <a:latin typeface="'Noto Sans SC', 'PingFang SC', 'Microsoft YaHei', sans-serif"/>
               </a:rPr>
               <a:t>为什么选择 Dify</a:t>
             </a:r>
@@ -4643,7 +4643,7 @@
                 <a:solidFill>
                   <a:srgbClr val="1A1815"/>
                 </a:solidFill>
-                <a:latin typeface="PingFang SC"/>
+                <a:latin typeface="'Noto Sans SC', 'PingFang SC', 'Microsoft YaHei', sans-serif"/>
               </a:rPr>
               <a:t>把模型能力和业务流程缝起来</a:t>
             </a:r>
@@ -4682,7 +4682,7 @@
                 <a:solidFill>
                   <a:srgbClr val="5C5548"/>
                 </a:solidFill>
-                <a:latin typeface="PingFang SC"/>
+                <a:latin typeface="'Noto Sans SC', 'PingFang SC', 'Microsoft YaHei', sans-serif"/>
               </a:rPr>
               <a:t>Dify 不是又一个聊天机器人，而是把 LLM 能力变成稳定可交付的业务流程。从 prompt 编排到工具调用、从知识库到日志评测，全链路可观测、可回滚。</a:t>
             </a:r>
@@ -4698,7 +4698,7 @@
                 <a:solidFill>
                   <a:srgbClr val="5C5548"/>
                 </a:solidFill>
-                <a:latin typeface="PingFang SC"/>
+                <a:latin typeface="'Noto Sans SC', 'PingFang SC', 'Microsoft YaHei', sans-serif"/>
               </a:rPr>
               <a:t>工程团队不需要重复造轮子。市场团队不需要等着 IT 排期。运维团队不需要担心 token 失控。</a:t>
             </a:r>
@@ -4784,7 +4784,7 @@
                 <a:solidFill>
                   <a:srgbClr val="1A1815"/>
                 </a:solidFill>
-                <a:latin typeface="PingFang SC"/>
+                <a:latin typeface="'Noto Sans SC', 'PingFang SC', 'Microsoft YaHei', sans-serif"/>
               </a:rPr>
               <a:t>核心模块</a:t>
             </a:r>
@@ -4864,7 +4864,7 @@
                 <a:solidFill>
                   <a:srgbClr val="FFFFFF"/>
                 </a:solidFill>
-                <a:latin typeface="PingFang SC"/>
+                <a:latin typeface="'Noto Sans SC', 'PingFang SC', 'Microsoft YaHei', sans-serif"/>
               </a:rPr>
               <a:t>01</a:t>
             </a:r>
@@ -4899,7 +4899,7 @@
                 <a:solidFill>
                   <a:srgbClr val="1A1815"/>
                 </a:solidFill>
-                <a:latin typeface="PingFang SC"/>
+                <a:latin typeface="'Noto Sans SC', 'PingFang SC', 'Microsoft YaHei', sans-serif"/>
               </a:rPr>
               <a:t>Workflow</a:t>
             </a:r>
@@ -4934,7 +4934,7 @@
                 <a:solidFill>
                   <a:srgbClr val="5C5548"/>
                 </a:solidFill>
-                <a:latin typeface="PingFang SC"/>
+                <a:latin typeface="'Noto Sans SC', 'PingFang SC', 'Microsoft YaHei', sans-serif"/>
               </a:rPr>
               <a:t>可视化编排</a:t>
             </a:r>
@@ -5014,7 +5014,7 @@
                 <a:solidFill>
                   <a:srgbClr val="FFFFFF"/>
                 </a:solidFill>
-                <a:latin typeface="PingFang SC"/>
+                <a:latin typeface="'Noto Sans SC', 'PingFang SC', 'Microsoft YaHei', sans-serif"/>
               </a:rPr>
               <a:t>02</a:t>
             </a:r>
@@ -5049,7 +5049,7 @@
                 <a:solidFill>
                   <a:srgbClr val="1A1815"/>
                 </a:solidFill>
-                <a:latin typeface="PingFang SC"/>
+                <a:latin typeface="'Noto Sans SC', 'PingFang SC', 'Microsoft YaHei', sans-serif"/>
               </a:rPr>
               <a:t>Agent</a:t>
             </a:r>
@@ -5084,7 +5084,7 @@
                 <a:solidFill>
                   <a:srgbClr val="5C5548"/>
                 </a:solidFill>
-                <a:latin typeface="PingFang SC"/>
+                <a:latin typeface="'Noto Sans SC', 'PingFang SC', 'Microsoft YaHei', sans-serif"/>
               </a:rPr>
               <a:t>工具调用框架</a:t>
             </a:r>
@@ -5164,7 +5164,7 @@
                 <a:solidFill>
                   <a:srgbClr val="FFFFFF"/>
                 </a:solidFill>
-                <a:latin typeface="PingFang SC"/>
+                <a:latin typeface="'Noto Sans SC', 'PingFang SC', 'Microsoft YaHei', sans-serif"/>
               </a:rPr>
               <a:t>03</a:t>
             </a:r>
@@ -5199,7 +5199,7 @@
                 <a:solidFill>
                   <a:srgbClr val="1A1815"/>
                 </a:solidFill>
-                <a:latin typeface="PingFang SC"/>
+                <a:latin typeface="'Noto Sans SC', 'PingFang SC', 'Microsoft YaHei', sans-serif"/>
               </a:rPr>
               <a:t>Knowledge</a:t>
             </a:r>
@@ -5234,7 +5234,7 @@
                 <a:solidFill>
                   <a:srgbClr val="5C5548"/>
                 </a:solidFill>
-                <a:latin typeface="PingFang SC"/>
+                <a:latin typeface="'Noto Sans SC', 'PingFang SC', 'Microsoft YaHei', sans-serif"/>
               </a:rPr>
               <a:t>RAG 引擎</a:t>
             </a:r>
@@ -5314,7 +5314,7 @@
                 <a:solidFill>
                   <a:srgbClr val="FFFFFF"/>
                 </a:solidFill>
-                <a:latin typeface="PingFang SC"/>
+                <a:latin typeface="'Noto Sans SC', 'PingFang SC', 'Microsoft YaHei', sans-serif"/>
               </a:rPr>
               <a:t>04</a:t>
             </a:r>
@@ -5349,7 +5349,7 @@
                 <a:solidFill>
                   <a:srgbClr val="1A1815"/>
                 </a:solidFill>
-                <a:latin typeface="PingFang SC"/>
+                <a:latin typeface="'Noto Sans SC', 'PingFang SC', 'Microsoft YaHei', sans-serif"/>
               </a:rPr>
               <a:t>LLMOps</a:t>
             </a:r>
@@ -5384,7 +5384,7 @@
                 <a:solidFill>
                   <a:srgbClr val="5C5548"/>
                 </a:solidFill>
-                <a:latin typeface="PingFang SC"/>
+                <a:latin typeface="'Noto Sans SC', 'PingFang SC', 'Microsoft YaHei', sans-serif"/>
               </a:rPr>
               <a:t>评测与监控</a:t>
             </a:r>
@@ -5419,7 +5419,7 @@
                 <a:solidFill>
                   <a:srgbClr val="9C9588"/>
                 </a:solidFill>
-                <a:latin typeface="PingFang SC"/>
+                <a:latin typeface="'Noto Sans SC', 'PingFang SC', 'Microsoft YaHei', sans-serif"/>
               </a:rPr>
               <a:t>Dify 企业介绍</a:t>
             </a:r>
@@ -5454,7 +5454,7 @@
                 <a:solidFill>
                   <a:srgbClr val="9C9588"/>
                 </a:solidFill>
-                <a:latin typeface="SF Mono"/>
+                <a:latin typeface="'IBM Plex Mono', 'SF Mono', 'JetBrains Mono', Menlo, monospace"/>
               </a:rPr>
               <a:t>03 / 08</a:t>
             </a:r>
@@ -5609,7 +5609,7 @@
                 <a:solidFill>
                   <a:srgbClr val="D4956B"/>
                 </a:solidFill>
-                <a:latin typeface="PingFang SC"/>
+                <a:latin typeface="'Noto Sans SC', 'PingFang SC', 'Microsoft YaHei', sans-serif"/>
               </a:rPr>
               <a:t>搭建一个 AI 应用</a:t>
             </a:r>
@@ -5644,7 +5644,7 @@
                 <a:solidFill>
                   <a:srgbClr val="1A1815"/>
                 </a:solidFill>
-                <a:latin typeface="PingFang SC"/>
+                <a:latin typeface="'Noto Sans SC', 'PingFang SC', 'Microsoft YaHei', sans-serif"/>
               </a:rPr>
               <a:t>5</a:t>
             </a:r>
@@ -5679,7 +5679,7 @@
                 <a:solidFill>
                   <a:srgbClr val="5C5548"/>
                 </a:solidFill>
-                <a:latin typeface="PingFang SC"/>
+                <a:latin typeface="'Noto Sans SC', 'PingFang SC', 'Microsoft YaHei', sans-serif"/>
               </a:rPr>
               <a:t>分钟</a:t>
             </a:r>
@@ -5757,7 +5757,7 @@
                 <a:solidFill>
                   <a:srgbClr val="5C5548"/>
                 </a:solidFill>
-                <a:latin typeface="PingFang SC"/>
+                <a:latin typeface="'Noto Sans SC', 'PingFang SC', 'Microsoft YaHei', sans-serif"/>
               </a:rPr>
               <a:t>从模板到上线</a:t>
             </a:r>
@@ -5843,7 +5843,7 @@
                 <a:solidFill>
                   <a:srgbClr val="D4956B"/>
                 </a:solidFill>
-                <a:latin typeface="PingFang SC"/>
+                <a:latin typeface="'Noto Sans SC', 'PingFang SC', 'Microsoft YaHei', sans-serif"/>
               </a:rPr>
               <a:t>支持模型数</a:t>
             </a:r>
@@ -5878,7 +5878,7 @@
                 <a:solidFill>
                   <a:srgbClr val="1A1815"/>
                 </a:solidFill>
-                <a:latin typeface="PingFang SC"/>
+                <a:latin typeface="'Noto Sans SC', 'PingFang SC', 'Microsoft YaHei', sans-serif"/>
               </a:rPr>
               <a:t>200</a:t>
             </a:r>
@@ -5913,7 +5913,7 @@
                 <a:solidFill>
                   <a:srgbClr val="5C5548"/>
                 </a:solidFill>
-                <a:latin typeface="PingFang SC"/>
+                <a:latin typeface="'Noto Sans SC', 'PingFang SC', 'Microsoft YaHei', sans-serif"/>
               </a:rPr>
               <a:t>+</a:t>
             </a:r>
@@ -5991,7 +5991,7 @@
                 <a:solidFill>
                   <a:srgbClr val="5C5548"/>
                 </a:solidFill>
-                <a:latin typeface="PingFang SC"/>
+                <a:latin typeface="'Noto Sans SC', 'PingFang SC', 'Microsoft YaHei', sans-serif"/>
               </a:rPr>
               <a:t>OpenAI / Anthropic / 国产</a:t>
             </a:r>
@@ -6077,7 +6077,7 @@
                 <a:solidFill>
                   <a:srgbClr val="D4956B"/>
                 </a:solidFill>
-                <a:latin typeface="PingFang SC"/>
+                <a:latin typeface="'Noto Sans SC', 'PingFang SC', 'Microsoft YaHei', sans-serif"/>
               </a:rPr>
               <a:t>可观测性</a:t>
             </a:r>
@@ -6112,7 +6112,7 @@
                 <a:solidFill>
                   <a:srgbClr val="1A1815"/>
                 </a:solidFill>
-                <a:latin typeface="PingFang SC"/>
+                <a:latin typeface="'Noto Sans SC', 'PingFang SC', 'Microsoft YaHei', sans-serif"/>
               </a:rPr>
               <a:t>100</a:t>
             </a:r>
@@ -6147,7 +6147,7 @@
                 <a:solidFill>
                   <a:srgbClr val="5C5548"/>
                 </a:solidFill>
-                <a:latin typeface="PingFang SC"/>
+                <a:latin typeface="'Noto Sans SC', 'PingFang SC', 'Microsoft YaHei', sans-serif"/>
               </a:rPr>
               <a:t>%</a:t>
             </a:r>
@@ -6225,7 +6225,7 @@
                 <a:solidFill>
                   <a:srgbClr val="5C5548"/>
                 </a:solidFill>
-                <a:latin typeface="PingFang SC"/>
+                <a:latin typeface="'Noto Sans SC', 'PingFang SC', 'Microsoft YaHei', sans-serif"/>
               </a:rPr>
               <a:t>全链路日志与评测</a:t>
             </a:r>
@@ -6260,7 +6260,7 @@
                 <a:solidFill>
                   <a:srgbClr val="9C9588"/>
                 </a:solidFill>
-                <a:latin typeface="PingFang SC"/>
+                <a:latin typeface="'Noto Sans SC', 'PingFang SC', 'Microsoft YaHei', sans-serif"/>
               </a:rPr>
               <a:t>Dify 企业介绍</a:t>
             </a:r>
@@ -6295,7 +6295,7 @@
                 <a:solidFill>
                   <a:srgbClr val="9C9588"/>
                 </a:solidFill>
-                <a:latin typeface="SF Mono"/>
+                <a:latin typeface="'IBM Plex Mono', 'SF Mono', 'JetBrains Mono', Menlo, monospace"/>
               </a:rPr>
               <a:t>04 / 08</a:t>
             </a:r>
@@ -6495,7 +6495,7 @@
                 <a:solidFill>
                   <a:srgbClr val="1A1815"/>
                 </a:solidFill>
-                <a:latin typeface="PingFang SC"/>
+                <a:latin typeface="'Noto Serif SC', 'Playfair Display', 'Times New Roman', serif"/>
               </a:rPr>
               <a:t>AI 应用的瓶颈不是模型，而是工程化。</a:t>
             </a:r>
@@ -6573,7 +6573,7 @@
                 <a:solidFill>
                   <a:srgbClr val="1A1815"/>
                 </a:solidFill>
-                <a:latin typeface="PingFang SC"/>
+                <a:latin typeface="'Noto Sans SC', 'PingFang SC', 'Microsoft YaHei', sans-serif"/>
               </a:rPr>
               <a:t>Dify 创始团队</a:t>
             </a:r>
@@ -6608,7 +6608,7 @@
                 <a:solidFill>
                   <a:srgbClr val="9C9588"/>
                 </a:solidFill>
-                <a:latin typeface="PingFang SC"/>
+                <a:latin typeface="'Noto Sans SC', 'PingFang SC', 'Microsoft YaHei', sans-serif"/>
               </a:rPr>
               <a:t>2024 年技术分享会</a:t>
             </a:r>
@@ -6694,7 +6694,7 @@
                 <a:solidFill>
                   <a:srgbClr val="D4956B"/>
                 </a:solidFill>
-                <a:latin typeface="PingFang SC"/>
+                <a:latin typeface="'Noto Sans SC', 'PingFang SC', 'Microsoft YaHei', sans-serif"/>
               </a:rPr>
               <a:t>模型延迟</a:t>
             </a:r>
@@ -6729,7 +6729,7 @@
                 <a:solidFill>
                   <a:srgbClr val="1A1815"/>
                 </a:solidFill>
-                <a:latin typeface="PingFang SC"/>
+                <a:latin typeface="'Noto Sans SC', 'PingFang SC', 'Microsoft YaHei', sans-serif"/>
               </a:rPr>
               <a:t>&lt;200</a:t>
             </a:r>
@@ -6744,7 +6744,7 @@
         </p:nvSpPr>
         <p:spPr>
           <a:xfrm>
-            <a:off x="914377" y="2000250"/>
+            <a:off x="914377" y="1800225"/>
             <a:ext cx="1447763" cy="219075"/>
           </a:xfrm>
           <a:prstGeom prst="rect">
@@ -6764,7 +6764,7 @@
                 <a:solidFill>
                   <a:srgbClr val="5C5548"/>
                 </a:solidFill>
-                <a:latin typeface="PingFang SC"/>
+                <a:latin typeface="'Noto Sans SC', 'PingFang SC', 'Microsoft YaHei', sans-serif"/>
               </a:rPr>
               <a:t>ms</a:t>
             </a:r>
@@ -6779,7 +6779,7 @@
         </p:nvSpPr>
         <p:spPr>
           <a:xfrm>
-            <a:off x="914377" y="2390775"/>
+            <a:off x="914377" y="2209800"/>
             <a:ext cx="571485" cy="28575"/>
           </a:xfrm>
           <a:prstGeom prst="rect">
@@ -6893,7 +6893,7 @@
                 <a:solidFill>
                   <a:srgbClr val="D4956B"/>
                 </a:solidFill>
-                <a:latin typeface="PingFang SC"/>
+                <a:latin typeface="'Noto Sans SC', 'PingFang SC', 'Microsoft YaHei', sans-serif"/>
               </a:rPr>
               <a:t>成本下降</a:t>
             </a:r>
@@ -6928,7 +6928,7 @@
                 <a:solidFill>
                   <a:srgbClr val="1A1815"/>
                 </a:solidFill>
-                <a:latin typeface="PingFang SC"/>
+                <a:latin typeface="'Noto Sans SC', 'PingFang SC', 'Microsoft YaHei', sans-serif"/>
               </a:rPr>
               <a:t>60</a:t>
             </a:r>
@@ -6963,7 +6963,7 @@
                 <a:solidFill>
                   <a:srgbClr val="5C5548"/>
                 </a:solidFill>
-                <a:latin typeface="PingFang SC"/>
+                <a:latin typeface="'Noto Sans SC', 'PingFang SC', 'Microsoft YaHei', sans-serif"/>
               </a:rPr>
               <a:t>%</a:t>
             </a:r>
@@ -7092,7 +7092,7 @@
                 <a:solidFill>
                   <a:srgbClr val="D4956B"/>
                 </a:solidFill>
-                <a:latin typeface="PingFang SC"/>
+                <a:latin typeface="'Noto Sans SC', 'PingFang SC', 'Microsoft YaHei', sans-serif"/>
               </a:rPr>
               <a:t>上线周期</a:t>
             </a:r>
@@ -7127,7 +7127,7 @@
                 <a:solidFill>
                   <a:srgbClr val="1A1815"/>
                 </a:solidFill>
-                <a:latin typeface="PingFang SC"/>
+                <a:latin typeface="'Noto Sans SC', 'PingFang SC', 'Microsoft YaHei', sans-serif"/>
               </a:rPr>
               <a:t>1/10</a:t>
             </a:r>
@@ -7205,7 +7205,7 @@
                 <a:solidFill>
                   <a:srgbClr val="5C5548"/>
                 </a:solidFill>
-                <a:latin typeface="PingFang SC"/>
+                <a:latin typeface="'Noto Sans SC', 'PingFang SC', 'Microsoft YaHei', sans-serif"/>
               </a:rPr>
               <a:t>对比传统开发</a:t>
             </a:r>
@@ -7291,7 +7291,7 @@
                 <a:solidFill>
                   <a:srgbClr val="D4956B"/>
                 </a:solidFill>
-                <a:latin typeface="PingFang SC"/>
+                <a:latin typeface="'Noto Sans SC', 'PingFang SC', 'Microsoft YaHei', sans-serif"/>
               </a:rPr>
               <a:t>客户留存</a:t>
             </a:r>
@@ -7326,7 +7326,7 @@
                 <a:solidFill>
                   <a:srgbClr val="1A1815"/>
                 </a:solidFill>
-                <a:latin typeface="PingFang SC"/>
+                <a:latin typeface="'Noto Sans SC', 'PingFang SC', 'Microsoft YaHei', sans-serif"/>
               </a:rPr>
               <a:t>94</a:t>
             </a:r>
@@ -7361,7 +7361,7 @@
                 <a:solidFill>
                   <a:srgbClr val="5C5548"/>
                 </a:solidFill>
-                <a:latin typeface="PingFang SC"/>
+                <a:latin typeface="'Noto Sans SC', 'PingFang SC', 'Microsoft YaHei', sans-serif"/>
               </a:rPr>
               <a:t>%</a:t>
             </a:r>
@@ -7439,7 +7439,7 @@
                 <a:solidFill>
                   <a:srgbClr val="9C9588"/>
                 </a:solidFill>
-                <a:latin typeface="PingFang SC"/>
+                <a:latin typeface="'Noto Sans SC', 'PingFang SC', 'Microsoft YaHei', sans-serif"/>
               </a:rPr>
               <a:t>Dify 企业介绍</a:t>
             </a:r>
@@ -7474,7 +7474,7 @@
                 <a:solidFill>
                   <a:srgbClr val="9C9588"/>
                 </a:solidFill>
-                <a:latin typeface="SF Mono"/>
+                <a:latin typeface="'IBM Plex Mono', 'SF Mono', 'JetBrains Mono', Menlo, monospace"/>
               </a:rPr>
               <a:t>05 / 08</a:t>
             </a:r>
@@ -7629,7 +7629,7 @@
                 <a:solidFill>
                   <a:srgbClr val="D4956B"/>
                 </a:solidFill>
-                <a:latin typeface="PingFang SC"/>
+                <a:latin typeface="'Noto Sans SC', 'PingFang SC', 'Microsoft YaHei', sans-serif"/>
               </a:rPr>
               <a:t>ARCHITECTURE</a:t>
             </a:r>
@@ -7664,7 +7664,7 @@
                 <a:solidFill>
                   <a:srgbClr val="1A1815"/>
                 </a:solidFill>
-                <a:latin typeface="PingFang SC"/>
+                <a:latin typeface="'Noto Sans SC', 'PingFang SC', 'Microsoft YaHei', sans-serif"/>
               </a:rPr>
               <a:t>分层架构：从数据层到编排层</a:t>
             </a:r>
@@ -7699,7 +7699,7 @@
                 <a:solidFill>
                   <a:srgbClr val="5C5548"/>
                 </a:solidFill>
-                <a:latin typeface="PingFang SC"/>
+                <a:latin typeface="'Noto Sans SC', 'PingFang SC', 'Microsoft YaHei', sans-serif"/>
               </a:rPr>
               <a:t>每一层都可独立替换，整体可观测</a:t>
             </a:r>
@@ -7785,7 +7785,7 @@
                 <a:solidFill>
                   <a:srgbClr val="1A1815"/>
                 </a:solidFill>
-                <a:latin typeface="PingFang SC"/>
+                <a:latin typeface="'Noto Sans SC', 'PingFang SC', 'Microsoft YaHei', sans-serif"/>
               </a:rPr>
               <a:t>数据层</a:t>
             </a:r>
@@ -7908,7 +7908,7 @@
                 <a:solidFill>
                   <a:srgbClr val="FFFFFF"/>
                 </a:solidFill>
-                <a:latin typeface="PingFang SC"/>
+                <a:latin typeface="'Noto Sans SC', 'PingFang SC', 'Microsoft YaHei', sans-serif"/>
               </a:rPr>
               <a:t>01</a:t>
             </a:r>
@@ -7943,7 +7943,7 @@
                 <a:solidFill>
                   <a:srgbClr val="1A1815"/>
                 </a:solidFill>
-                <a:latin typeface="PingFang SC"/>
+                <a:latin typeface="'Noto Sans SC', 'PingFang SC', 'Microsoft YaHei', sans-serif"/>
               </a:rPr>
               <a:t>向量库</a:t>
             </a:r>
@@ -8023,7 +8023,7 @@
                 <a:solidFill>
                   <a:srgbClr val="FFFFFF"/>
                 </a:solidFill>
-                <a:latin typeface="PingFang SC"/>
+                <a:latin typeface="'Noto Sans SC', 'PingFang SC', 'Microsoft YaHei', sans-serif"/>
               </a:rPr>
               <a:t>02</a:t>
             </a:r>
@@ -8058,7 +8058,7 @@
                 <a:solidFill>
                   <a:srgbClr val="5C5548"/>
                 </a:solidFill>
-                <a:latin typeface="PingFang SC"/>
+                <a:latin typeface="'Noto Sans SC', 'PingFang SC', 'Microsoft YaHei', sans-serif"/>
               </a:rPr>
               <a:t>对象存储</a:t>
             </a:r>
@@ -8138,7 +8138,7 @@
                 <a:solidFill>
                   <a:srgbClr val="FFFFFF"/>
                 </a:solidFill>
-                <a:latin typeface="PingFang SC"/>
+                <a:latin typeface="'Noto Sans SC', 'PingFang SC', 'Microsoft YaHei', sans-serif"/>
               </a:rPr>
               <a:t>03</a:t>
             </a:r>
@@ -8173,7 +8173,7 @@
                 <a:solidFill>
                   <a:srgbClr val="5C5548"/>
                 </a:solidFill>
-                <a:latin typeface="PingFang SC"/>
+                <a:latin typeface="'Noto Sans SC', 'PingFang SC', 'Microsoft YaHei', sans-serif"/>
               </a:rPr>
               <a:t>审计日志</a:t>
             </a:r>
@@ -8259,7 +8259,7 @@
                 <a:solidFill>
                   <a:srgbClr val="1A1815"/>
                 </a:solidFill>
-                <a:latin typeface="PingFang SC"/>
+                <a:latin typeface="'Noto Sans SC', 'PingFang SC', 'Microsoft YaHei', sans-serif"/>
               </a:rPr>
               <a:t>能力层</a:t>
             </a:r>
@@ -8382,7 +8382,7 @@
                 <a:solidFill>
                   <a:srgbClr val="FFFFFF"/>
                 </a:solidFill>
-                <a:latin typeface="PingFang SC"/>
+                <a:latin typeface="'Noto Sans SC', 'PingFang SC', 'Microsoft YaHei', sans-serif"/>
               </a:rPr>
               <a:t>01</a:t>
             </a:r>
@@ -8417,7 +8417,7 @@
                 <a:solidFill>
                   <a:srgbClr val="1A1815"/>
                 </a:solidFill>
-                <a:latin typeface="PingFang SC"/>
+                <a:latin typeface="'Noto Sans SC', 'PingFang SC', 'Microsoft YaHei', sans-serif"/>
               </a:rPr>
               <a:t>模型路由</a:t>
             </a:r>
@@ -8497,7 +8497,7 @@
                 <a:solidFill>
                   <a:srgbClr val="FFFFFF"/>
                 </a:solidFill>
-                <a:latin typeface="PingFang SC"/>
+                <a:latin typeface="'Noto Sans SC', 'PingFang SC', 'Microsoft YaHei', sans-serif"/>
               </a:rPr>
               <a:t>02</a:t>
             </a:r>
@@ -8532,7 +8532,7 @@
                 <a:solidFill>
                   <a:srgbClr val="5C5548"/>
                 </a:solidFill>
-                <a:latin typeface="PingFang SC"/>
+                <a:latin typeface="'Noto Sans SC', 'PingFang SC', 'Microsoft YaHei', sans-serif"/>
               </a:rPr>
               <a:t>工具调用</a:t>
             </a:r>
@@ -8612,7 +8612,7 @@
                 <a:solidFill>
                   <a:srgbClr val="FFFFFF"/>
                 </a:solidFill>
-                <a:latin typeface="PingFang SC"/>
+                <a:latin typeface="'Noto Sans SC', 'PingFang SC', 'Microsoft YaHei', sans-serif"/>
               </a:rPr>
               <a:t>03</a:t>
             </a:r>
@@ -8647,7 +8647,7 @@
                 <a:solidFill>
                   <a:srgbClr val="5C5548"/>
                 </a:solidFill>
-                <a:latin typeface="PingFang SC"/>
+                <a:latin typeface="'Noto Sans SC', 'PingFang SC', 'Microsoft YaHei', sans-serif"/>
               </a:rPr>
               <a:t>知识检索</a:t>
             </a:r>
@@ -8733,7 +8733,7 @@
                 <a:solidFill>
                   <a:srgbClr val="1A1815"/>
                 </a:solidFill>
-                <a:latin typeface="PingFang SC"/>
+                <a:latin typeface="'Noto Sans SC', 'PingFang SC', 'Microsoft YaHei', sans-serif"/>
               </a:rPr>
               <a:t>编排层</a:t>
             </a:r>
@@ -8856,7 +8856,7 @@
                 <a:solidFill>
                   <a:srgbClr val="FFFFFF"/>
                 </a:solidFill>
-                <a:latin typeface="PingFang SC"/>
+                <a:latin typeface="'Noto Sans SC', 'PingFang SC', 'Microsoft YaHei', sans-serif"/>
               </a:rPr>
               <a:t>01</a:t>
             </a:r>
@@ -8891,7 +8891,7 @@
                 <a:solidFill>
                   <a:srgbClr val="1A1815"/>
                 </a:solidFill>
-                <a:latin typeface="PingFang SC"/>
+                <a:latin typeface="'Noto Sans SC', 'PingFang SC', 'Microsoft YaHei', sans-serif"/>
               </a:rPr>
               <a:t>Workflow</a:t>
             </a:r>
@@ -8971,7 +8971,7 @@
                 <a:solidFill>
                   <a:srgbClr val="FFFFFF"/>
                 </a:solidFill>
-                <a:latin typeface="PingFang SC"/>
+                <a:latin typeface="'Noto Sans SC', 'PingFang SC', 'Microsoft YaHei', sans-serif"/>
               </a:rPr>
               <a:t>02</a:t>
             </a:r>
@@ -9006,7 +9006,7 @@
                 <a:solidFill>
                   <a:srgbClr val="5C5548"/>
                 </a:solidFill>
-                <a:latin typeface="PingFang SC"/>
+                <a:latin typeface="'Noto Sans SC', 'PingFang SC', 'Microsoft YaHei', sans-serif"/>
               </a:rPr>
               <a:t>Agent</a:t>
             </a:r>
@@ -9086,7 +9086,7 @@
                 <a:solidFill>
                   <a:srgbClr val="FFFFFF"/>
                 </a:solidFill>
-                <a:latin typeface="PingFang SC"/>
+                <a:latin typeface="'Noto Sans SC', 'PingFang SC', 'Microsoft YaHei', sans-serif"/>
               </a:rPr>
               <a:t>03</a:t>
             </a:r>
@@ -9121,7 +9121,7 @@
                 <a:solidFill>
                   <a:srgbClr val="5C5548"/>
                 </a:solidFill>
-                <a:latin typeface="PingFang SC"/>
+                <a:latin typeface="'Noto Sans SC', 'PingFang SC', 'Microsoft YaHei', sans-serif"/>
               </a:rPr>
               <a:t>Chat 流</a:t>
             </a:r>
@@ -9156,7 +9156,7 @@
                 <a:solidFill>
                   <a:srgbClr val="9C9588"/>
                 </a:solidFill>
-                <a:latin typeface="PingFang SC"/>
+                <a:latin typeface="'Noto Sans SC', 'PingFang SC', 'Microsoft YaHei', sans-serif"/>
               </a:rPr>
               <a:t>Dify 企业介绍</a:t>
             </a:r>
@@ -9191,7 +9191,7 @@
                 <a:solidFill>
                   <a:srgbClr val="9C9588"/>
                 </a:solidFill>
-                <a:latin typeface="SF Mono"/>
+                <a:latin typeface="'IBM Plex Mono', 'SF Mono', 'JetBrains Mono', Menlo, monospace"/>
               </a:rPr>
               <a:t>06 / 08</a:t>
             </a:r>
@@ -9346,7 +9346,7 @@
                 <a:solidFill>
                   <a:srgbClr val="D4956B"/>
                 </a:solidFill>
-                <a:latin typeface="PingFang SC"/>
+                <a:latin typeface="'Noto Sans SC', 'PingFang SC', 'Microsoft YaHei', sans-serif"/>
               </a:rPr>
               <a:t>模型调用量月环比</a:t>
             </a:r>
@@ -9381,7 +9381,7 @@
                 <a:solidFill>
                   <a:srgbClr val="1A1815"/>
                 </a:solidFill>
-                <a:latin typeface="PingFang SC"/>
+                <a:latin typeface="'Noto Sans SC', 'PingFang SC', 'Microsoft YaHei', sans-serif"/>
               </a:rPr>
               <a:t>GPT-4</a:t>
             </a:r>
@@ -9508,7 +9508,7 @@
                 <a:solidFill>
                   <a:srgbClr val="1A1815"/>
                 </a:solidFill>
-                <a:latin typeface="PingFang SC"/>
+                <a:latin typeface="'Noto Sans SC', 'PingFang SC', 'Microsoft YaHei', sans-serif"/>
               </a:rPr>
               <a:t>42 亿</a:t>
             </a:r>
@@ -9543,7 +9543,7 @@
                 <a:solidFill>
                   <a:srgbClr val="1A1815"/>
                 </a:solidFill>
-                <a:latin typeface="PingFang SC"/>
+                <a:latin typeface="'Noto Sans SC', 'PingFang SC', 'Microsoft YaHei', sans-serif"/>
               </a:rPr>
               <a:t>Claude</a:t>
             </a:r>
@@ -9670,7 +9670,7 @@
                 <a:solidFill>
                   <a:srgbClr val="1A1815"/>
                 </a:solidFill>
-                <a:latin typeface="PingFang SC"/>
+                <a:latin typeface="'Noto Sans SC', 'PingFang SC', 'Microsoft YaHei', sans-serif"/>
               </a:rPr>
               <a:t>31 亿</a:t>
             </a:r>
@@ -9705,7 +9705,7 @@
                 <a:solidFill>
                   <a:srgbClr val="1A1815"/>
                 </a:solidFill>
-                <a:latin typeface="PingFang SC"/>
+                <a:latin typeface="'Noto Sans SC', 'PingFang SC', 'Microsoft YaHei', sans-serif"/>
               </a:rPr>
               <a:t>Gemini</a:t>
             </a:r>
@@ -9832,7 +9832,7 @@
                 <a:solidFill>
                   <a:srgbClr val="1A1815"/>
                 </a:solidFill>
-                <a:latin typeface="PingFang SC"/>
+                <a:latin typeface="'Noto Sans SC', 'PingFang SC', 'Microsoft YaHei', sans-serif"/>
               </a:rPr>
               <a:t>18 亿</a:t>
             </a:r>
@@ -9918,7 +9918,7 @@
                 <a:solidFill>
                   <a:srgbClr val="D4956B"/>
                 </a:solidFill>
-                <a:latin typeface="PingFang SC"/>
+                <a:latin typeface="'Noto Sans SC', 'PingFang SC', 'Microsoft YaHei', sans-serif"/>
               </a:rPr>
               <a:t>运行指标</a:t>
             </a:r>
@@ -9933,7 +9933,7 @@
         </p:nvSpPr>
         <p:spPr>
           <a:xfrm>
-            <a:off x="8496087" y="1257300"/>
+            <a:off x="8496087" y="1228725"/>
             <a:ext cx="2781230" cy="542925"/>
           </a:xfrm>
           <a:prstGeom prst="rect">
@@ -9953,7 +9953,7 @@
                 <a:solidFill>
                   <a:srgbClr val="1A1815"/>
                 </a:solidFill>
-                <a:latin typeface="PingFang SC"/>
+                <a:latin typeface="'Noto Sans SC', 'PingFang SC', 'Microsoft YaHei', sans-serif"/>
               </a:rPr>
               <a:t>187</a:t>
             </a:r>
@@ -9968,7 +9968,7 @@
         </p:nvSpPr>
         <p:spPr>
           <a:xfrm>
-            <a:off x="9315216" y="1562100"/>
+            <a:off x="9315216" y="1533525"/>
             <a:ext cx="371465" cy="180975"/>
           </a:xfrm>
           <a:prstGeom prst="rect">
@@ -9988,7 +9988,7 @@
                 <a:solidFill>
                   <a:srgbClr val="D4956B"/>
                 </a:solidFill>
-                <a:latin typeface="PingFang SC"/>
+                <a:latin typeface="'Noto Sans SC', 'PingFang SC', 'Microsoft YaHei', sans-serif"/>
               </a:rPr>
               <a:t>ms</a:t>
             </a:r>
@@ -10003,7 +10003,7 @@
         </p:nvSpPr>
         <p:spPr>
           <a:xfrm>
-            <a:off x="9581910" y="1533525"/>
+            <a:off x="9581910" y="1504950"/>
             <a:ext cx="1600159" cy="219075"/>
           </a:xfrm>
           <a:prstGeom prst="rect">
@@ -10023,7 +10023,7 @@
                 <a:solidFill>
                   <a:srgbClr val="5C5548"/>
                 </a:solidFill>
-                <a:latin typeface="PingFang SC"/>
+                <a:latin typeface="'Noto Sans SC', 'PingFang SC', 'Microsoft YaHei', sans-serif"/>
               </a:rPr>
               <a:t>API 平均响应</a:t>
             </a:r>
@@ -10038,7 +10038,7 @@
         </p:nvSpPr>
         <p:spPr>
           <a:xfrm>
-            <a:off x="8496087" y="1752600"/>
+            <a:off x="8496087" y="1762125"/>
             <a:ext cx="1390615" cy="171450"/>
           </a:xfrm>
           <a:prstGeom prst="rect">
@@ -10058,7 +10058,7 @@
                 <a:solidFill>
                   <a:srgbClr val="9C9588"/>
                 </a:solidFill>
-                <a:latin typeface="PingFang SC"/>
+                <a:latin typeface="'Noto Sans SC', 'PingFang SC', 'Microsoft YaHei', sans-serif"/>
               </a:rPr>
               <a:t>99 分位</a:t>
             </a:r>
@@ -10073,7 +10073,7 @@
         </p:nvSpPr>
         <p:spPr>
           <a:xfrm>
-            <a:off x="8496087" y="1866900"/>
+            <a:off x="8496087" y="1895475"/>
             <a:ext cx="1390615" cy="238125"/>
           </a:xfrm>
           <a:prstGeom prst="rect">
@@ -10093,7 +10093,7 @@
                 <a:solidFill>
                   <a:srgbClr val="1A1815"/>
                 </a:solidFill>
-                <a:latin typeface="PingFang SC"/>
+                <a:latin typeface="'Noto Sans SC', 'PingFang SC', 'Microsoft YaHei', sans-serif"/>
               </a:rPr>
               <a:t>420 ms</a:t>
             </a:r>
@@ -10108,7 +10108,7 @@
         </p:nvSpPr>
         <p:spPr>
           <a:xfrm>
-            <a:off x="9886702" y="1752600"/>
+            <a:off x="9886702" y="1762125"/>
             <a:ext cx="1390615" cy="171450"/>
           </a:xfrm>
           <a:prstGeom prst="rect">
@@ -10128,7 +10128,7 @@
                 <a:solidFill>
                   <a:srgbClr val="9C9588"/>
                 </a:solidFill>
-                <a:latin typeface="PingFang SC"/>
+                <a:latin typeface="'Noto Sans SC', 'PingFang SC', 'Microsoft YaHei', sans-serif"/>
               </a:rPr>
               <a:t>错误率</a:t>
             </a:r>
@@ -10143,7 +10143,7 @@
         </p:nvSpPr>
         <p:spPr>
           <a:xfrm>
-            <a:off x="9886702" y="1866900"/>
+            <a:off x="9886702" y="1895475"/>
             <a:ext cx="1390615" cy="238125"/>
           </a:xfrm>
           <a:prstGeom prst="rect">
@@ -10163,7 +10163,7 @@
                 <a:solidFill>
                   <a:srgbClr val="1A1815"/>
                 </a:solidFill>
-                <a:latin typeface="PingFang SC"/>
+                <a:latin typeface="'Noto Sans SC', 'PingFang SC', 'Microsoft YaHei', sans-serif"/>
               </a:rPr>
               <a:t>0.03%</a:t>
             </a:r>
@@ -10290,7 +10290,7 @@
                 <a:solidFill>
                   <a:srgbClr val="5C5548"/>
                 </a:solidFill>
-                <a:latin typeface="PingFang SC"/>
+                <a:latin typeface="'Noto Sans SC', 'PingFang SC', 'Microsoft YaHei', sans-serif"/>
               </a:rPr>
               <a:t>SLA 99% 达标</a:t>
             </a:r>
@@ -10376,7 +10376,7 @@
                 <a:solidFill>
                   <a:srgbClr val="D4956B"/>
                 </a:solidFill>
-                <a:latin typeface="PingFang SC"/>
+                <a:latin typeface="'Noto Sans SC', 'PingFang SC', 'Microsoft YaHei', sans-serif"/>
               </a:rPr>
               <a:t>界面预览</a:t>
             </a:r>
@@ -10462,7 +10462,7 @@
                 <a:solidFill>
                   <a:srgbClr val="5C5548"/>
                 </a:solidFill>
-                <a:latin typeface="PingFang SC"/>
+                <a:latin typeface="'Noto Sans SC', 'PingFang SC', 'Microsoft YaHei', sans-serif"/>
               </a:rPr>
               <a:t>Workflow 编排画布概念图</a:t>
             </a:r>
@@ -10548,7 +10548,7 @@
                 <a:solidFill>
                   <a:srgbClr val="1A1815"/>
                 </a:solidFill>
-                <a:latin typeface="PingFang SC"/>
+                <a:latin typeface="'Noto Sans SC', 'PingFang SC', 'Microsoft YaHei', sans-serif"/>
               </a:rPr>
               <a:t>落地案例</a:t>
             </a:r>
@@ -10587,7 +10587,7 @@
                 <a:solidFill>
                   <a:srgbClr val="5C5548"/>
                 </a:solidFill>
-                <a:latin typeface="PingFang SC"/>
+                <a:latin typeface="'Noto Sans SC', 'PingFang SC', 'Microsoft YaHei', sans-serif"/>
               </a:rPr>
               <a:t>某头部券商：用 Dify 把 17 个内部系统的接口能力封装成 Agent 工具，把客户经理日均处理工单数从 23 提升到 78。</a:t>
             </a:r>
@@ -10603,7 +10603,7 @@
                 <a:solidFill>
                   <a:srgbClr val="5C5548"/>
                 </a:solidFill>
-                <a:latin typeface="PingFang SC"/>
+                <a:latin typeface="'Noto Sans SC', 'PingFang SC', 'Microsoft YaHei', sans-serif"/>
               </a:rPr>
               <a:t>某省级政务平台：基于 Dify 知识库构建公文助手，问答准确率从 62% 提升到 91%。</a:t>
             </a:r>
@@ -10638,7 +10638,7 @@
                 <a:solidFill>
                   <a:srgbClr val="9C9588"/>
                 </a:solidFill>
-                <a:latin typeface="PingFang SC"/>
+                <a:latin typeface="'Noto Sans SC', 'PingFang SC', 'Microsoft YaHei', sans-serif"/>
               </a:rPr>
               <a:t>Dify 企业介绍</a:t>
             </a:r>
@@ -10673,7 +10673,7 @@
                 <a:solidFill>
                   <a:srgbClr val="9C9588"/>
                 </a:solidFill>
-                <a:latin typeface="SF Mono"/>
+                <a:latin typeface="'IBM Plex Mono', 'SF Mono', 'JetBrains Mono', Menlo, monospace"/>
               </a:rPr>
               <a:t>07 / 08</a:t>
             </a:r>
@@ -10828,7 +10828,7 @@
                 <a:solidFill>
                   <a:srgbClr val="D4956B"/>
                 </a:solidFill>
-                <a:latin typeface="PingFang SC"/>
+                <a:latin typeface="'Noto Sans SC', 'PingFang SC', 'Microsoft YaHei', sans-serif"/>
               </a:rPr>
               <a:t>THANK YOU</a:t>
             </a:r>
@@ -10863,7 +10863,7 @@
                 <a:solidFill>
                   <a:srgbClr val="1A1815"/>
                 </a:solidFill>
-                <a:latin typeface="PingFang SC"/>
+                <a:latin typeface="'Noto Sans SC', 'PingFang SC', 'Microsoft YaHei', sans-serif"/>
               </a:rPr>
               <a:t>让我们一起，把 AI 装进每一个业务流程</a:t>
             </a:r>
@@ -10898,7 +10898,7 @@
                 <a:solidFill>
                   <a:srgbClr val="5C5548"/>
                 </a:solidFill>
-                <a:latin typeface="PingFang SC"/>
+                <a:latin typeface="'Noto Sans SC', 'PingFang SC', 'Microsoft YaHei', sans-serif"/>
               </a:rPr>
               <a:t>联系 sales@dify.ai 安排技术演示</a:t>
             </a:r>
@@ -10976,7 +10976,7 @@
                 <a:solidFill>
                   <a:srgbClr val="5C5548"/>
                 </a:solidFill>
-                <a:latin typeface="PingFang SC"/>
+                <a:latin typeface="'Noto Sans SC', 'PingFang SC', 'Microsoft YaHei', sans-serif"/>
               </a:rPr>
               <a:t>Dify · 2026</a:t>
             </a:r>
@@ -11011,7 +11011,7 @@
                 <a:solidFill>
                   <a:srgbClr val="9C9588"/>
                 </a:solidFill>
-                <a:latin typeface="PingFang SC"/>
+                <a:latin typeface="'Noto Sans SC', 'PingFang SC', 'Microsoft YaHei', sans-serif"/>
               </a:rPr>
               <a:t>Dify 企业介绍</a:t>
             </a:r>
@@ -11046,7 +11046,7 @@
                 <a:solidFill>
                   <a:srgbClr val="9C9588"/>
                 </a:solidFill>
-                <a:latin typeface="SF Mono"/>
+                <a:latin typeface="'IBM Plex Mono', 'SF Mono', 'JetBrains Mono', Menlo, monospace"/>
               </a:rPr>
               <a:t>08 / 08</a:t>
             </a:r>

</xml_diff>

<commit_message>
fix: 渲染细节 — stat/quote/stack 布局 + 硬编码字体消除 (#17)
* fix: stat 单位换行 + quote 字体 + card-stack 间距 + 硬编码字体消除

- stat 窄卡: 单位换行时不增加 y 偏移，紧贴 value 下方左对齐
- card-quote: 横幅和大卡模式都使用 theme.fonts.display (serif)
- card-stack: 窄卡 (H<240) sec_gap/sec_label_gap 16→20
- 消除硬编码: font_name→theme.fonts.sans/mono/display (3处)
- render.py docstring: bento-tech→bento-paper

Co-Authored-By: Claude Opus 4.7 <noreply@anthropic.com>

* fix: extract first font from CSS stack for python-pptx compatibility

---------

Co-authored-by: Claude Opus 4.7 <noreply@anthropic.com>
</commit_message>
<xml_diff>
--- a/examples/dify-intro/deck.pptx
+++ b/examples/dify-intro/deck.pptx
@@ -3222,7 +3222,7 @@
             <a:pPr algn="r"/>
             <a:r>
               <a:rPr sz="11925" b="1" i="0" spc="600">
-                <a:latin typeface="PingFang SC"/>
+                <a:latin typeface="'Noto Sans SC', 'PingFang SC', 'Microsoft YaHei', sans-serif"/>
                 <a:solidFill>
                   <a:srgbClr val="B8654A">
                     <a:alpha val="6999"/>
@@ -3262,7 +3262,7 @@
                 <a:solidFill>
                   <a:srgbClr val="D4956B"/>
                 </a:solidFill>
-                <a:latin typeface="PingFang SC"/>
+                <a:latin typeface="'Noto Sans SC', 'PingFang SC', 'Microsoft YaHei', sans-serif"/>
               </a:rPr>
               <a:t>PRODUCT INTRO · 2026 Q2</a:t>
             </a:r>
@@ -3297,7 +3297,7 @@
                 <a:solidFill>
                   <a:srgbClr val="1A1815"/>
                 </a:solidFill>
-                <a:latin typeface="PingFang SC"/>
+                <a:latin typeface="'Noto Sans SC', 'PingFang SC', 'Microsoft YaHei', sans-serif"/>
               </a:rPr>
               <a:t>Dify 企业介绍</a:t>
             </a:r>
@@ -3332,7 +3332,7 @@
                 <a:solidFill>
                   <a:srgbClr val="1A1815"/>
                 </a:solidFill>
-                <a:latin typeface="PingFang SC"/>
+                <a:latin typeface="'Noto Sans SC', 'PingFang SC', 'Microsoft YaHei', sans-serif"/>
               </a:rPr>
               <a:t>下一代 AI 应用开发平台</a:t>
             </a:r>
@@ -3418,7 +3418,7 @@
                 <a:solidFill>
                   <a:srgbClr val="FFFFFF"/>
                 </a:solidFill>
-                <a:latin typeface="PingFang SC"/>
+                <a:latin typeface="'Noto Sans SC', 'PingFang SC', 'Microsoft YaHei', sans-serif"/>
               </a:rPr>
               <a:t>PRODUCTION-READY</a:t>
             </a:r>
@@ -3453,7 +3453,7 @@
                 <a:solidFill>
                   <a:srgbClr val="5C5548"/>
                 </a:solidFill>
-                <a:latin typeface="PingFang SC"/>
+                <a:latin typeface="'Noto Sans SC', 'PingFang SC', 'Microsoft YaHei', sans-serif"/>
               </a:rPr>
               <a:t>把生成式 AI 的不确定，变成产品落地的确定</a:t>
             </a:r>
@@ -3531,7 +3531,7 @@
                 <a:solidFill>
                   <a:srgbClr val="9C9588"/>
                 </a:solidFill>
-                <a:latin typeface="PingFang SC"/>
+                <a:latin typeface="'Noto Sans SC', 'PingFang SC', 'Microsoft YaHei', sans-serif"/>
               </a:rPr>
               <a:t>PRESENTED BY</a:t>
             </a:r>
@@ -3566,7 +3566,7 @@
                 <a:solidFill>
                   <a:srgbClr val="1A1815"/>
                 </a:solidFill>
-                <a:latin typeface="PingFang SC"/>
+                <a:latin typeface="'Noto Sans SC', 'PingFang SC', 'Microsoft YaHei', sans-serif"/>
               </a:rPr>
               <a:t>Dify Team</a:t>
             </a:r>
@@ -3601,7 +3601,7 @@
                 <a:solidFill>
                   <a:srgbClr val="9C9588"/>
                 </a:solidFill>
-                <a:latin typeface="PingFang SC"/>
+                <a:latin typeface="'Noto Sans SC', 'PingFang SC', 'Microsoft YaHei', sans-serif"/>
               </a:rPr>
               <a:t>DATE</a:t>
             </a:r>
@@ -3636,7 +3636,7 @@
                 <a:solidFill>
                   <a:srgbClr val="1A1815"/>
                 </a:solidFill>
-                <a:latin typeface="PingFang SC"/>
+                <a:latin typeface="'Noto Sans SC', 'PingFang SC', 'Microsoft YaHei', sans-serif"/>
               </a:rPr>
               <a:t>2026 Q2</a:t>
             </a:r>
@@ -3671,7 +3671,7 @@
                 <a:solidFill>
                   <a:srgbClr val="9C9588"/>
                 </a:solidFill>
-                <a:latin typeface="PingFang SC"/>
+                <a:latin typeface="'Noto Sans SC', 'PingFang SC', 'Microsoft YaHei', sans-serif"/>
               </a:rPr>
               <a:t>AUDIENCE</a:t>
             </a:r>
@@ -3706,7 +3706,7 @@
                 <a:solidFill>
                   <a:srgbClr val="1A1815"/>
                 </a:solidFill>
-                <a:latin typeface="PingFang SC"/>
+                <a:latin typeface="'Noto Sans SC', 'PingFang SC', 'Microsoft YaHei', sans-serif"/>
               </a:rPr>
               <a:t>企业客户 / 投资人</a:t>
             </a:r>
@@ -3741,7 +3741,7 @@
                 <a:solidFill>
                   <a:srgbClr val="9C9588"/>
                 </a:solidFill>
-                <a:latin typeface="PingFang SC"/>
+                <a:latin typeface="'Noto Sans SC', 'PingFang SC', 'Microsoft YaHei', sans-serif"/>
               </a:rPr>
               <a:t>Dify 企业介绍</a:t>
             </a:r>
@@ -3776,7 +3776,7 @@
                 <a:solidFill>
                   <a:srgbClr val="9C9588"/>
                 </a:solidFill>
-                <a:latin typeface="SF Mono"/>
+                <a:latin typeface="'IBM Plex Mono', 'SF Mono', 'JetBrains Mono', Menlo, monospace"/>
               </a:rPr>
               <a:t>01 / 08</a:t>
             </a:r>
@@ -3931,7 +3931,7 @@
                 <a:solidFill>
                   <a:srgbClr val="D4956B"/>
                 </a:solidFill>
-                <a:latin typeface="PingFang SC"/>
+                <a:latin typeface="'Noto Sans SC', 'PingFang SC', 'Microsoft YaHei', sans-serif"/>
               </a:rPr>
               <a:t>全球开发者</a:t>
             </a:r>
@@ -3966,7 +3966,7 @@
                 <a:solidFill>
                   <a:srgbClr val="1A1815"/>
                 </a:solidFill>
-                <a:latin typeface="PingFang SC"/>
+                <a:latin typeface="'Noto Sans SC', 'PingFang SC', 'Microsoft YaHei', sans-serif"/>
               </a:rPr>
               <a:t>180</a:t>
             </a:r>
@@ -4001,7 +4001,7 @@
                 <a:solidFill>
                   <a:srgbClr val="5C5548"/>
                 </a:solidFill>
-                <a:latin typeface="PingFang SC"/>
+                <a:latin typeface="'Noto Sans SC', 'PingFang SC', 'Microsoft YaHei', sans-serif"/>
               </a:rPr>
               <a:t>万+</a:t>
             </a:r>
@@ -4036,7 +4036,7 @@
                 <a:solidFill>
                   <a:srgbClr val="7A8B5E"/>
                 </a:solidFill>
-                <a:latin typeface="PingFang SC"/>
+                <a:latin typeface="'Noto Sans SC', 'PingFang SC', 'Microsoft YaHei', sans-serif"/>
               </a:rPr>
               <a:t>↑ 180% YoY</a:t>
             </a:r>
@@ -4114,7 +4114,7 @@
                 <a:solidFill>
                   <a:srgbClr val="5C5548"/>
                 </a:solidFill>
-                <a:latin typeface="PingFang SC"/>
+                <a:latin typeface="'Noto Sans SC', 'PingFang SC', 'Microsoft YaHei', sans-serif"/>
               </a:rPr>
               <a:t>覆盖 130+ 个国家与地区</a:t>
             </a:r>
@@ -4200,7 +4200,7 @@
                 <a:solidFill>
                   <a:srgbClr val="D4956B"/>
                 </a:solidFill>
-                <a:latin typeface="PingFang SC"/>
+                <a:latin typeface="'Noto Sans SC', 'PingFang SC', 'Microsoft YaHei', sans-serif"/>
               </a:rPr>
               <a:t>企业客户</a:t>
             </a:r>
@@ -4235,7 +4235,7 @@
                 <a:solidFill>
                   <a:srgbClr val="1A1815"/>
                 </a:solidFill>
-                <a:latin typeface="PingFang SC"/>
+                <a:latin typeface="'Noto Sans SC', 'PingFang SC', 'Microsoft YaHei', sans-serif"/>
               </a:rPr>
               <a:t>12000</a:t>
             </a:r>
@@ -4270,7 +4270,7 @@
                 <a:solidFill>
                   <a:srgbClr val="5C5548"/>
                 </a:solidFill>
-                <a:latin typeface="PingFang SC"/>
+                <a:latin typeface="'Noto Sans SC', 'PingFang SC', 'Microsoft YaHei', sans-serif"/>
               </a:rPr>
               <a:t>+</a:t>
             </a:r>
@@ -4305,7 +4305,7 @@
                 <a:solidFill>
                   <a:srgbClr val="7A8B5E"/>
                 </a:solidFill>
-                <a:latin typeface="PingFang SC"/>
+                <a:latin typeface="'Noto Sans SC', 'PingFang SC', 'Microsoft YaHei', sans-serif"/>
               </a:rPr>
               <a:t>↑ Fortune 500 中的 23 家</a:t>
             </a:r>
@@ -4383,7 +4383,7 @@
                 <a:solidFill>
                   <a:srgbClr val="5C5548"/>
                 </a:solidFill>
-                <a:latin typeface="PingFang SC"/>
+                <a:latin typeface="'Noto Sans SC', 'PingFang SC', 'Microsoft YaHei', sans-serif"/>
               </a:rPr>
               <a:t>金融、零售、教育、政务皆有落地</a:t>
             </a:r>
@@ -4418,7 +4418,7 @@
                 <a:solidFill>
                   <a:srgbClr val="9C9588"/>
                 </a:solidFill>
-                <a:latin typeface="PingFang SC"/>
+                <a:latin typeface="'Noto Sans SC', 'PingFang SC', 'Microsoft YaHei', sans-serif"/>
               </a:rPr>
               <a:t>Dify 企业介绍</a:t>
             </a:r>
@@ -4453,7 +4453,7 @@
                 <a:solidFill>
                   <a:srgbClr val="9C9588"/>
                 </a:solidFill>
-                <a:latin typeface="SF Mono"/>
+                <a:latin typeface="'IBM Plex Mono', 'SF Mono', 'JetBrains Mono', Menlo, monospace"/>
               </a:rPr>
               <a:t>02 / 08</a:t>
             </a:r>
@@ -4608,7 +4608,7 @@
                 <a:solidFill>
                   <a:srgbClr val="D4956B"/>
                 </a:solidFill>
-                <a:latin typeface="PingFang SC"/>
+                <a:latin typeface="'Noto Sans SC', 'PingFang SC', 'Microsoft YaHei', sans-serif"/>
               </a:rPr>
               <a:t>为什么选择 Dify</a:t>
             </a:r>
@@ -4643,7 +4643,7 @@
                 <a:solidFill>
                   <a:srgbClr val="1A1815"/>
                 </a:solidFill>
-                <a:latin typeface="PingFang SC"/>
+                <a:latin typeface="'Noto Sans SC', 'PingFang SC', 'Microsoft YaHei', sans-serif"/>
               </a:rPr>
               <a:t>把模型能力和业务流程缝起来</a:t>
             </a:r>
@@ -4682,7 +4682,7 @@
                 <a:solidFill>
                   <a:srgbClr val="5C5548"/>
                 </a:solidFill>
-                <a:latin typeface="PingFang SC"/>
+                <a:latin typeface="'Noto Sans SC', 'PingFang SC', 'Microsoft YaHei', sans-serif"/>
               </a:rPr>
               <a:t>Dify 不是又一个聊天机器人，而是把 LLM 能力变成稳定可交付的业务流程。从 prompt 编排到工具调用、从知识库到日志评测，全链路可观测、可回滚。</a:t>
             </a:r>
@@ -4698,7 +4698,7 @@
                 <a:solidFill>
                   <a:srgbClr val="5C5548"/>
                 </a:solidFill>
-                <a:latin typeface="PingFang SC"/>
+                <a:latin typeface="'Noto Sans SC', 'PingFang SC', 'Microsoft YaHei', sans-serif"/>
               </a:rPr>
               <a:t>工程团队不需要重复造轮子。市场团队不需要等着 IT 排期。运维团队不需要担心 token 失控。</a:t>
             </a:r>
@@ -4784,7 +4784,7 @@
                 <a:solidFill>
                   <a:srgbClr val="1A1815"/>
                 </a:solidFill>
-                <a:latin typeface="PingFang SC"/>
+                <a:latin typeface="'Noto Sans SC', 'PingFang SC', 'Microsoft YaHei', sans-serif"/>
               </a:rPr>
               <a:t>核心模块</a:t>
             </a:r>
@@ -4864,7 +4864,7 @@
                 <a:solidFill>
                   <a:srgbClr val="FFFFFF"/>
                 </a:solidFill>
-                <a:latin typeface="PingFang SC"/>
+                <a:latin typeface="'Noto Sans SC', 'PingFang SC', 'Microsoft YaHei', sans-serif"/>
               </a:rPr>
               <a:t>01</a:t>
             </a:r>
@@ -4899,7 +4899,7 @@
                 <a:solidFill>
                   <a:srgbClr val="1A1815"/>
                 </a:solidFill>
-                <a:latin typeface="PingFang SC"/>
+                <a:latin typeface="'Noto Sans SC', 'PingFang SC', 'Microsoft YaHei', sans-serif"/>
               </a:rPr>
               <a:t>Workflow</a:t>
             </a:r>
@@ -4934,7 +4934,7 @@
                 <a:solidFill>
                   <a:srgbClr val="5C5548"/>
                 </a:solidFill>
-                <a:latin typeface="PingFang SC"/>
+                <a:latin typeface="'Noto Sans SC', 'PingFang SC', 'Microsoft YaHei', sans-serif"/>
               </a:rPr>
               <a:t>可视化编排</a:t>
             </a:r>
@@ -5014,7 +5014,7 @@
                 <a:solidFill>
                   <a:srgbClr val="FFFFFF"/>
                 </a:solidFill>
-                <a:latin typeface="PingFang SC"/>
+                <a:latin typeface="'Noto Sans SC', 'PingFang SC', 'Microsoft YaHei', sans-serif"/>
               </a:rPr>
               <a:t>02</a:t>
             </a:r>
@@ -5049,7 +5049,7 @@
                 <a:solidFill>
                   <a:srgbClr val="1A1815"/>
                 </a:solidFill>
-                <a:latin typeface="PingFang SC"/>
+                <a:latin typeface="'Noto Sans SC', 'PingFang SC', 'Microsoft YaHei', sans-serif"/>
               </a:rPr>
               <a:t>Agent</a:t>
             </a:r>
@@ -5084,7 +5084,7 @@
                 <a:solidFill>
                   <a:srgbClr val="5C5548"/>
                 </a:solidFill>
-                <a:latin typeface="PingFang SC"/>
+                <a:latin typeface="'Noto Sans SC', 'PingFang SC', 'Microsoft YaHei', sans-serif"/>
               </a:rPr>
               <a:t>工具调用框架</a:t>
             </a:r>
@@ -5164,7 +5164,7 @@
                 <a:solidFill>
                   <a:srgbClr val="FFFFFF"/>
                 </a:solidFill>
-                <a:latin typeface="PingFang SC"/>
+                <a:latin typeface="'Noto Sans SC', 'PingFang SC', 'Microsoft YaHei', sans-serif"/>
               </a:rPr>
               <a:t>03</a:t>
             </a:r>
@@ -5199,7 +5199,7 @@
                 <a:solidFill>
                   <a:srgbClr val="1A1815"/>
                 </a:solidFill>
-                <a:latin typeface="PingFang SC"/>
+                <a:latin typeface="'Noto Sans SC', 'PingFang SC', 'Microsoft YaHei', sans-serif"/>
               </a:rPr>
               <a:t>Knowledge</a:t>
             </a:r>
@@ -5234,7 +5234,7 @@
                 <a:solidFill>
                   <a:srgbClr val="5C5548"/>
                 </a:solidFill>
-                <a:latin typeface="PingFang SC"/>
+                <a:latin typeface="'Noto Sans SC', 'PingFang SC', 'Microsoft YaHei', sans-serif"/>
               </a:rPr>
               <a:t>RAG 引擎</a:t>
             </a:r>
@@ -5314,7 +5314,7 @@
                 <a:solidFill>
                   <a:srgbClr val="FFFFFF"/>
                 </a:solidFill>
-                <a:latin typeface="PingFang SC"/>
+                <a:latin typeface="'Noto Sans SC', 'PingFang SC', 'Microsoft YaHei', sans-serif"/>
               </a:rPr>
               <a:t>04</a:t>
             </a:r>
@@ -5349,7 +5349,7 @@
                 <a:solidFill>
                   <a:srgbClr val="1A1815"/>
                 </a:solidFill>
-                <a:latin typeface="PingFang SC"/>
+                <a:latin typeface="'Noto Sans SC', 'PingFang SC', 'Microsoft YaHei', sans-serif"/>
               </a:rPr>
               <a:t>LLMOps</a:t>
             </a:r>
@@ -5384,7 +5384,7 @@
                 <a:solidFill>
                   <a:srgbClr val="5C5548"/>
                 </a:solidFill>
-                <a:latin typeface="PingFang SC"/>
+                <a:latin typeface="'Noto Sans SC', 'PingFang SC', 'Microsoft YaHei', sans-serif"/>
               </a:rPr>
               <a:t>评测与监控</a:t>
             </a:r>
@@ -5419,7 +5419,7 @@
                 <a:solidFill>
                   <a:srgbClr val="9C9588"/>
                 </a:solidFill>
-                <a:latin typeface="PingFang SC"/>
+                <a:latin typeface="'Noto Sans SC', 'PingFang SC', 'Microsoft YaHei', sans-serif"/>
               </a:rPr>
               <a:t>Dify 企业介绍</a:t>
             </a:r>
@@ -5454,7 +5454,7 @@
                 <a:solidFill>
                   <a:srgbClr val="9C9588"/>
                 </a:solidFill>
-                <a:latin typeface="SF Mono"/>
+                <a:latin typeface="'IBM Plex Mono', 'SF Mono', 'JetBrains Mono', Menlo, monospace"/>
               </a:rPr>
               <a:t>03 / 08</a:t>
             </a:r>
@@ -5609,7 +5609,7 @@
                 <a:solidFill>
                   <a:srgbClr val="D4956B"/>
                 </a:solidFill>
-                <a:latin typeface="PingFang SC"/>
+                <a:latin typeface="'Noto Sans SC', 'PingFang SC', 'Microsoft YaHei', sans-serif"/>
               </a:rPr>
               <a:t>搭建一个 AI 应用</a:t>
             </a:r>
@@ -5644,7 +5644,7 @@
                 <a:solidFill>
                   <a:srgbClr val="1A1815"/>
                 </a:solidFill>
-                <a:latin typeface="PingFang SC"/>
+                <a:latin typeface="'Noto Sans SC', 'PingFang SC', 'Microsoft YaHei', sans-serif"/>
               </a:rPr>
               <a:t>5</a:t>
             </a:r>
@@ -5679,7 +5679,7 @@
                 <a:solidFill>
                   <a:srgbClr val="5C5548"/>
                 </a:solidFill>
-                <a:latin typeface="PingFang SC"/>
+                <a:latin typeface="'Noto Sans SC', 'PingFang SC', 'Microsoft YaHei', sans-serif"/>
               </a:rPr>
               <a:t>分钟</a:t>
             </a:r>
@@ -5757,7 +5757,7 @@
                 <a:solidFill>
                   <a:srgbClr val="5C5548"/>
                 </a:solidFill>
-                <a:latin typeface="PingFang SC"/>
+                <a:latin typeface="'Noto Sans SC', 'PingFang SC', 'Microsoft YaHei', sans-serif"/>
               </a:rPr>
               <a:t>从模板到上线</a:t>
             </a:r>
@@ -5843,7 +5843,7 @@
                 <a:solidFill>
                   <a:srgbClr val="D4956B"/>
                 </a:solidFill>
-                <a:latin typeface="PingFang SC"/>
+                <a:latin typeface="'Noto Sans SC', 'PingFang SC', 'Microsoft YaHei', sans-serif"/>
               </a:rPr>
               <a:t>支持模型数</a:t>
             </a:r>
@@ -5878,7 +5878,7 @@
                 <a:solidFill>
                   <a:srgbClr val="1A1815"/>
                 </a:solidFill>
-                <a:latin typeface="PingFang SC"/>
+                <a:latin typeface="'Noto Sans SC', 'PingFang SC', 'Microsoft YaHei', sans-serif"/>
               </a:rPr>
               <a:t>200</a:t>
             </a:r>
@@ -5913,7 +5913,7 @@
                 <a:solidFill>
                   <a:srgbClr val="5C5548"/>
                 </a:solidFill>
-                <a:latin typeface="PingFang SC"/>
+                <a:latin typeface="'Noto Sans SC', 'PingFang SC', 'Microsoft YaHei', sans-serif"/>
               </a:rPr>
               <a:t>+</a:t>
             </a:r>
@@ -5991,7 +5991,7 @@
                 <a:solidFill>
                   <a:srgbClr val="5C5548"/>
                 </a:solidFill>
-                <a:latin typeface="PingFang SC"/>
+                <a:latin typeface="'Noto Sans SC', 'PingFang SC', 'Microsoft YaHei', sans-serif"/>
               </a:rPr>
               <a:t>OpenAI / Anthropic / 国产</a:t>
             </a:r>
@@ -6077,7 +6077,7 @@
                 <a:solidFill>
                   <a:srgbClr val="D4956B"/>
                 </a:solidFill>
-                <a:latin typeface="PingFang SC"/>
+                <a:latin typeface="'Noto Sans SC', 'PingFang SC', 'Microsoft YaHei', sans-serif"/>
               </a:rPr>
               <a:t>可观测性</a:t>
             </a:r>
@@ -6112,7 +6112,7 @@
                 <a:solidFill>
                   <a:srgbClr val="1A1815"/>
                 </a:solidFill>
-                <a:latin typeface="PingFang SC"/>
+                <a:latin typeface="'Noto Sans SC', 'PingFang SC', 'Microsoft YaHei', sans-serif"/>
               </a:rPr>
               <a:t>100</a:t>
             </a:r>
@@ -6147,7 +6147,7 @@
                 <a:solidFill>
                   <a:srgbClr val="5C5548"/>
                 </a:solidFill>
-                <a:latin typeface="PingFang SC"/>
+                <a:latin typeface="'Noto Sans SC', 'PingFang SC', 'Microsoft YaHei', sans-serif"/>
               </a:rPr>
               <a:t>%</a:t>
             </a:r>
@@ -6225,7 +6225,7 @@
                 <a:solidFill>
                   <a:srgbClr val="5C5548"/>
                 </a:solidFill>
-                <a:latin typeface="PingFang SC"/>
+                <a:latin typeface="'Noto Sans SC', 'PingFang SC', 'Microsoft YaHei', sans-serif"/>
               </a:rPr>
               <a:t>全链路日志与评测</a:t>
             </a:r>
@@ -6260,7 +6260,7 @@
                 <a:solidFill>
                   <a:srgbClr val="9C9588"/>
                 </a:solidFill>
-                <a:latin typeface="PingFang SC"/>
+                <a:latin typeface="'Noto Sans SC', 'PingFang SC', 'Microsoft YaHei', sans-serif"/>
               </a:rPr>
               <a:t>Dify 企业介绍</a:t>
             </a:r>
@@ -6295,7 +6295,7 @@
                 <a:solidFill>
                   <a:srgbClr val="9C9588"/>
                 </a:solidFill>
-                <a:latin typeface="SF Mono"/>
+                <a:latin typeface="'IBM Plex Mono', 'SF Mono', 'JetBrains Mono', Menlo, monospace"/>
               </a:rPr>
               <a:t>04 / 08</a:t>
             </a:r>
@@ -6495,7 +6495,7 @@
                 <a:solidFill>
                   <a:srgbClr val="1A1815"/>
                 </a:solidFill>
-                <a:latin typeface="PingFang SC"/>
+                <a:latin typeface="'Noto Serif SC', 'Playfair Display', 'Times New Roman', serif"/>
               </a:rPr>
               <a:t>AI 应用的瓶颈不是模型，而是工程化。</a:t>
             </a:r>
@@ -6573,7 +6573,7 @@
                 <a:solidFill>
                   <a:srgbClr val="1A1815"/>
                 </a:solidFill>
-                <a:latin typeface="PingFang SC"/>
+                <a:latin typeface="'Noto Sans SC', 'PingFang SC', 'Microsoft YaHei', sans-serif"/>
               </a:rPr>
               <a:t>Dify 创始团队</a:t>
             </a:r>
@@ -6608,7 +6608,7 @@
                 <a:solidFill>
                   <a:srgbClr val="9C9588"/>
                 </a:solidFill>
-                <a:latin typeface="PingFang SC"/>
+                <a:latin typeface="'Noto Sans SC', 'PingFang SC', 'Microsoft YaHei', sans-serif"/>
               </a:rPr>
               <a:t>2024 年技术分享会</a:t>
             </a:r>
@@ -6694,7 +6694,7 @@
                 <a:solidFill>
                   <a:srgbClr val="D4956B"/>
                 </a:solidFill>
-                <a:latin typeface="PingFang SC"/>
+                <a:latin typeface="'Noto Sans SC', 'PingFang SC', 'Microsoft YaHei', sans-serif"/>
               </a:rPr>
               <a:t>模型延迟</a:t>
             </a:r>
@@ -6729,7 +6729,7 @@
                 <a:solidFill>
                   <a:srgbClr val="1A1815"/>
                 </a:solidFill>
-                <a:latin typeface="PingFang SC"/>
+                <a:latin typeface="'Noto Sans SC', 'PingFang SC', 'Microsoft YaHei', sans-serif"/>
               </a:rPr>
               <a:t>&lt;200</a:t>
             </a:r>
@@ -6744,7 +6744,7 @@
         </p:nvSpPr>
         <p:spPr>
           <a:xfrm>
-            <a:off x="914377" y="2000250"/>
+            <a:off x="914377" y="1800225"/>
             <a:ext cx="1447763" cy="219075"/>
           </a:xfrm>
           <a:prstGeom prst="rect">
@@ -6764,7 +6764,7 @@
                 <a:solidFill>
                   <a:srgbClr val="5C5548"/>
                 </a:solidFill>
-                <a:latin typeface="PingFang SC"/>
+                <a:latin typeface="'Noto Sans SC', 'PingFang SC', 'Microsoft YaHei', sans-serif"/>
               </a:rPr>
               <a:t>ms</a:t>
             </a:r>
@@ -6779,7 +6779,7 @@
         </p:nvSpPr>
         <p:spPr>
           <a:xfrm>
-            <a:off x="914377" y="2390775"/>
+            <a:off x="914377" y="2209800"/>
             <a:ext cx="571485" cy="28575"/>
           </a:xfrm>
           <a:prstGeom prst="rect">
@@ -6893,7 +6893,7 @@
                 <a:solidFill>
                   <a:srgbClr val="D4956B"/>
                 </a:solidFill>
-                <a:latin typeface="PingFang SC"/>
+                <a:latin typeface="'Noto Sans SC', 'PingFang SC', 'Microsoft YaHei', sans-serif"/>
               </a:rPr>
               <a:t>成本下降</a:t>
             </a:r>
@@ -6928,7 +6928,7 @@
                 <a:solidFill>
                   <a:srgbClr val="1A1815"/>
                 </a:solidFill>
-                <a:latin typeface="PingFang SC"/>
+                <a:latin typeface="'Noto Sans SC', 'PingFang SC', 'Microsoft YaHei', sans-serif"/>
               </a:rPr>
               <a:t>60</a:t>
             </a:r>
@@ -6963,7 +6963,7 @@
                 <a:solidFill>
                   <a:srgbClr val="5C5548"/>
                 </a:solidFill>
-                <a:latin typeface="PingFang SC"/>
+                <a:latin typeface="'Noto Sans SC', 'PingFang SC', 'Microsoft YaHei', sans-serif"/>
               </a:rPr>
               <a:t>%</a:t>
             </a:r>
@@ -7092,7 +7092,7 @@
                 <a:solidFill>
                   <a:srgbClr val="D4956B"/>
                 </a:solidFill>
-                <a:latin typeface="PingFang SC"/>
+                <a:latin typeface="'Noto Sans SC', 'PingFang SC', 'Microsoft YaHei', sans-serif"/>
               </a:rPr>
               <a:t>上线周期</a:t>
             </a:r>
@@ -7127,7 +7127,7 @@
                 <a:solidFill>
                   <a:srgbClr val="1A1815"/>
                 </a:solidFill>
-                <a:latin typeface="PingFang SC"/>
+                <a:latin typeface="'Noto Sans SC', 'PingFang SC', 'Microsoft YaHei', sans-serif"/>
               </a:rPr>
               <a:t>1/10</a:t>
             </a:r>
@@ -7205,7 +7205,7 @@
                 <a:solidFill>
                   <a:srgbClr val="5C5548"/>
                 </a:solidFill>
-                <a:latin typeface="PingFang SC"/>
+                <a:latin typeface="'Noto Sans SC', 'PingFang SC', 'Microsoft YaHei', sans-serif"/>
               </a:rPr>
               <a:t>对比传统开发</a:t>
             </a:r>
@@ -7291,7 +7291,7 @@
                 <a:solidFill>
                   <a:srgbClr val="D4956B"/>
                 </a:solidFill>
-                <a:latin typeface="PingFang SC"/>
+                <a:latin typeface="'Noto Sans SC', 'PingFang SC', 'Microsoft YaHei', sans-serif"/>
               </a:rPr>
               <a:t>客户留存</a:t>
             </a:r>
@@ -7326,7 +7326,7 @@
                 <a:solidFill>
                   <a:srgbClr val="1A1815"/>
                 </a:solidFill>
-                <a:latin typeface="PingFang SC"/>
+                <a:latin typeface="'Noto Sans SC', 'PingFang SC', 'Microsoft YaHei', sans-serif"/>
               </a:rPr>
               <a:t>94</a:t>
             </a:r>
@@ -7361,7 +7361,7 @@
                 <a:solidFill>
                   <a:srgbClr val="5C5548"/>
                 </a:solidFill>
-                <a:latin typeface="PingFang SC"/>
+                <a:latin typeface="'Noto Sans SC', 'PingFang SC', 'Microsoft YaHei', sans-serif"/>
               </a:rPr>
               <a:t>%</a:t>
             </a:r>
@@ -7439,7 +7439,7 @@
                 <a:solidFill>
                   <a:srgbClr val="9C9588"/>
                 </a:solidFill>
-                <a:latin typeface="PingFang SC"/>
+                <a:latin typeface="'Noto Sans SC', 'PingFang SC', 'Microsoft YaHei', sans-serif"/>
               </a:rPr>
               <a:t>Dify 企业介绍</a:t>
             </a:r>
@@ -7474,7 +7474,7 @@
                 <a:solidFill>
                   <a:srgbClr val="9C9588"/>
                 </a:solidFill>
-                <a:latin typeface="SF Mono"/>
+                <a:latin typeface="'IBM Plex Mono', 'SF Mono', 'JetBrains Mono', Menlo, monospace"/>
               </a:rPr>
               <a:t>05 / 08</a:t>
             </a:r>
@@ -7629,7 +7629,7 @@
                 <a:solidFill>
                   <a:srgbClr val="D4956B"/>
                 </a:solidFill>
-                <a:latin typeface="PingFang SC"/>
+                <a:latin typeface="'Noto Sans SC', 'PingFang SC', 'Microsoft YaHei', sans-serif"/>
               </a:rPr>
               <a:t>ARCHITECTURE</a:t>
             </a:r>
@@ -7664,7 +7664,7 @@
                 <a:solidFill>
                   <a:srgbClr val="1A1815"/>
                 </a:solidFill>
-                <a:latin typeface="PingFang SC"/>
+                <a:latin typeface="'Noto Sans SC', 'PingFang SC', 'Microsoft YaHei', sans-serif"/>
               </a:rPr>
               <a:t>分层架构：从数据层到编排层</a:t>
             </a:r>
@@ -7699,7 +7699,7 @@
                 <a:solidFill>
                   <a:srgbClr val="5C5548"/>
                 </a:solidFill>
-                <a:latin typeface="PingFang SC"/>
+                <a:latin typeface="'Noto Sans SC', 'PingFang SC', 'Microsoft YaHei', sans-serif"/>
               </a:rPr>
               <a:t>每一层都可独立替换，整体可观测</a:t>
             </a:r>
@@ -7785,7 +7785,7 @@
                 <a:solidFill>
                   <a:srgbClr val="1A1815"/>
                 </a:solidFill>
-                <a:latin typeface="PingFang SC"/>
+                <a:latin typeface="'Noto Sans SC', 'PingFang SC', 'Microsoft YaHei', sans-serif"/>
               </a:rPr>
               <a:t>数据层</a:t>
             </a:r>
@@ -7908,7 +7908,7 @@
                 <a:solidFill>
                   <a:srgbClr val="FFFFFF"/>
                 </a:solidFill>
-                <a:latin typeface="PingFang SC"/>
+                <a:latin typeface="'Noto Sans SC', 'PingFang SC', 'Microsoft YaHei', sans-serif"/>
               </a:rPr>
               <a:t>01</a:t>
             </a:r>
@@ -7943,7 +7943,7 @@
                 <a:solidFill>
                   <a:srgbClr val="1A1815"/>
                 </a:solidFill>
-                <a:latin typeface="PingFang SC"/>
+                <a:latin typeface="'Noto Sans SC', 'PingFang SC', 'Microsoft YaHei', sans-serif"/>
               </a:rPr>
               <a:t>向量库</a:t>
             </a:r>
@@ -8023,7 +8023,7 @@
                 <a:solidFill>
                   <a:srgbClr val="FFFFFF"/>
                 </a:solidFill>
-                <a:latin typeface="PingFang SC"/>
+                <a:latin typeface="'Noto Sans SC', 'PingFang SC', 'Microsoft YaHei', sans-serif"/>
               </a:rPr>
               <a:t>02</a:t>
             </a:r>
@@ -8058,7 +8058,7 @@
                 <a:solidFill>
                   <a:srgbClr val="5C5548"/>
                 </a:solidFill>
-                <a:latin typeface="PingFang SC"/>
+                <a:latin typeface="'Noto Sans SC', 'PingFang SC', 'Microsoft YaHei', sans-serif"/>
               </a:rPr>
               <a:t>对象存储</a:t>
             </a:r>
@@ -8138,7 +8138,7 @@
                 <a:solidFill>
                   <a:srgbClr val="FFFFFF"/>
                 </a:solidFill>
-                <a:latin typeface="PingFang SC"/>
+                <a:latin typeface="'Noto Sans SC', 'PingFang SC', 'Microsoft YaHei', sans-serif"/>
               </a:rPr>
               <a:t>03</a:t>
             </a:r>
@@ -8173,7 +8173,7 @@
                 <a:solidFill>
                   <a:srgbClr val="5C5548"/>
                 </a:solidFill>
-                <a:latin typeface="PingFang SC"/>
+                <a:latin typeface="'Noto Sans SC', 'PingFang SC', 'Microsoft YaHei', sans-serif"/>
               </a:rPr>
               <a:t>审计日志</a:t>
             </a:r>
@@ -8259,7 +8259,7 @@
                 <a:solidFill>
                   <a:srgbClr val="1A1815"/>
                 </a:solidFill>
-                <a:latin typeface="PingFang SC"/>
+                <a:latin typeface="'Noto Sans SC', 'PingFang SC', 'Microsoft YaHei', sans-serif"/>
               </a:rPr>
               <a:t>能力层</a:t>
             </a:r>
@@ -8382,7 +8382,7 @@
                 <a:solidFill>
                   <a:srgbClr val="FFFFFF"/>
                 </a:solidFill>
-                <a:latin typeface="PingFang SC"/>
+                <a:latin typeface="'Noto Sans SC', 'PingFang SC', 'Microsoft YaHei', sans-serif"/>
               </a:rPr>
               <a:t>01</a:t>
             </a:r>
@@ -8417,7 +8417,7 @@
                 <a:solidFill>
                   <a:srgbClr val="1A1815"/>
                 </a:solidFill>
-                <a:latin typeface="PingFang SC"/>
+                <a:latin typeface="'Noto Sans SC', 'PingFang SC', 'Microsoft YaHei', sans-serif"/>
               </a:rPr>
               <a:t>模型路由</a:t>
             </a:r>
@@ -8497,7 +8497,7 @@
                 <a:solidFill>
                   <a:srgbClr val="FFFFFF"/>
                 </a:solidFill>
-                <a:latin typeface="PingFang SC"/>
+                <a:latin typeface="'Noto Sans SC', 'PingFang SC', 'Microsoft YaHei', sans-serif"/>
               </a:rPr>
               <a:t>02</a:t>
             </a:r>
@@ -8532,7 +8532,7 @@
                 <a:solidFill>
                   <a:srgbClr val="5C5548"/>
                 </a:solidFill>
-                <a:latin typeface="PingFang SC"/>
+                <a:latin typeface="'Noto Sans SC', 'PingFang SC', 'Microsoft YaHei', sans-serif"/>
               </a:rPr>
               <a:t>工具调用</a:t>
             </a:r>
@@ -8612,7 +8612,7 @@
                 <a:solidFill>
                   <a:srgbClr val="FFFFFF"/>
                 </a:solidFill>
-                <a:latin typeface="PingFang SC"/>
+                <a:latin typeface="'Noto Sans SC', 'PingFang SC', 'Microsoft YaHei', sans-serif"/>
               </a:rPr>
               <a:t>03</a:t>
             </a:r>
@@ -8647,7 +8647,7 @@
                 <a:solidFill>
                   <a:srgbClr val="5C5548"/>
                 </a:solidFill>
-                <a:latin typeface="PingFang SC"/>
+                <a:latin typeface="'Noto Sans SC', 'PingFang SC', 'Microsoft YaHei', sans-serif"/>
               </a:rPr>
               <a:t>知识检索</a:t>
             </a:r>
@@ -8733,7 +8733,7 @@
                 <a:solidFill>
                   <a:srgbClr val="1A1815"/>
                 </a:solidFill>
-                <a:latin typeface="PingFang SC"/>
+                <a:latin typeface="'Noto Sans SC', 'PingFang SC', 'Microsoft YaHei', sans-serif"/>
               </a:rPr>
               <a:t>编排层</a:t>
             </a:r>
@@ -8856,7 +8856,7 @@
                 <a:solidFill>
                   <a:srgbClr val="FFFFFF"/>
                 </a:solidFill>
-                <a:latin typeface="PingFang SC"/>
+                <a:latin typeface="'Noto Sans SC', 'PingFang SC', 'Microsoft YaHei', sans-serif"/>
               </a:rPr>
               <a:t>01</a:t>
             </a:r>
@@ -8891,7 +8891,7 @@
                 <a:solidFill>
                   <a:srgbClr val="1A1815"/>
                 </a:solidFill>
-                <a:latin typeface="PingFang SC"/>
+                <a:latin typeface="'Noto Sans SC', 'PingFang SC', 'Microsoft YaHei', sans-serif"/>
               </a:rPr>
               <a:t>Workflow</a:t>
             </a:r>
@@ -8971,7 +8971,7 @@
                 <a:solidFill>
                   <a:srgbClr val="FFFFFF"/>
                 </a:solidFill>
-                <a:latin typeface="PingFang SC"/>
+                <a:latin typeface="'Noto Sans SC', 'PingFang SC', 'Microsoft YaHei', sans-serif"/>
               </a:rPr>
               <a:t>02</a:t>
             </a:r>
@@ -9006,7 +9006,7 @@
                 <a:solidFill>
                   <a:srgbClr val="5C5548"/>
                 </a:solidFill>
-                <a:latin typeface="PingFang SC"/>
+                <a:latin typeface="'Noto Sans SC', 'PingFang SC', 'Microsoft YaHei', sans-serif"/>
               </a:rPr>
               <a:t>Agent</a:t>
             </a:r>
@@ -9086,7 +9086,7 @@
                 <a:solidFill>
                   <a:srgbClr val="FFFFFF"/>
                 </a:solidFill>
-                <a:latin typeface="PingFang SC"/>
+                <a:latin typeface="'Noto Sans SC', 'PingFang SC', 'Microsoft YaHei', sans-serif"/>
               </a:rPr>
               <a:t>03</a:t>
             </a:r>
@@ -9121,7 +9121,7 @@
                 <a:solidFill>
                   <a:srgbClr val="5C5548"/>
                 </a:solidFill>
-                <a:latin typeface="PingFang SC"/>
+                <a:latin typeface="'Noto Sans SC', 'PingFang SC', 'Microsoft YaHei', sans-serif"/>
               </a:rPr>
               <a:t>Chat 流</a:t>
             </a:r>
@@ -9156,7 +9156,7 @@
                 <a:solidFill>
                   <a:srgbClr val="9C9588"/>
                 </a:solidFill>
-                <a:latin typeface="PingFang SC"/>
+                <a:latin typeface="'Noto Sans SC', 'PingFang SC', 'Microsoft YaHei', sans-serif"/>
               </a:rPr>
               <a:t>Dify 企业介绍</a:t>
             </a:r>
@@ -9191,7 +9191,7 @@
                 <a:solidFill>
                   <a:srgbClr val="9C9588"/>
                 </a:solidFill>
-                <a:latin typeface="SF Mono"/>
+                <a:latin typeface="'IBM Plex Mono', 'SF Mono', 'JetBrains Mono', Menlo, monospace"/>
               </a:rPr>
               <a:t>06 / 08</a:t>
             </a:r>
@@ -9346,7 +9346,7 @@
                 <a:solidFill>
                   <a:srgbClr val="D4956B"/>
                 </a:solidFill>
-                <a:latin typeface="PingFang SC"/>
+                <a:latin typeface="'Noto Sans SC', 'PingFang SC', 'Microsoft YaHei', sans-serif"/>
               </a:rPr>
               <a:t>模型调用量月环比</a:t>
             </a:r>
@@ -9381,7 +9381,7 @@
                 <a:solidFill>
                   <a:srgbClr val="1A1815"/>
                 </a:solidFill>
-                <a:latin typeface="PingFang SC"/>
+                <a:latin typeface="'Noto Sans SC', 'PingFang SC', 'Microsoft YaHei', sans-serif"/>
               </a:rPr>
               <a:t>GPT-4</a:t>
             </a:r>
@@ -9508,7 +9508,7 @@
                 <a:solidFill>
                   <a:srgbClr val="1A1815"/>
                 </a:solidFill>
-                <a:latin typeface="PingFang SC"/>
+                <a:latin typeface="'Noto Sans SC', 'PingFang SC', 'Microsoft YaHei', sans-serif"/>
               </a:rPr>
               <a:t>42 亿</a:t>
             </a:r>
@@ -9543,7 +9543,7 @@
                 <a:solidFill>
                   <a:srgbClr val="1A1815"/>
                 </a:solidFill>
-                <a:latin typeface="PingFang SC"/>
+                <a:latin typeface="'Noto Sans SC', 'PingFang SC', 'Microsoft YaHei', sans-serif"/>
               </a:rPr>
               <a:t>Claude</a:t>
             </a:r>
@@ -9670,7 +9670,7 @@
                 <a:solidFill>
                   <a:srgbClr val="1A1815"/>
                 </a:solidFill>
-                <a:latin typeface="PingFang SC"/>
+                <a:latin typeface="'Noto Sans SC', 'PingFang SC', 'Microsoft YaHei', sans-serif"/>
               </a:rPr>
               <a:t>31 亿</a:t>
             </a:r>
@@ -9705,7 +9705,7 @@
                 <a:solidFill>
                   <a:srgbClr val="1A1815"/>
                 </a:solidFill>
-                <a:latin typeface="PingFang SC"/>
+                <a:latin typeface="'Noto Sans SC', 'PingFang SC', 'Microsoft YaHei', sans-serif"/>
               </a:rPr>
               <a:t>Gemini</a:t>
             </a:r>
@@ -9832,7 +9832,7 @@
                 <a:solidFill>
                   <a:srgbClr val="1A1815"/>
                 </a:solidFill>
-                <a:latin typeface="PingFang SC"/>
+                <a:latin typeface="'Noto Sans SC', 'PingFang SC', 'Microsoft YaHei', sans-serif"/>
               </a:rPr>
               <a:t>18 亿</a:t>
             </a:r>
@@ -9918,7 +9918,7 @@
                 <a:solidFill>
                   <a:srgbClr val="D4956B"/>
                 </a:solidFill>
-                <a:latin typeface="PingFang SC"/>
+                <a:latin typeface="'Noto Sans SC', 'PingFang SC', 'Microsoft YaHei', sans-serif"/>
               </a:rPr>
               <a:t>运行指标</a:t>
             </a:r>
@@ -9933,7 +9933,7 @@
         </p:nvSpPr>
         <p:spPr>
           <a:xfrm>
-            <a:off x="8496087" y="1257300"/>
+            <a:off x="8496087" y="1228725"/>
             <a:ext cx="2781230" cy="542925"/>
           </a:xfrm>
           <a:prstGeom prst="rect">
@@ -9953,7 +9953,7 @@
                 <a:solidFill>
                   <a:srgbClr val="1A1815"/>
                 </a:solidFill>
-                <a:latin typeface="PingFang SC"/>
+                <a:latin typeface="'Noto Sans SC', 'PingFang SC', 'Microsoft YaHei', sans-serif"/>
               </a:rPr>
               <a:t>187</a:t>
             </a:r>
@@ -9968,7 +9968,7 @@
         </p:nvSpPr>
         <p:spPr>
           <a:xfrm>
-            <a:off x="9315216" y="1562100"/>
+            <a:off x="9315216" y="1533525"/>
             <a:ext cx="371465" cy="180975"/>
           </a:xfrm>
           <a:prstGeom prst="rect">
@@ -9988,7 +9988,7 @@
                 <a:solidFill>
                   <a:srgbClr val="D4956B"/>
                 </a:solidFill>
-                <a:latin typeface="PingFang SC"/>
+                <a:latin typeface="'Noto Sans SC', 'PingFang SC', 'Microsoft YaHei', sans-serif"/>
               </a:rPr>
               <a:t>ms</a:t>
             </a:r>
@@ -10003,7 +10003,7 @@
         </p:nvSpPr>
         <p:spPr>
           <a:xfrm>
-            <a:off x="9581910" y="1533525"/>
+            <a:off x="9581910" y="1504950"/>
             <a:ext cx="1600159" cy="219075"/>
           </a:xfrm>
           <a:prstGeom prst="rect">
@@ -10023,7 +10023,7 @@
                 <a:solidFill>
                   <a:srgbClr val="5C5548"/>
                 </a:solidFill>
-                <a:latin typeface="PingFang SC"/>
+                <a:latin typeface="'Noto Sans SC', 'PingFang SC', 'Microsoft YaHei', sans-serif"/>
               </a:rPr>
               <a:t>API 平均响应</a:t>
             </a:r>
@@ -10038,7 +10038,7 @@
         </p:nvSpPr>
         <p:spPr>
           <a:xfrm>
-            <a:off x="8496087" y="1752600"/>
+            <a:off x="8496087" y="1762125"/>
             <a:ext cx="1390615" cy="171450"/>
           </a:xfrm>
           <a:prstGeom prst="rect">
@@ -10058,7 +10058,7 @@
                 <a:solidFill>
                   <a:srgbClr val="9C9588"/>
                 </a:solidFill>
-                <a:latin typeface="PingFang SC"/>
+                <a:latin typeface="'Noto Sans SC', 'PingFang SC', 'Microsoft YaHei', sans-serif"/>
               </a:rPr>
               <a:t>99 分位</a:t>
             </a:r>
@@ -10073,7 +10073,7 @@
         </p:nvSpPr>
         <p:spPr>
           <a:xfrm>
-            <a:off x="8496087" y="1866900"/>
+            <a:off x="8496087" y="1895475"/>
             <a:ext cx="1390615" cy="238125"/>
           </a:xfrm>
           <a:prstGeom prst="rect">
@@ -10093,7 +10093,7 @@
                 <a:solidFill>
                   <a:srgbClr val="1A1815"/>
                 </a:solidFill>
-                <a:latin typeface="PingFang SC"/>
+                <a:latin typeface="'Noto Sans SC', 'PingFang SC', 'Microsoft YaHei', sans-serif"/>
               </a:rPr>
               <a:t>420 ms</a:t>
             </a:r>
@@ -10108,7 +10108,7 @@
         </p:nvSpPr>
         <p:spPr>
           <a:xfrm>
-            <a:off x="9886702" y="1752600"/>
+            <a:off x="9886702" y="1762125"/>
             <a:ext cx="1390615" cy="171450"/>
           </a:xfrm>
           <a:prstGeom prst="rect">
@@ -10128,7 +10128,7 @@
                 <a:solidFill>
                   <a:srgbClr val="9C9588"/>
                 </a:solidFill>
-                <a:latin typeface="PingFang SC"/>
+                <a:latin typeface="'Noto Sans SC', 'PingFang SC', 'Microsoft YaHei', sans-serif"/>
               </a:rPr>
               <a:t>错误率</a:t>
             </a:r>
@@ -10143,7 +10143,7 @@
         </p:nvSpPr>
         <p:spPr>
           <a:xfrm>
-            <a:off x="9886702" y="1866900"/>
+            <a:off x="9886702" y="1895475"/>
             <a:ext cx="1390615" cy="238125"/>
           </a:xfrm>
           <a:prstGeom prst="rect">
@@ -10163,7 +10163,7 @@
                 <a:solidFill>
                   <a:srgbClr val="1A1815"/>
                 </a:solidFill>
-                <a:latin typeface="PingFang SC"/>
+                <a:latin typeface="'Noto Sans SC', 'PingFang SC', 'Microsoft YaHei', sans-serif"/>
               </a:rPr>
               <a:t>0.03%</a:t>
             </a:r>
@@ -10290,7 +10290,7 @@
                 <a:solidFill>
                   <a:srgbClr val="5C5548"/>
                 </a:solidFill>
-                <a:latin typeface="PingFang SC"/>
+                <a:latin typeface="'Noto Sans SC', 'PingFang SC', 'Microsoft YaHei', sans-serif"/>
               </a:rPr>
               <a:t>SLA 99% 达标</a:t>
             </a:r>
@@ -10376,7 +10376,7 @@
                 <a:solidFill>
                   <a:srgbClr val="D4956B"/>
                 </a:solidFill>
-                <a:latin typeface="PingFang SC"/>
+                <a:latin typeface="'Noto Sans SC', 'PingFang SC', 'Microsoft YaHei', sans-serif"/>
               </a:rPr>
               <a:t>界面预览</a:t>
             </a:r>
@@ -10462,7 +10462,7 @@
                 <a:solidFill>
                   <a:srgbClr val="5C5548"/>
                 </a:solidFill>
-                <a:latin typeface="PingFang SC"/>
+                <a:latin typeface="'Noto Sans SC', 'PingFang SC', 'Microsoft YaHei', sans-serif"/>
               </a:rPr>
               <a:t>Workflow 编排画布概念图</a:t>
             </a:r>
@@ -10548,7 +10548,7 @@
                 <a:solidFill>
                   <a:srgbClr val="1A1815"/>
                 </a:solidFill>
-                <a:latin typeface="PingFang SC"/>
+                <a:latin typeface="'Noto Sans SC', 'PingFang SC', 'Microsoft YaHei', sans-serif"/>
               </a:rPr>
               <a:t>落地案例</a:t>
             </a:r>
@@ -10587,7 +10587,7 @@
                 <a:solidFill>
                   <a:srgbClr val="5C5548"/>
                 </a:solidFill>
-                <a:latin typeface="PingFang SC"/>
+                <a:latin typeface="'Noto Sans SC', 'PingFang SC', 'Microsoft YaHei', sans-serif"/>
               </a:rPr>
               <a:t>某头部券商：用 Dify 把 17 个内部系统的接口能力封装成 Agent 工具，把客户经理日均处理工单数从 23 提升到 78。</a:t>
             </a:r>
@@ -10603,7 +10603,7 @@
                 <a:solidFill>
                   <a:srgbClr val="5C5548"/>
                 </a:solidFill>
-                <a:latin typeface="PingFang SC"/>
+                <a:latin typeface="'Noto Sans SC', 'PingFang SC', 'Microsoft YaHei', sans-serif"/>
               </a:rPr>
               <a:t>某省级政务平台：基于 Dify 知识库构建公文助手，问答准确率从 62% 提升到 91%。</a:t>
             </a:r>
@@ -10638,7 +10638,7 @@
                 <a:solidFill>
                   <a:srgbClr val="9C9588"/>
                 </a:solidFill>
-                <a:latin typeface="PingFang SC"/>
+                <a:latin typeface="'Noto Sans SC', 'PingFang SC', 'Microsoft YaHei', sans-serif"/>
               </a:rPr>
               <a:t>Dify 企业介绍</a:t>
             </a:r>
@@ -10673,7 +10673,7 @@
                 <a:solidFill>
                   <a:srgbClr val="9C9588"/>
                 </a:solidFill>
-                <a:latin typeface="SF Mono"/>
+                <a:latin typeface="'IBM Plex Mono', 'SF Mono', 'JetBrains Mono', Menlo, monospace"/>
               </a:rPr>
               <a:t>07 / 08</a:t>
             </a:r>
@@ -10828,7 +10828,7 @@
                 <a:solidFill>
                   <a:srgbClr val="D4956B"/>
                 </a:solidFill>
-                <a:latin typeface="PingFang SC"/>
+                <a:latin typeface="'Noto Sans SC', 'PingFang SC', 'Microsoft YaHei', sans-serif"/>
               </a:rPr>
               <a:t>THANK YOU</a:t>
             </a:r>
@@ -10863,7 +10863,7 @@
                 <a:solidFill>
                   <a:srgbClr val="1A1815"/>
                 </a:solidFill>
-                <a:latin typeface="PingFang SC"/>
+                <a:latin typeface="'Noto Sans SC', 'PingFang SC', 'Microsoft YaHei', sans-serif"/>
               </a:rPr>
               <a:t>让我们一起，把 AI 装进每一个业务流程</a:t>
             </a:r>
@@ -10898,7 +10898,7 @@
                 <a:solidFill>
                   <a:srgbClr val="5C5548"/>
                 </a:solidFill>
-                <a:latin typeface="PingFang SC"/>
+                <a:latin typeface="'Noto Sans SC', 'PingFang SC', 'Microsoft YaHei', sans-serif"/>
               </a:rPr>
               <a:t>联系 sales@dify.ai 安排技术演示</a:t>
             </a:r>
@@ -10976,7 +10976,7 @@
                 <a:solidFill>
                   <a:srgbClr val="5C5548"/>
                 </a:solidFill>
-                <a:latin typeface="PingFang SC"/>
+                <a:latin typeface="'Noto Sans SC', 'PingFang SC', 'Microsoft YaHei', sans-serif"/>
               </a:rPr>
               <a:t>Dify · 2026</a:t>
             </a:r>
@@ -11011,7 +11011,7 @@
                 <a:solidFill>
                   <a:srgbClr val="9C9588"/>
                 </a:solidFill>
-                <a:latin typeface="PingFang SC"/>
+                <a:latin typeface="'Noto Sans SC', 'PingFang SC', 'Microsoft YaHei', sans-serif"/>
               </a:rPr>
               <a:t>Dify 企业介绍</a:t>
             </a:r>
@@ -11046,7 +11046,7 @@
                 <a:solidFill>
                   <a:srgbClr val="9C9588"/>
                 </a:solidFill>
-                <a:latin typeface="SF Mono"/>
+                <a:latin typeface="'IBM Plex Mono', 'SF Mono', 'JetBrains Mono', Menlo, monospace"/>
               </a:rPr>
               <a:t>08 / 08</a:t>
             </a:r>

</xml_diff>